<commit_message>
Fix section 2.3 slide visuals after render check
Restore the P2 capability stack so network facts sit at the base and external product behavior sits on top. Tighten the P1 constraint-to-route connector so the control-allocation step reads as a single flow.

Co-authored-by: newmanxiang <newmanxiang@users.noreply.github.com>
</commit_message>
<xml_diff>
--- a/reports/6g-data-fabric-section-23-deck.pptx
+++ b/reports/6g-data-fabric-section-23-deck.pptx
@@ -4336,14 +4336,100 @@
       </p:sp>
       <p:sp>
         <p:nvSpPr>
-          <p:cNvPr id="31" name="Rounded Rectangle 30"/>
+          <p:cNvPr id="31" name="Rectangle 30"/>
           <p:cNvSpPr/>
           <p:nvPr/>
         </p:nvSpPr>
         <p:spPr>
           <a:xfrm>
-            <a:off x="4279392" y="2788920"/>
-            <a:ext cx="1572768" cy="1417320"/>
+            <a:off x="4187952" y="1572768"/>
+            <a:ext cx="41148" cy="3493008"/>
+          </a:xfrm>
+          <a:prstGeom prst="rect">
+            <a:avLst/>
+          </a:prstGeom>
+          <a:solidFill>
+            <a:srgbClr val="0E7C7B"/>
+          </a:solidFill>
+          <a:ln>
+            <a:noFill/>
+          </a:ln>
+        </p:spPr>
+        <p:style>
+          <a:lnRef idx="1">
+            <a:schemeClr val="accent1"/>
+          </a:lnRef>
+          <a:fillRef idx="3">
+            <a:schemeClr val="accent1"/>
+          </a:fillRef>
+          <a:effectRef idx="2">
+            <a:schemeClr val="accent1"/>
+          </a:effectRef>
+          <a:fontRef idx="minor">
+            <a:schemeClr val="lt1"/>
+          </a:fontRef>
+        </p:style>
+        <p:txBody>
+          <a:bodyPr rtlCol="0" anchor="ctr"/>
+          <a:lstStyle/>
+          <a:p>
+            <a:pPr algn="ctr"/>
+          </a:p>
+        </p:txBody>
+      </p:sp>
+      <p:sp>
+        <p:nvSpPr>
+          <p:cNvPr id="32" name="Right Arrow 31"/>
+          <p:cNvSpPr/>
+          <p:nvPr/>
+        </p:nvSpPr>
+        <p:spPr>
+          <a:xfrm>
+            <a:off x="4187952" y="3273552"/>
+            <a:ext cx="219456" cy="201168"/>
+          </a:xfrm>
+          <a:prstGeom prst="rightArrow">
+            <a:avLst/>
+          </a:prstGeom>
+          <a:solidFill>
+            <a:srgbClr val="0E7C7B"/>
+          </a:solidFill>
+          <a:ln>
+            <a:noFill/>
+          </a:ln>
+        </p:spPr>
+        <p:style>
+          <a:lnRef idx="1">
+            <a:schemeClr val="accent1"/>
+          </a:lnRef>
+          <a:fillRef idx="3">
+            <a:schemeClr val="accent1"/>
+          </a:fillRef>
+          <a:effectRef idx="2">
+            <a:schemeClr val="accent1"/>
+          </a:effectRef>
+          <a:fontRef idx="minor">
+            <a:schemeClr val="lt1"/>
+          </a:fontRef>
+        </p:style>
+        <p:txBody>
+          <a:bodyPr rtlCol="0" anchor="ctr"/>
+          <a:lstStyle/>
+          <a:p>
+            <a:pPr algn="ctr"/>
+          </a:p>
+        </p:txBody>
+      </p:sp>
+      <p:sp>
+        <p:nvSpPr>
+          <p:cNvPr id="33" name="Rounded Rectangle 32"/>
+          <p:cNvSpPr/>
+          <p:nvPr/>
+        </p:nvSpPr>
+        <p:spPr>
+          <a:xfrm>
+            <a:off x="4443984" y="2816352"/>
+            <a:ext cx="1335024" cy="1298448"/>
           </a:xfrm>
           <a:prstGeom prst="roundRect">
             <a:avLst/>
@@ -4379,14 +4465,14 @@
       </p:sp>
       <p:sp>
         <p:nvSpPr>
-          <p:cNvPr id="32" name="TextBox 31"/>
+          <p:cNvPr id="34" name="TextBox 33"/>
           <p:cNvSpPr txBox="1"/>
           <p:nvPr/>
         </p:nvSpPr>
         <p:spPr>
           <a:xfrm>
-            <a:off x="4370832" y="2999232"/>
-            <a:ext cx="1389888" cy="1005840"/>
+            <a:off x="4498848" y="2999232"/>
+            <a:ext cx="1225296" cy="950976"/>
           </a:xfrm>
           <a:prstGeom prst="rect">
             <a:avLst/>
@@ -4440,14 +4526,14 @@
       </p:sp>
       <p:sp>
         <p:nvSpPr>
-          <p:cNvPr id="33" name="Right Arrow 32"/>
+          <p:cNvPr id="35" name="Right Arrow 34"/>
           <p:cNvSpPr/>
           <p:nvPr/>
         </p:nvSpPr>
         <p:spPr>
           <a:xfrm>
-            <a:off x="4279392" y="2331720"/>
-            <a:ext cx="1572768" cy="256032"/>
+            <a:off x="5815584" y="3273552"/>
+            <a:ext cx="182880" cy="201168"/>
           </a:xfrm>
           <a:prstGeom prst="rightArrow">
             <a:avLst/>
@@ -4483,50 +4569,7 @@
       </p:sp>
       <p:sp>
         <p:nvSpPr>
-          <p:cNvPr id="34" name="Right Arrow 33"/>
-          <p:cNvSpPr/>
-          <p:nvPr/>
-        </p:nvSpPr>
-        <p:spPr>
-          <a:xfrm>
-            <a:off x="4279392" y="4370832"/>
-            <a:ext cx="1572768" cy="256032"/>
-          </a:xfrm>
-          <a:prstGeom prst="rightArrow">
-            <a:avLst/>
-          </a:prstGeom>
-          <a:solidFill>
-            <a:srgbClr val="0E7C7B"/>
-          </a:solidFill>
-          <a:ln>
-            <a:noFill/>
-          </a:ln>
-        </p:spPr>
-        <p:style>
-          <a:lnRef idx="1">
-            <a:schemeClr val="accent1"/>
-          </a:lnRef>
-          <a:fillRef idx="3">
-            <a:schemeClr val="accent1"/>
-          </a:fillRef>
-          <a:effectRef idx="2">
-            <a:schemeClr val="accent1"/>
-          </a:effectRef>
-          <a:fontRef idx="minor">
-            <a:schemeClr val="lt1"/>
-          </a:fontRef>
-        </p:style>
-        <p:txBody>
-          <a:bodyPr rtlCol="0" anchor="ctr"/>
-          <a:lstStyle/>
-          <a:p>
-            <a:pPr algn="ctr"/>
-          </a:p>
-        </p:txBody>
-      </p:sp>
-      <p:sp>
-        <p:nvSpPr>
-          <p:cNvPr id="35" name="Rounded Rectangle 34"/>
+          <p:cNvPr id="36" name="Rounded Rectangle 35"/>
           <p:cNvSpPr/>
           <p:nvPr/>
         </p:nvSpPr>
@@ -4571,7 +4614,7 @@
       </p:sp>
       <p:sp>
         <p:nvSpPr>
-          <p:cNvPr id="36" name="Rectangle 35"/>
+          <p:cNvPr id="37" name="Rectangle 36"/>
           <p:cNvSpPr/>
           <p:nvPr/>
         </p:nvSpPr>
@@ -4614,7 +4657,7 @@
       </p:sp>
       <p:sp>
         <p:nvSpPr>
-          <p:cNvPr id="37" name="TextBox 36"/>
+          <p:cNvPr id="38" name="TextBox 37"/>
           <p:cNvSpPr txBox="1"/>
           <p:nvPr/>
         </p:nvSpPr>
@@ -4655,7 +4698,7 @@
       </p:sp>
       <p:sp>
         <p:nvSpPr>
-          <p:cNvPr id="38" name="TextBox 37"/>
+          <p:cNvPr id="39" name="TextBox 38"/>
           <p:cNvSpPr txBox="1"/>
           <p:nvPr/>
         </p:nvSpPr>
@@ -4696,7 +4739,7 @@
       </p:sp>
       <p:sp>
         <p:nvSpPr>
-          <p:cNvPr id="39" name="TextBox 38"/>
+          <p:cNvPr id="40" name="TextBox 39"/>
           <p:cNvSpPr txBox="1"/>
           <p:nvPr/>
         </p:nvSpPr>
@@ -4737,7 +4780,7 @@
       </p:sp>
       <p:sp>
         <p:nvSpPr>
-          <p:cNvPr id="40" name="Rounded Rectangle 39"/>
+          <p:cNvPr id="41" name="Rounded Rectangle 40"/>
           <p:cNvSpPr/>
           <p:nvPr/>
         </p:nvSpPr>
@@ -4782,7 +4825,7 @@
       </p:sp>
       <p:sp>
         <p:nvSpPr>
-          <p:cNvPr id="41" name="Rectangle 40"/>
+          <p:cNvPr id="42" name="Rectangle 41"/>
           <p:cNvSpPr/>
           <p:nvPr/>
         </p:nvSpPr>
@@ -4825,7 +4868,7 @@
       </p:sp>
       <p:sp>
         <p:nvSpPr>
-          <p:cNvPr id="42" name="TextBox 41"/>
+          <p:cNvPr id="43" name="TextBox 42"/>
           <p:cNvSpPr txBox="1"/>
           <p:nvPr/>
         </p:nvSpPr>
@@ -4866,7 +4909,7 @@
       </p:sp>
       <p:sp>
         <p:nvSpPr>
-          <p:cNvPr id="43" name="TextBox 42"/>
+          <p:cNvPr id="44" name="TextBox 43"/>
           <p:cNvSpPr txBox="1"/>
           <p:nvPr/>
         </p:nvSpPr>
@@ -4907,7 +4950,7 @@
       </p:sp>
       <p:sp>
         <p:nvSpPr>
-          <p:cNvPr id="44" name="TextBox 43"/>
+          <p:cNvPr id="45" name="TextBox 44"/>
           <p:cNvSpPr txBox="1"/>
           <p:nvPr/>
         </p:nvSpPr>
@@ -4948,7 +4991,7 @@
       </p:sp>
       <p:sp>
         <p:nvSpPr>
-          <p:cNvPr id="45" name="Rounded Rectangle 44"/>
+          <p:cNvPr id="46" name="Rounded Rectangle 45"/>
           <p:cNvSpPr/>
           <p:nvPr/>
         </p:nvSpPr>
@@ -4993,7 +5036,7 @@
       </p:sp>
       <p:sp>
         <p:nvSpPr>
-          <p:cNvPr id="46" name="Rectangle 45"/>
+          <p:cNvPr id="47" name="Rectangle 46"/>
           <p:cNvSpPr/>
           <p:nvPr/>
         </p:nvSpPr>
@@ -5036,7 +5079,7 @@
       </p:sp>
       <p:sp>
         <p:nvSpPr>
-          <p:cNvPr id="47" name="TextBox 46"/>
+          <p:cNvPr id="48" name="TextBox 47"/>
           <p:cNvSpPr txBox="1"/>
           <p:nvPr/>
         </p:nvSpPr>
@@ -5077,7 +5120,7 @@
       </p:sp>
       <p:sp>
         <p:nvSpPr>
-          <p:cNvPr id="48" name="TextBox 47"/>
+          <p:cNvPr id="49" name="TextBox 48"/>
           <p:cNvSpPr txBox="1"/>
           <p:nvPr/>
         </p:nvSpPr>
@@ -5118,7 +5161,7 @@
       </p:sp>
       <p:sp>
         <p:nvSpPr>
-          <p:cNvPr id="49" name="TextBox 48"/>
+          <p:cNvPr id="50" name="TextBox 49"/>
           <p:cNvSpPr txBox="1"/>
           <p:nvPr/>
         </p:nvSpPr>
@@ -5159,7 +5202,7 @@
       </p:sp>
       <p:sp>
         <p:nvSpPr>
-          <p:cNvPr id="50" name="Rounded Rectangle 49"/>
+          <p:cNvPr id="51" name="Rounded Rectangle 50"/>
           <p:cNvSpPr/>
           <p:nvPr/>
         </p:nvSpPr>
@@ -5204,7 +5247,7 @@
       </p:sp>
       <p:sp>
         <p:nvSpPr>
-          <p:cNvPr id="51" name="TextBox 50"/>
+          <p:cNvPr id="52" name="TextBox 51"/>
           <p:cNvSpPr txBox="1"/>
           <p:nvPr/>
         </p:nvSpPr>
@@ -5245,7 +5288,7 @@
       </p:sp>
       <p:sp>
         <p:nvSpPr>
-          <p:cNvPr id="52" name="Rounded Rectangle 51"/>
+          <p:cNvPr id="53" name="Rounded Rectangle 52"/>
           <p:cNvSpPr/>
           <p:nvPr/>
         </p:nvSpPr>
@@ -5288,7 +5331,7 @@
       </p:sp>
       <p:sp>
         <p:nvSpPr>
-          <p:cNvPr id="53" name="TextBox 52"/>
+          <p:cNvPr id="54" name="TextBox 53"/>
           <p:cNvSpPr txBox="1"/>
           <p:nvPr/>
         </p:nvSpPr>
@@ -5329,7 +5372,7 @@
       </p:sp>
       <p:sp>
         <p:nvSpPr>
-          <p:cNvPr id="54" name="Rounded Rectangle 53"/>
+          <p:cNvPr id="55" name="Rounded Rectangle 54"/>
           <p:cNvSpPr/>
           <p:nvPr/>
         </p:nvSpPr>
@@ -5372,7 +5415,7 @@
       </p:sp>
       <p:sp>
         <p:nvSpPr>
-          <p:cNvPr id="55" name="TextBox 54"/>
+          <p:cNvPr id="56" name="TextBox 55"/>
           <p:cNvSpPr txBox="1"/>
           <p:nvPr/>
         </p:nvSpPr>
@@ -5413,7 +5456,7 @@
       </p:sp>
       <p:sp>
         <p:nvSpPr>
-          <p:cNvPr id="56" name="Rounded Rectangle 55"/>
+          <p:cNvPr id="57" name="Rounded Rectangle 56"/>
           <p:cNvSpPr/>
           <p:nvPr/>
         </p:nvSpPr>
@@ -5456,7 +5499,7 @@
       </p:sp>
       <p:sp>
         <p:nvSpPr>
-          <p:cNvPr id="57" name="TextBox 56"/>
+          <p:cNvPr id="58" name="TextBox 57"/>
           <p:cNvSpPr txBox="1"/>
           <p:nvPr/>
         </p:nvSpPr>
@@ -5497,7 +5540,7 @@
       </p:sp>
       <p:sp>
         <p:nvSpPr>
-          <p:cNvPr id="58" name="Rounded Rectangle 57"/>
+          <p:cNvPr id="59" name="Rounded Rectangle 58"/>
           <p:cNvSpPr/>
           <p:nvPr/>
         </p:nvSpPr>
@@ -5540,7 +5583,7 @@
       </p:sp>
       <p:sp>
         <p:nvSpPr>
-          <p:cNvPr id="59" name="TextBox 58"/>
+          <p:cNvPr id="60" name="TextBox 59"/>
           <p:cNvSpPr txBox="1"/>
           <p:nvPr/>
         </p:nvSpPr>
@@ -5581,7 +5624,7 @@
       </p:sp>
       <p:sp>
         <p:nvSpPr>
-          <p:cNvPr id="60" name="Rectangle 59"/>
+          <p:cNvPr id="61" name="Rectangle 60"/>
           <p:cNvSpPr/>
           <p:nvPr/>
         </p:nvSpPr>
@@ -5624,7 +5667,7 @@
       </p:sp>
       <p:sp>
         <p:nvSpPr>
-          <p:cNvPr id="61" name="TextBox 60"/>
+          <p:cNvPr id="62" name="TextBox 61"/>
           <p:cNvSpPr txBox="1"/>
           <p:nvPr/>
         </p:nvSpPr>
@@ -5665,7 +5708,7 @@
       </p:sp>
       <p:sp>
         <p:nvSpPr>
-          <p:cNvPr id="62" name="TextBox 61"/>
+          <p:cNvPr id="63" name="TextBox 62"/>
           <p:cNvSpPr txBox="1"/>
           <p:nvPr/>
         </p:nvSpPr>
@@ -5963,7 +6006,7 @@
         </p:nvSpPr>
         <p:spPr>
           <a:xfrm>
-            <a:off x="347472" y="4462272"/>
+            <a:off x="347472" y="1353312"/>
             <a:ext cx="6583680" cy="1389888"/>
           </a:xfrm>
           <a:prstGeom prst="roundRect">
@@ -6006,7 +6049,7 @@
         </p:nvSpPr>
         <p:spPr>
           <a:xfrm>
-            <a:off x="512064" y="4535424"/>
+            <a:off x="512064" y="1426464"/>
             <a:ext cx="6254496" cy="182880"/>
           </a:xfrm>
           <a:prstGeom prst="rect">
@@ -6047,7 +6090,7 @@
         </p:nvSpPr>
         <p:spPr>
           <a:xfrm>
-            <a:off x="512064" y="4718304"/>
+            <a:off x="512064" y="1609344"/>
             <a:ext cx="6254496" cy="256032"/>
           </a:xfrm>
           <a:prstGeom prst="rect">
@@ -6088,7 +6131,7 @@
         </p:nvSpPr>
         <p:spPr>
           <a:xfrm>
-            <a:off x="512064" y="4992624"/>
+            <a:off x="512064" y="1883664"/>
             <a:ext cx="6254496" cy="768096"/>
           </a:xfrm>
           <a:prstGeom prst="rect">
@@ -6295,7 +6338,7 @@
         </p:nvSpPr>
         <p:spPr>
           <a:xfrm>
-            <a:off x="347472" y="1353312"/>
+            <a:off x="347472" y="4462272"/>
             <a:ext cx="6583680" cy="1389888"/>
           </a:xfrm>
           <a:prstGeom prst="roundRect">
@@ -6338,7 +6381,7 @@
         </p:nvSpPr>
         <p:spPr>
           <a:xfrm>
-            <a:off x="512064" y="1426464"/>
+            <a:off x="512064" y="4535424"/>
             <a:ext cx="6254496" cy="182880"/>
           </a:xfrm>
           <a:prstGeom prst="rect">
@@ -6379,7 +6422,7 @@
         </p:nvSpPr>
         <p:spPr>
           <a:xfrm>
-            <a:off x="512064" y="1609344"/>
+            <a:off x="512064" y="4718304"/>
             <a:ext cx="6254496" cy="256032"/>
           </a:xfrm>
           <a:prstGeom prst="rect">
@@ -6420,7 +6463,7 @@
         </p:nvSpPr>
         <p:spPr>
           <a:xfrm>
-            <a:off x="512064" y="1883664"/>
+            <a:off x="512064" y="4992624"/>
             <a:ext cx="6254496" cy="768096"/>
           </a:xfrm>
           <a:prstGeom prst="rect">

</xml_diff>

<commit_message>
Double the body copy on the 2.3 six-slide deck
Keep the six-page architecture-route structure, but expand theses, analysis cards, evidence bars, and the synthesis table so each page carries about twice the Chinese text without adding extra tables or shrinking type below 7.5pt.

Co-authored-by: newmanxiang <newmanxiang@users.noreply.github.com>
</commit_message>
<xml_diff>
--- a/reports/6g-data-fabric-section-23-deck.pptx
+++ b/reports/6g-data-fabric-section-23-deck.pptx
@@ -3270,7 +3270,7 @@
         <p:spPr>
           <a:xfrm>
             <a:off x="347472" y="640080"/>
-            <a:ext cx="11475720" cy="420624"/>
+            <a:ext cx="11475720" cy="493776"/>
           </a:xfrm>
           <a:prstGeom prst="roundRect">
             <a:avLst/>
@@ -3304,10 +3304,10 @@
           <a:p>
             <a:pPr algn="l">
               <a:lnSpc>
-                <a:spcPct val="105000"/>
+                <a:spcPct val="104000"/>
               </a:lnSpc>
               <a:spcBef>
-                <a:spcPts val="300"/>
+                <a:spcPts val="200"/>
               </a:spcBef>
               <a:spcAft>
                 <a:spcPts val="100"/>
@@ -3321,7 +3321,7 @@
                 <a:latin typeface="WenQuanYi Micro Hei"/>
                 <a:ea typeface="WenQuanYi Micro Hei"/>
               </a:rPr>
-              <a:t>三条路线是不同起点，不是“谁更接近Fabric”的排名；它们分别优先解决低风险演进、近源执行与产品化速度。</a:t>
+              <a:t>三条路线来自同一组架构矛盾，不是对Fabric理解不同，更不是成熟度阶梯。Ericsson优先低风险演进，Huawei优先近源执行，Nokia优先产品化速度；真正要比较的是控制权放在哪里、以什么代价换什么优势。</a:t>
             </a:r>
           </a:p>
         </p:txBody>
@@ -3334,8 +3334,8 @@
         </p:nvSpPr>
         <p:spPr>
           <a:xfrm>
-            <a:off x="347472" y="1170432"/>
-            <a:ext cx="3794760" cy="950976"/>
+            <a:off x="347472" y="1207008"/>
+            <a:ext cx="3794760" cy="914400"/>
           </a:xfrm>
           <a:prstGeom prst="roundRect">
             <a:avLst/>
@@ -3463,8 +3463,8 @@
         </p:nvSpPr>
         <p:spPr>
           <a:xfrm>
-            <a:off x="768096" y="1243584"/>
-            <a:ext cx="3246120" cy="164592"/>
+            <a:off x="768096" y="1252728"/>
+            <a:ext cx="3246120" cy="146304"/>
           </a:xfrm>
           <a:prstGeom prst="rect">
             <a:avLst/>
@@ -3504,8 +3504,8 @@
         </p:nvSpPr>
         <p:spPr>
           <a:xfrm>
-            <a:off x="768096" y="1408176"/>
-            <a:ext cx="3246120" cy="219456"/>
+            <a:off x="768096" y="1399032"/>
+            <a:ext cx="3246120" cy="182880"/>
           </a:xfrm>
           <a:prstGeom prst="rect">
             <a:avLst/>
@@ -3525,7 +3525,7 @@
               </a:spcAft>
             </a:pPr>
             <a:r>
-              <a:rPr sz="1300" b="1">
+              <a:rPr sz="1200" b="1">
                 <a:solidFill>
                   <a:srgbClr val="0B1F3A"/>
                 </a:solidFill>
@@ -3545,8 +3545,8 @@
         </p:nvSpPr>
         <p:spPr>
           <a:xfrm>
-            <a:off x="457200" y="1664208"/>
-            <a:ext cx="3538728" cy="402336"/>
+            <a:off x="457200" y="1591056"/>
+            <a:ext cx="3538728" cy="493776"/>
           </a:xfrm>
           <a:prstGeom prst="rect">
             <a:avLst/>
@@ -3559,21 +3559,21 @@
           <a:p>
             <a:pPr algn="l">
               <a:lnSpc>
-                <a:spcPct val="104000"/>
-              </a:lnSpc>
-              <a:spcAft>
-                <a:spcPts val="100"/>
-              </a:spcAft>
-            </a:pPr>
-            <a:r>
-              <a:rPr sz="1000" b="0">
+                <a:spcPct val="102000"/>
+              </a:lnSpc>
+              <a:spcAft>
+                <a:spcPts val="100"/>
+              </a:spcAft>
+            </a:pPr>
+            <a:r>
+              <a:rPr sz="950" b="0">
                 <a:solidFill>
                   <a:srgbClr val="2C3E50"/>
                 </a:solidFill>
                 <a:latin typeface="WenQuanYi Micro Hei"/>
                 <a:ea typeface="WenQuanYi Micro Hei"/>
               </a:rPr>
-              <a:t>无线状态、移动性和断链生存，要求毫秒执行留在网元、边缘或域控制器。</a:t>
+              <a:t>无线状态、移动性和断链生存，要求毫秒执行留在网元、边缘或域控制器。把快环事实外移到远端平台，会同时失去时延和故障域。</a:t>
             </a:r>
           </a:p>
         </p:txBody>
@@ -3587,7 +3587,7 @@
         <p:spPr>
           <a:xfrm>
             <a:off x="347472" y="2194560"/>
-            <a:ext cx="3794760" cy="950976"/>
+            <a:ext cx="3794760" cy="914400"/>
           </a:xfrm>
           <a:prstGeom prst="roundRect">
             <a:avLst/>
@@ -3631,7 +3631,7 @@
         </p:nvSpPr>
         <p:spPr>
           <a:xfrm>
-            <a:off x="457200" y="2304288"/>
+            <a:off x="457200" y="2267712"/>
             <a:ext cx="237744" cy="237744"/>
           </a:xfrm>
           <a:prstGeom prst="ellipse">
@@ -3674,7 +3674,7 @@
         </p:nvSpPr>
         <p:spPr>
           <a:xfrm>
-            <a:off x="457200" y="2313432"/>
+            <a:off x="457200" y="2276856"/>
             <a:ext cx="237744" cy="219456"/>
           </a:xfrm>
           <a:prstGeom prst="rect">
@@ -3715,8 +3715,8 @@
         </p:nvSpPr>
         <p:spPr>
           <a:xfrm>
-            <a:off x="768096" y="2267712"/>
-            <a:ext cx="3246120" cy="164592"/>
+            <a:off x="768096" y="2240280"/>
+            <a:ext cx="3246120" cy="146304"/>
           </a:xfrm>
           <a:prstGeom prst="rect">
             <a:avLst/>
@@ -3756,8 +3756,8 @@
         </p:nvSpPr>
         <p:spPr>
           <a:xfrm>
-            <a:off x="768096" y="2432304"/>
-            <a:ext cx="3246120" cy="219456"/>
+            <a:off x="768096" y="2386584"/>
+            <a:ext cx="3246120" cy="182880"/>
           </a:xfrm>
           <a:prstGeom prst="rect">
             <a:avLst/>
@@ -3777,7 +3777,7 @@
               </a:spcAft>
             </a:pPr>
             <a:r>
-              <a:rPr sz="1300" b="1">
+              <a:rPr sz="1200" b="1">
                 <a:solidFill>
                   <a:srgbClr val="0B1F3A"/>
                 </a:solidFill>
@@ -3797,8 +3797,8 @@
         </p:nvSpPr>
         <p:spPr>
           <a:xfrm>
-            <a:off x="457200" y="2688336"/>
-            <a:ext cx="3538728" cy="402336"/>
+            <a:off x="457200" y="2578608"/>
+            <a:ext cx="3538728" cy="493776"/>
           </a:xfrm>
           <a:prstGeom prst="rect">
             <a:avLst/>
@@ -3811,21 +3811,21 @@
           <a:p>
             <a:pPr algn="l">
               <a:lnSpc>
-                <a:spcPct val="104000"/>
-              </a:lnSpc>
-              <a:spcAft>
-                <a:spcPts val="100"/>
-              </a:spcAft>
-            </a:pPr>
-            <a:r>
-              <a:rPr sz="1000" b="0">
+                <a:spcPct val="102000"/>
+              </a:lnSpc>
+              <a:spcAft>
+                <a:spcPts val="100"/>
+              </a:spcAft>
+            </a:pPr>
+            <a:r>
+              <a:rPr sz="950" b="0">
                 <a:solidFill>
                   <a:srgbClr val="2C3E50"/>
                 </a:solidFill>
                 <a:latin typeface="WenQuanYi Micro Hei"/>
                 <a:ea typeface="WenQuanYi Micro Hei"/>
               </a:rPr>
-              <a:t>模型与产品跨RAN、Core、OSS/BSS复用，需要稳定对象、上下文、QoD和版本。</a:t>
+              <a:t>模型与产品要跨RAN、Core、OSS/BSS复用，必须有稳定对象、上下文、QoD和版本。名称相似不等于跨域语义已经对齐。</a:t>
             </a:r>
           </a:p>
         </p:txBody>
@@ -3838,8 +3838,8 @@
         </p:nvSpPr>
         <p:spPr>
           <a:xfrm>
-            <a:off x="347472" y="3218688"/>
-            <a:ext cx="3794760" cy="950976"/>
+            <a:off x="347472" y="3182112"/>
+            <a:ext cx="3794760" cy="914400"/>
           </a:xfrm>
           <a:prstGeom prst="roundRect">
             <a:avLst/>
@@ -3883,7 +3883,7 @@
         </p:nvSpPr>
         <p:spPr>
           <a:xfrm>
-            <a:off x="457200" y="3328416"/>
+            <a:off x="457200" y="3255264"/>
             <a:ext cx="237744" cy="237744"/>
           </a:xfrm>
           <a:prstGeom prst="ellipse">
@@ -3926,7 +3926,7 @@
         </p:nvSpPr>
         <p:spPr>
           <a:xfrm>
-            <a:off x="457200" y="3337560"/>
+            <a:off x="457200" y="3264408"/>
             <a:ext cx="237744" cy="219456"/>
           </a:xfrm>
           <a:prstGeom prst="rect">
@@ -3967,8 +3967,8 @@
         </p:nvSpPr>
         <p:spPr>
           <a:xfrm>
-            <a:off x="768096" y="3291840"/>
-            <a:ext cx="3246120" cy="164592"/>
+            <a:off x="768096" y="3227832"/>
+            <a:ext cx="3246120" cy="146304"/>
           </a:xfrm>
           <a:prstGeom prst="rect">
             <a:avLst/>
@@ -4008,8 +4008,8 @@
         </p:nvSpPr>
         <p:spPr>
           <a:xfrm>
-            <a:off x="768096" y="3456432"/>
-            <a:ext cx="3246120" cy="219456"/>
+            <a:off x="768096" y="3374136"/>
+            <a:ext cx="3246120" cy="182880"/>
           </a:xfrm>
           <a:prstGeom prst="rect">
             <a:avLst/>
@@ -4029,7 +4029,7 @@
               </a:spcAft>
             </a:pPr>
             <a:r>
-              <a:rPr sz="1300" b="1">
+              <a:rPr sz="1200" b="1">
                 <a:solidFill>
                   <a:srgbClr val="0B1F3A"/>
                 </a:solidFill>
@@ -4049,8 +4049,8 @@
         </p:nvSpPr>
         <p:spPr>
           <a:xfrm>
-            <a:off x="457200" y="3712464"/>
-            <a:ext cx="3538728" cy="402336"/>
+            <a:off x="457200" y="3566160"/>
+            <a:ext cx="3538728" cy="493776"/>
           </a:xfrm>
           <a:prstGeom prst="rect">
             <a:avLst/>
@@ -4063,21 +4063,21 @@
           <a:p>
             <a:pPr algn="l">
               <a:lnSpc>
-                <a:spcPct val="104000"/>
-              </a:lnSpc>
-              <a:spcAft>
-                <a:spcPts val="100"/>
-              </a:spcAft>
-            </a:pPr>
-            <a:r>
-              <a:rPr sz="1000" b="0">
+                <a:spcPct val="102000"/>
+              </a:lnSpc>
+              <a:spcAft>
+                <a:spcPts val="100"/>
+              </a:spcAft>
+            </a:pPr>
+            <a:r>
+              <a:rPr sz="950" b="0">
                 <a:solidFill>
                   <a:srgbClr val="2C3E50"/>
                 </a:solidFill>
                 <a:latin typeface="WenQuanYi Micro Hei"/>
                 <a:ea typeface="WenQuanYi Micro Hei"/>
               </a:rPr>
-              <a:t>感知、训练和遥测规模推动过滤、特征化与推理向源侧下沉，而不是默认集中。</a:t>
+              <a:t>感知、训练和遥测规模不允许默认把全量数据搬到中心。过滤、特征化与推理应先在源侧完成，再按用途交付。</a:t>
             </a:r>
           </a:p>
         </p:txBody>
@@ -4090,8 +4090,8 @@
         </p:nvSpPr>
         <p:spPr>
           <a:xfrm>
-            <a:off x="347472" y="4242816"/>
-            <a:ext cx="3794760" cy="950976"/>
+            <a:off x="347472" y="4169664"/>
+            <a:ext cx="3794760" cy="914400"/>
           </a:xfrm>
           <a:prstGeom prst="roundRect">
             <a:avLst/>
@@ -4135,7 +4135,7 @@
         </p:nvSpPr>
         <p:spPr>
           <a:xfrm>
-            <a:off x="457200" y="4352544"/>
+            <a:off x="457200" y="4242816"/>
             <a:ext cx="237744" cy="237744"/>
           </a:xfrm>
           <a:prstGeom prst="ellipse">
@@ -4178,7 +4178,7 @@
         </p:nvSpPr>
         <p:spPr>
           <a:xfrm>
-            <a:off x="457200" y="4361688"/>
+            <a:off x="457200" y="4251960"/>
             <a:ext cx="237744" cy="219456"/>
           </a:xfrm>
           <a:prstGeom prst="rect">
@@ -4219,8 +4219,8 @@
         </p:nvSpPr>
         <p:spPr>
           <a:xfrm>
-            <a:off x="768096" y="4315968"/>
-            <a:ext cx="3246120" cy="164592"/>
+            <a:off x="768096" y="4215384"/>
+            <a:ext cx="3246120" cy="146304"/>
           </a:xfrm>
           <a:prstGeom prst="rect">
             <a:avLst/>
@@ -4260,8 +4260,8 @@
         </p:nvSpPr>
         <p:spPr>
           <a:xfrm>
-            <a:off x="768096" y="4480560"/>
-            <a:ext cx="3246120" cy="219456"/>
+            <a:off x="768096" y="4361688"/>
+            <a:ext cx="3246120" cy="182880"/>
           </a:xfrm>
           <a:prstGeom prst="rect">
             <a:avLst/>
@@ -4281,7 +4281,7 @@
               </a:spcAft>
             </a:pPr>
             <a:r>
-              <a:rPr sz="1300" b="1">
+              <a:rPr sz="1200" b="1">
                 <a:solidFill>
                   <a:srgbClr val="0B1F3A"/>
                 </a:solidFill>
@@ -4301,8 +4301,8 @@
         </p:nvSpPr>
         <p:spPr>
           <a:xfrm>
-            <a:off x="457200" y="4736592"/>
-            <a:ext cx="3538728" cy="402336"/>
+            <a:off x="457200" y="4553712"/>
+            <a:ext cx="3538728" cy="493776"/>
           </a:xfrm>
           <a:prstGeom prst="rect">
             <a:avLst/>
@@ -4315,21 +4315,21 @@
           <a:p>
             <a:pPr algn="l">
               <a:lnSpc>
-                <a:spcPct val="104000"/>
-              </a:lnSpc>
-              <a:spcAft>
-                <a:spcPts val="100"/>
-              </a:spcAft>
-            </a:pPr>
-            <a:r>
-              <a:rPr sz="1000" b="0">
+                <a:spcPct val="102000"/>
+              </a:lnSpc>
+              <a:spcAft>
+                <a:spcPts val="100"/>
+              </a:spcAft>
+            </a:pPr>
+            <a:r>
+              <a:rPr sz="950" b="0">
                 <a:solidFill>
                   <a:srgbClr val="2C3E50"/>
                 </a:solidFill>
                 <a:latin typeface="WenQuanYi Micro Hei"/>
                 <a:ea typeface="WenQuanYi Micro Hei"/>
               </a:rPr>
-              <a:t>Agent输出会改变真实网络，数据、模型、策略、动作与结果必须形成证据链。</a:t>
+              <a:t>Agent输出会改变真实网络。数据、模型、策略、动作、结果和回滚必须连成可解释、可追责的证据链，否则自治权限扩不出去。</a:t>
             </a:r>
           </a:p>
         </p:txBody>
@@ -4343,7 +4343,7 @@
         <p:spPr>
           <a:xfrm>
             <a:off x="4187952" y="1572768"/>
-            <a:ext cx="41148" cy="3493008"/>
+            <a:ext cx="41148" cy="3383280"/>
           </a:xfrm>
           <a:prstGeom prst="rect">
             <a:avLst/>
@@ -4428,8 +4428,8 @@
         </p:nvSpPr>
         <p:spPr>
           <a:xfrm>
-            <a:off x="4443984" y="2816352"/>
-            <a:ext cx="1335024" cy="1298448"/>
+            <a:off x="4443984" y="2743200"/>
+            <a:ext cx="1335024" cy="1353312"/>
           </a:xfrm>
           <a:prstGeom prst="roundRect">
             <a:avLst/>
@@ -4471,8 +4471,8 @@
         </p:nvSpPr>
         <p:spPr>
           <a:xfrm>
-            <a:off x="4498848" y="2999232"/>
-            <a:ext cx="1225296" cy="950976"/>
+            <a:off x="4498848" y="2852928"/>
+            <a:ext cx="1225296" cy="1133856"/>
           </a:xfrm>
           <a:prstGeom prst="rect">
             <a:avLst/>
@@ -4485,14 +4485,14 @@
           <a:p>
             <a:pPr algn="ctr">
               <a:lnSpc>
-                <a:spcPct val="115000"/>
-              </a:lnSpc>
-              <a:spcAft>
-                <a:spcPts val="100"/>
-              </a:spcAft>
-            </a:pPr>
-            <a:r>
-              <a:rPr sz="1300" b="1">
+                <a:spcPct val="112000"/>
+              </a:lnSpc>
+              <a:spcAft>
+                <a:spcPts val="100"/>
+              </a:spcAft>
+            </a:pPr>
+            <a:r>
+              <a:rPr sz="1200" b="1">
                 <a:solidFill>
                   <a:srgbClr val="FFFFFF"/>
                 </a:solidFill>
@@ -4505,14 +4505,14 @@
           <a:p>
             <a:pPr algn="ctr">
               <a:lnSpc>
-                <a:spcPct val="115000"/>
-              </a:lnSpc>
-              <a:spcAft>
-                <a:spcPts val="100"/>
-              </a:spcAft>
-            </a:pPr>
-            <a:r>
-              <a:rPr sz="1300" b="1">
+                <a:spcPct val="112000"/>
+              </a:lnSpc>
+              <a:spcAft>
+                <a:spcPts val="100"/>
+              </a:spcAft>
+            </a:pPr>
+            <a:r>
+              <a:rPr sz="1200" b="1">
                 <a:solidFill>
                   <a:srgbClr val="FFFFFF"/>
                 </a:solidFill>
@@ -4520,6 +4520,26 @@
                 <a:ea typeface="WenQuanYi Micro Hei"/>
               </a:rPr>
               <a:t>如何分配</a:t>
+            </a:r>
+          </a:p>
+          <a:p>
+            <a:pPr algn="ctr">
+              <a:lnSpc>
+                <a:spcPct val="112000"/>
+              </a:lnSpc>
+              <a:spcAft>
+                <a:spcPts val="100"/>
+              </a:spcAft>
+            </a:pPr>
+            <a:r>
+              <a:rPr sz="1200" b="1">
+                <a:solidFill>
+                  <a:srgbClr val="FFFFFF"/>
+                </a:solidFill>
+                <a:latin typeface="WenQuanYi Micro Hei"/>
+                <a:ea typeface="WenQuanYi Micro Hei"/>
+              </a:rPr>
+              <a:t>决定路线</a:t>
             </a:r>
           </a:p>
         </p:txBody>
@@ -4575,8 +4595,8 @@
         </p:nvSpPr>
         <p:spPr>
           <a:xfrm>
-            <a:off x="6016752" y="1170432"/>
-            <a:ext cx="5806440" cy="1280160"/>
+            <a:off x="6016752" y="1207008"/>
+            <a:ext cx="5806440" cy="1243584"/>
           </a:xfrm>
           <a:prstGeom prst="roundRect">
             <a:avLst/>
@@ -4620,8 +4640,8 @@
         </p:nvSpPr>
         <p:spPr>
           <a:xfrm>
-            <a:off x="6016752" y="1170432"/>
-            <a:ext cx="73152" cy="1280160"/>
+            <a:off x="6016752" y="1207008"/>
+            <a:ext cx="73152" cy="1243584"/>
           </a:xfrm>
           <a:prstGeom prst="rect">
             <a:avLst/>
@@ -4663,8 +4683,8 @@
         </p:nvSpPr>
         <p:spPr>
           <a:xfrm>
-            <a:off x="6236208" y="1243584"/>
-            <a:ext cx="5440680" cy="182880"/>
+            <a:off x="6236208" y="1261872"/>
+            <a:ext cx="5440680" cy="164592"/>
           </a:xfrm>
           <a:prstGeom prst="rect">
             <a:avLst/>
@@ -4705,7 +4725,7 @@
         <p:spPr>
           <a:xfrm>
             <a:off x="6236208" y="1426464"/>
-            <a:ext cx="5440680" cy="237744"/>
+            <a:ext cx="5440680" cy="201168"/>
           </a:xfrm>
           <a:prstGeom prst="rect">
             <a:avLst/>
@@ -4725,7 +4745,7 @@
               </a:spcAft>
             </a:pPr>
             <a:r>
-              <a:rPr sz="1400" b="1">
+              <a:rPr sz="1300" b="1">
                 <a:solidFill>
                   <a:srgbClr val="0B1F3A"/>
                 </a:solidFill>
@@ -4745,8 +4765,8 @@
         </p:nvSpPr>
         <p:spPr>
           <a:xfrm>
-            <a:off x="6236208" y="1700784"/>
-            <a:ext cx="5440680" cy="658368"/>
+            <a:off x="6236208" y="1645920"/>
+            <a:ext cx="5440680" cy="749808"/>
           </a:xfrm>
           <a:prstGeom prst="rect">
             <a:avLst/>
@@ -4759,21 +4779,21 @@
           <a:p>
             <a:pPr algn="l">
               <a:lnSpc>
-                <a:spcPct val="105000"/>
-              </a:lnSpc>
-              <a:spcAft>
-                <a:spcPts val="100"/>
-              </a:spcAft>
-            </a:pPr>
-            <a:r>
-              <a:rPr sz="1050" b="0">
+                <a:spcPct val="104000"/>
+              </a:lnSpc>
+              <a:spcAft>
+                <a:spcPts val="100"/>
+              </a:spcAft>
+            </a:pPr>
+            <a:r>
+              <a:rPr sz="1000" b="0">
                 <a:solidFill>
                   <a:srgbClr val="2C3E50"/>
                 </a:solidFill>
                 <a:latin typeface="WenQuanYi Micro Hei"/>
                 <a:ea typeface="WenQuanYi Micro Hei"/>
               </a:rPr>
-              <a:t>以复杂协调换迁移连续性。权威源与存量产品不可跳过，统一的是治理视图，不是全部运行时。</a:t>
+              <a:t>以复杂协调换迁移连续性。权威源与Mediation、NWDAF、湖仓不可跳过；统一的是发现、策略和消费体验，不是把全部运行时收进一个SKU。</a:t>
             </a:r>
           </a:p>
         </p:txBody>
@@ -4786,8 +4806,8 @@
         </p:nvSpPr>
         <p:spPr>
           <a:xfrm>
-            <a:off x="6016752" y="2542032"/>
-            <a:ext cx="5806440" cy="1280160"/>
+            <a:off x="6016752" y="2523744"/>
+            <a:ext cx="5806440" cy="1243584"/>
           </a:xfrm>
           <a:prstGeom prst="roundRect">
             <a:avLst/>
@@ -4831,8 +4851,8 @@
         </p:nvSpPr>
         <p:spPr>
           <a:xfrm>
-            <a:off x="6016752" y="2542032"/>
-            <a:ext cx="73152" cy="1280160"/>
+            <a:off x="6016752" y="2523744"/>
+            <a:ext cx="73152" cy="1243584"/>
           </a:xfrm>
           <a:prstGeom prst="rect">
             <a:avLst/>
@@ -4874,8 +4894,8 @@
         </p:nvSpPr>
         <p:spPr>
           <a:xfrm>
-            <a:off x="6236208" y="2615184"/>
-            <a:ext cx="5440680" cy="182880"/>
+            <a:off x="6236208" y="2578608"/>
+            <a:ext cx="5440680" cy="164592"/>
           </a:xfrm>
           <a:prstGeom prst="rect">
             <a:avLst/>
@@ -4915,8 +4935,8 @@
         </p:nvSpPr>
         <p:spPr>
           <a:xfrm>
-            <a:off x="6236208" y="2798064"/>
-            <a:ext cx="5440680" cy="237744"/>
+            <a:off x="6236208" y="2743200"/>
+            <a:ext cx="5440680" cy="201168"/>
           </a:xfrm>
           <a:prstGeom prst="rect">
             <a:avLst/>
@@ -4936,7 +4956,7 @@
               </a:spcAft>
             </a:pPr>
             <a:r>
-              <a:rPr sz="1400" b="1">
+              <a:rPr sz="1300" b="1">
                 <a:solidFill>
                   <a:srgbClr val="0B1F3A"/>
                 </a:solidFill>
@@ -4956,8 +4976,8 @@
         </p:nvSpPr>
         <p:spPr>
           <a:xfrm>
-            <a:off x="6236208" y="3072384"/>
-            <a:ext cx="5440680" cy="658368"/>
+            <a:off x="6236208" y="2962656"/>
+            <a:ext cx="5440680" cy="749808"/>
           </a:xfrm>
           <a:prstGeom prst="rect">
             <a:avLst/>
@@ -4970,21 +4990,21 @@
           <a:p>
             <a:pPr algn="l">
               <a:lnSpc>
-                <a:spcPct val="105000"/>
-              </a:lnSpc>
-              <a:spcAft>
-                <a:spcPts val="100"/>
-              </a:spcAft>
-            </a:pPr>
-            <a:r>
-              <a:rPr sz="1050" b="0">
+                <a:spcPct val="104000"/>
+              </a:lnSpc>
+              <a:spcAft>
+                <a:spcPts val="100"/>
+              </a:spcAft>
+            </a:pPr>
+            <a:r>
+              <a:rPr sz="1000" b="0">
                 <a:solidFill>
                   <a:srgbClr val="2C3E50"/>
                 </a:solidFill>
                 <a:latin typeface="WenQuanYi Micro Hei"/>
                 <a:ea typeface="WenQuanYi Micro Hei"/>
               </a:rPr>
-              <a:t>以新平面复杂度换近源控制。把多源、多处理、多汇做成可编排执行，而不是先建企业Catalog。</a:t>
+              <a:t>以新平面复杂度换近源控制。把多源、多处理、多汇做成可编排执行，而不是先建设企业Catalog；缺少通用目录不能直接判为路线不完整。</a:t>
             </a:r>
           </a:p>
         </p:txBody>
@@ -4997,8 +5017,8 @@
         </p:nvSpPr>
         <p:spPr>
           <a:xfrm>
-            <a:off x="6016752" y="3913632"/>
-            <a:ext cx="5806440" cy="1280160"/>
+            <a:off x="6016752" y="3840480"/>
+            <a:ext cx="5806440" cy="1243584"/>
           </a:xfrm>
           <a:prstGeom prst="roundRect">
             <a:avLst/>
@@ -5042,8 +5062,8 @@
         </p:nvSpPr>
         <p:spPr>
           <a:xfrm>
-            <a:off x="6016752" y="3913632"/>
-            <a:ext cx="73152" cy="1280160"/>
+            <a:off x="6016752" y="3840480"/>
+            <a:ext cx="73152" cy="1243584"/>
           </a:xfrm>
           <a:prstGeom prst="rect">
             <a:avLst/>
@@ -5085,8 +5105,8 @@
         </p:nvSpPr>
         <p:spPr>
           <a:xfrm>
-            <a:off x="6236208" y="3986784"/>
-            <a:ext cx="5440680" cy="182880"/>
+            <a:off x="6236208" y="3895344"/>
+            <a:ext cx="5440680" cy="164592"/>
           </a:xfrm>
           <a:prstGeom prst="rect">
             <a:avLst/>
@@ -5126,8 +5146,8 @@
         </p:nvSpPr>
         <p:spPr>
           <a:xfrm>
-            <a:off x="6236208" y="4169664"/>
-            <a:ext cx="5440680" cy="237744"/>
+            <a:off x="6236208" y="4059936"/>
+            <a:ext cx="5440680" cy="201168"/>
           </a:xfrm>
           <a:prstGeom prst="rect">
             <a:avLst/>
@@ -5147,7 +5167,7 @@
               </a:spcAft>
             </a:pPr>
             <a:r>
-              <a:rPr sz="1400" b="1">
+              <a:rPr sz="1300" b="1">
                 <a:solidFill>
                   <a:srgbClr val="0B1F3A"/>
                 </a:solidFill>
@@ -5167,8 +5187,8 @@
         </p:nvSpPr>
         <p:spPr>
           <a:xfrm>
-            <a:off x="6236208" y="4443984"/>
-            <a:ext cx="5440680" cy="658368"/>
+            <a:off x="6236208" y="4279392"/>
+            <a:ext cx="5440680" cy="749808"/>
           </a:xfrm>
           <a:prstGeom prst="rect">
             <a:avLst/>
@@ -5181,21 +5201,21 @@
           <a:p>
             <a:pPr algn="l">
               <a:lnSpc>
-                <a:spcPct val="105000"/>
-              </a:lnSpc>
-              <a:spcAft>
-                <a:spcPts val="100"/>
-              </a:spcAft>
-            </a:pPr>
-            <a:r>
-              <a:rPr sz="1050" b="0">
+                <a:spcPct val="104000"/>
+              </a:lnSpc>
+              <a:spcAft>
+                <a:spcPts val="100"/>
+              </a:spcAft>
+            </a:pPr>
+            <a:r>
+              <a:rPr sz="1000" b="0">
                 <a:solidFill>
                   <a:srgbClr val="2C3E50"/>
                 </a:solidFill>
                 <a:latin typeface="WenQuanYi Micro Hei"/>
                 <a:ea typeface="WenQuanYi Micro Hei"/>
               </a:rPr>
-              <a:t>以分层SKU换产品化速度。先让能力可销售、可组合，再验证各层是否共享同一控制体系。</a:t>
+              <a:t>以分层SKU换产品化速度。先让目录、AI和应用可分别销售并进入现网，再验证各层是否共享同一契约和控制体系。</a:t>
             </a:r>
           </a:p>
         </p:txBody>
@@ -5208,8 +5228,8 @@
         </p:nvSpPr>
         <p:spPr>
           <a:xfrm>
-            <a:off x="347472" y="5321808"/>
-            <a:ext cx="11475720" cy="1170432"/>
+            <a:off x="347472" y="5212080"/>
+            <a:ext cx="11475720" cy="1298448"/>
           </a:xfrm>
           <a:prstGeom prst="roundRect">
             <a:avLst/>
@@ -5253,8 +5273,8 @@
         </p:nvSpPr>
         <p:spPr>
           <a:xfrm>
-            <a:off x="493776" y="5394960"/>
-            <a:ext cx="11183112" cy="201168"/>
+            <a:off x="493776" y="5266944"/>
+            <a:ext cx="11183112" cy="182880"/>
           </a:xfrm>
           <a:prstGeom prst="rect">
             <a:avLst/>
@@ -5281,7 +5301,7 @@
                 <a:latin typeface="WenQuanYi Micro Hei"/>
                 <a:ea typeface="WenQuanYi Micro Hei"/>
               </a:rPr>
-              <a:t>共同绕不开的不是平台名称，而是四类控制能力</a:t>
+              <a:t>共同绕不开的不是平台名称，而是四类控制能力及其外部接口</a:t>
             </a:r>
           </a:p>
         </p:txBody>
@@ -5294,8 +5314,8 @@
         </p:nvSpPr>
         <p:spPr>
           <a:xfrm>
-            <a:off x="493776" y="5687568"/>
-            <a:ext cx="2697480" cy="621792"/>
+            <a:off x="493776" y="5504688"/>
+            <a:ext cx="2697480" cy="877824"/>
           </a:xfrm>
           <a:prstGeom prst="roundRect">
             <a:avLst/>
@@ -5337,8 +5357,8 @@
         </p:nvSpPr>
         <p:spPr>
           <a:xfrm>
-            <a:off x="493776" y="5833872"/>
-            <a:ext cx="2697480" cy="347472"/>
+            <a:off x="585216" y="5559552"/>
+            <a:ext cx="2514600" cy="256032"/>
           </a:xfrm>
           <a:prstGeom prst="rect">
             <a:avLst/>
@@ -5358,7 +5378,7 @@
               </a:spcAft>
             </a:pPr>
             <a:r>
-              <a:rPr sz="1300" b="1">
+              <a:rPr sz="1200" b="1">
                 <a:solidFill>
                   <a:srgbClr val="FFFFFF"/>
                 </a:solidFill>
@@ -5372,14 +5392,55 @@
       </p:sp>
       <p:sp>
         <p:nvSpPr>
-          <p:cNvPr id="55" name="Rounded Rectangle 54"/>
+          <p:cNvPr id="55" name="TextBox 54"/>
+          <p:cNvSpPr txBox="1"/>
+          <p:nvPr/>
+        </p:nvSpPr>
+        <p:spPr>
+          <a:xfrm>
+            <a:off x="585216" y="5833872"/>
+            <a:ext cx="2514600" cy="475488"/>
+          </a:xfrm>
+          <a:prstGeom prst="rect">
+            <a:avLst/>
+          </a:prstGeom>
+          <a:noFill/>
+        </p:spPr>
+        <p:txBody>
+          <a:bodyPr wrap="square"/>
+          <a:lstStyle/>
+          <a:p>
+            <a:pPr algn="ctr">
+              <a:lnSpc>
+                <a:spcPct val="102000"/>
+              </a:lnSpc>
+              <a:spcAft>
+                <a:spcPts val="100"/>
+              </a:spcAft>
+            </a:pPr>
+            <a:r>
+              <a:rPr sz="900" b="0">
+                <a:solidFill>
+                  <a:srgbClr val="FFFFFF"/>
+                </a:solidFill>
+                <a:latin typeface="WenQuanYi Micro Hei"/>
+                <a:ea typeface="WenQuanYi Micro Hei"/>
+              </a:rPr>
+              <a:t>稳定ID、权威源、配置版本和对象映射</a:t>
+            </a:r>
+          </a:p>
+        </p:txBody>
+      </p:sp>
+      <p:sp>
+        <p:nvSpPr>
+          <p:cNvPr id="56" name="Rounded Rectangle 55"/>
           <p:cNvSpPr/>
           <p:nvPr/>
         </p:nvSpPr>
         <p:spPr>
           <a:xfrm>
-            <a:off x="3328416" y="5687568"/>
-            <a:ext cx="2697480" cy="621792"/>
+            <a:off x="3328416" y="5504688"/>
+            <a:ext cx="2697480" cy="877824"/>
           </a:xfrm>
           <a:prstGeom prst="roundRect">
             <a:avLst/>
@@ -5415,14 +5476,14 @@
       </p:sp>
       <p:sp>
         <p:nvSpPr>
-          <p:cNvPr id="56" name="TextBox 55"/>
+          <p:cNvPr id="57" name="TextBox 56"/>
           <p:cNvSpPr txBox="1"/>
           <p:nvPr/>
         </p:nvSpPr>
         <p:spPr>
           <a:xfrm>
-            <a:off x="3328416" y="5833872"/>
-            <a:ext cx="2697480" cy="347472"/>
+            <a:off x="3419856" y="5559552"/>
+            <a:ext cx="2514600" cy="256032"/>
           </a:xfrm>
           <a:prstGeom prst="rect">
             <a:avLst/>
@@ -5442,7 +5503,7 @@
               </a:spcAft>
             </a:pPr>
             <a:r>
-              <a:rPr sz="1300" b="1">
+              <a:rPr sz="1200" b="1">
                 <a:solidFill>
                   <a:srgbClr val="FFFFFF"/>
                 </a:solidFill>
@@ -5456,14 +5517,55 @@
       </p:sp>
       <p:sp>
         <p:nvSpPr>
-          <p:cNvPr id="57" name="Rounded Rectangle 56"/>
+          <p:cNvPr id="58" name="TextBox 57"/>
+          <p:cNvSpPr txBox="1"/>
+          <p:nvPr/>
+        </p:nvSpPr>
+        <p:spPr>
+          <a:xfrm>
+            <a:off x="3419856" y="5833872"/>
+            <a:ext cx="2514600" cy="475488"/>
+          </a:xfrm>
+          <a:prstGeom prst="rect">
+            <a:avLst/>
+          </a:prstGeom>
+          <a:noFill/>
+        </p:spPr>
+        <p:txBody>
+          <a:bodyPr wrap="square"/>
+          <a:lstStyle/>
+          <a:p>
+            <a:pPr algn="ctr">
+              <a:lnSpc>
+                <a:spcPct val="102000"/>
+              </a:lnSpc>
+              <a:spcAft>
+                <a:spcPts val="100"/>
+              </a:spcAft>
+            </a:pPr>
+            <a:r>
+              <a:rPr sz="900" b="0">
+                <a:solidFill>
+                  <a:srgbClr val="FFFFFF"/>
+                </a:solidFill>
+                <a:latin typeface="WenQuanYi Micro Hei"/>
+                <a:ea typeface="WenQuanYi Micro Hei"/>
+              </a:rPr>
+              <a:t>用途适用性、Owner、SLO、计量与退出</a:t>
+            </a:r>
+          </a:p>
+        </p:txBody>
+      </p:sp>
+      <p:sp>
+        <p:nvSpPr>
+          <p:cNvPr id="59" name="Rounded Rectangle 58"/>
           <p:cNvSpPr/>
           <p:nvPr/>
         </p:nvSpPr>
         <p:spPr>
           <a:xfrm>
-            <a:off x="6163056" y="5687568"/>
-            <a:ext cx="2697480" cy="621792"/>
+            <a:off x="6163056" y="5504688"/>
+            <a:ext cx="2697480" cy="877824"/>
           </a:xfrm>
           <a:prstGeom prst="roundRect">
             <a:avLst/>
@@ -5499,14 +5601,14 @@
       </p:sp>
       <p:sp>
         <p:nvSpPr>
-          <p:cNvPr id="58" name="TextBox 57"/>
+          <p:cNvPr id="60" name="TextBox 59"/>
           <p:cNvSpPr txBox="1"/>
           <p:nvPr/>
         </p:nvSpPr>
         <p:spPr>
           <a:xfrm>
-            <a:off x="6163056" y="5833872"/>
-            <a:ext cx="2697480" cy="347472"/>
+            <a:off x="6254496" y="5559552"/>
+            <a:ext cx="2514600" cy="256032"/>
           </a:xfrm>
           <a:prstGeom prst="rect">
             <a:avLst/>
@@ -5526,7 +5628,7 @@
               </a:spcAft>
             </a:pPr>
             <a:r>
-              <a:rPr sz="1300" b="1">
+              <a:rPr sz="1200" b="1">
                 <a:solidFill>
                   <a:srgbClr val="FFFFFF"/>
                 </a:solidFill>
@@ -5540,14 +5642,55 @@
       </p:sp>
       <p:sp>
         <p:nvSpPr>
-          <p:cNvPr id="59" name="Rounded Rectangle 58"/>
+          <p:cNvPr id="61" name="TextBox 60"/>
+          <p:cNvSpPr txBox="1"/>
+          <p:nvPr/>
+        </p:nvSpPr>
+        <p:spPr>
+          <a:xfrm>
+            <a:off x="6254496" y="5833872"/>
+            <a:ext cx="2514600" cy="475488"/>
+          </a:xfrm>
+          <a:prstGeom prst="rect">
+            <a:avLst/>
+          </a:prstGeom>
+          <a:noFill/>
+        </p:spPr>
+        <p:txBody>
+          <a:bodyPr wrap="square"/>
+          <a:lstStyle/>
+          <a:p>
+            <a:pPr algn="ctr">
+              <a:lnSpc>
+                <a:spcPct val="102000"/>
+              </a:lnSpc>
+              <a:spcAft>
+                <a:spcPts val="100"/>
+              </a:spcAft>
+            </a:pPr>
+            <a:r>
+              <a:rPr sz="900" b="0">
+                <a:solidFill>
+                  <a:srgbClr val="FFFFFF"/>
+                </a:solidFill>
+                <a:latin typeface="WenQuanYi Micro Hei"/>
+                <a:ea typeface="WenQuanYi Micro Hei"/>
+              </a:rPr>
+              <a:t>算子放置、策略下发、断链生存与回退</a:t>
+            </a:r>
+          </a:p>
+        </p:txBody>
+      </p:sp>
+      <p:sp>
+        <p:nvSpPr>
+          <p:cNvPr id="62" name="Rounded Rectangle 61"/>
           <p:cNvSpPr/>
           <p:nvPr/>
         </p:nvSpPr>
         <p:spPr>
           <a:xfrm>
-            <a:off x="8997696" y="5687568"/>
-            <a:ext cx="2697480" cy="621792"/>
+            <a:off x="8997696" y="5504688"/>
+            <a:ext cx="2697480" cy="877824"/>
           </a:xfrm>
           <a:prstGeom prst="roundRect">
             <a:avLst/>
@@ -5583,14 +5726,14 @@
       </p:sp>
       <p:sp>
         <p:nvSpPr>
-          <p:cNvPr id="60" name="TextBox 59"/>
+          <p:cNvPr id="63" name="TextBox 62"/>
           <p:cNvSpPr txBox="1"/>
           <p:nvPr/>
         </p:nvSpPr>
         <p:spPr>
           <a:xfrm>
-            <a:off x="8997696" y="5833872"/>
-            <a:ext cx="2697480" cy="347472"/>
+            <a:off x="9089136" y="5559552"/>
+            <a:ext cx="2514600" cy="256032"/>
           </a:xfrm>
           <a:prstGeom prst="rect">
             <a:avLst/>
@@ -5610,7 +5753,7 @@
               </a:spcAft>
             </a:pPr>
             <a:r>
-              <a:rPr sz="1300" b="1">
+              <a:rPr sz="1200" b="1">
                 <a:solidFill>
                   <a:srgbClr val="FFFFFF"/>
                 </a:solidFill>
@@ -5624,7 +5767,48 @@
       </p:sp>
       <p:sp>
         <p:nvSpPr>
-          <p:cNvPr id="61" name="Rectangle 60"/>
+          <p:cNvPr id="64" name="TextBox 63"/>
+          <p:cNvSpPr txBox="1"/>
+          <p:nvPr/>
+        </p:nvSpPr>
+        <p:spPr>
+          <a:xfrm>
+            <a:off x="9089136" y="5833872"/>
+            <a:ext cx="2514600" cy="475488"/>
+          </a:xfrm>
+          <a:prstGeom prst="rect">
+            <a:avLst/>
+          </a:prstGeom>
+          <a:noFill/>
+        </p:spPr>
+        <p:txBody>
+          <a:bodyPr wrap="square"/>
+          <a:lstStyle/>
+          <a:p>
+            <a:pPr algn="ctr">
+              <a:lnSpc>
+                <a:spcPct val="102000"/>
+              </a:lnSpc>
+              <a:spcAft>
+                <a:spcPts val="100"/>
+              </a:spcAft>
+            </a:pPr>
+            <a:r>
+              <a:rPr sz="900" b="0">
+                <a:solidFill>
+                  <a:srgbClr val="FFFFFF"/>
+                </a:solidFill>
+                <a:latin typeface="WenQuanYi Micro Hei"/>
+                <a:ea typeface="WenQuanYi Micro Hei"/>
+              </a:rPr>
+              <a:t>数据到回滚可关联、可导出、可测试</a:t>
+            </a:r>
+          </a:p>
+        </p:txBody>
+      </p:sp>
+      <p:sp>
+        <p:nvSpPr>
+          <p:cNvPr id="65" name="Rectangle 64"/>
           <p:cNvSpPr/>
           <p:nvPr/>
         </p:nvSpPr>
@@ -5667,7 +5851,7 @@
       </p:sp>
       <p:sp>
         <p:nvSpPr>
-          <p:cNvPr id="62" name="TextBox 61"/>
+          <p:cNvPr id="66" name="TextBox 65"/>
           <p:cNvSpPr txBox="1"/>
           <p:nvPr/>
         </p:nvSpPr>
@@ -5708,7 +5892,7 @@
       </p:sp>
       <p:sp>
         <p:nvSpPr>
-          <p:cNvPr id="63" name="TextBox 62"/>
+          <p:cNvPr id="67" name="TextBox 66"/>
           <p:cNvSpPr txBox="1"/>
           <p:nvPr/>
         </p:nvSpPr>
@@ -5942,7 +6126,7 @@
         <p:spPr>
           <a:xfrm>
             <a:off x="347472" y="640080"/>
-            <a:ext cx="11475720" cy="420624"/>
+            <a:ext cx="11475720" cy="493776"/>
           </a:xfrm>
           <a:prstGeom prst="roundRect">
             <a:avLst/>
@@ -5976,10 +6160,10 @@
           <a:p>
             <a:pPr algn="l">
               <a:lnSpc>
-                <a:spcPct val="105000"/>
+                <a:spcPct val="104000"/>
               </a:lnSpc>
               <a:spcBef>
-                <a:spcPts val="300"/>
+                <a:spcPts val="200"/>
               </a:spcBef>
               <a:spcAft>
                 <a:spcPts val="100"/>
@@ -5993,7 +6177,7 @@
                 <a:latin typeface="WenQuanYi Micro Hei"/>
                 <a:ea typeface="WenQuanYi Micro Hei"/>
               </a:rPr>
-              <a:t>标准更关注跨厂商必须一致的对象和接口，不替厂商选择内部拓扑，因此三条路线可以长期并存。</a:t>
+              <a:t>ITU-R、SA2/SA5、O-RAN和外部运营接口正在形成一条可组合链路，但并不共同要求一个名为Data Fabric的网元。标准冻结跨厂商必须一致的对象与接口，不替厂商选择内部拓扑，因此三条路线可以长期并存。</a:t>
             </a:r>
           </a:p>
         </p:txBody>
@@ -6006,8 +6190,8 @@
         </p:nvSpPr>
         <p:spPr>
           <a:xfrm>
-            <a:off x="347472" y="1353312"/>
-            <a:ext cx="6583680" cy="1389888"/>
+            <a:off x="347472" y="1207008"/>
+            <a:ext cx="6583680" cy="1371600"/>
           </a:xfrm>
           <a:prstGeom prst="roundRect">
             <a:avLst/>
@@ -6049,8 +6233,8 @@
         </p:nvSpPr>
         <p:spPr>
           <a:xfrm>
-            <a:off x="512064" y="1426464"/>
-            <a:ext cx="6254496" cy="182880"/>
+            <a:off x="493776" y="1261872"/>
+            <a:ext cx="6291072" cy="164592"/>
           </a:xfrm>
           <a:prstGeom prst="rect">
             <a:avLst/>
@@ -6090,8 +6274,8 @@
         </p:nvSpPr>
         <p:spPr>
           <a:xfrm>
-            <a:off x="512064" y="1609344"/>
-            <a:ext cx="6254496" cy="256032"/>
+            <a:off x="493776" y="1426464"/>
+            <a:ext cx="6291072" cy="237744"/>
           </a:xfrm>
           <a:prstGeom prst="rect">
             <a:avLst/>
@@ -6111,7 +6295,7 @@
               </a:spcAft>
             </a:pPr>
             <a:r>
-              <a:rPr sz="1400" b="1">
+              <a:rPr sz="1300" b="1">
                 <a:solidFill>
                   <a:srgbClr val="FFFFFF"/>
                 </a:solidFill>
@@ -6131,8 +6315,8 @@
         </p:nvSpPr>
         <p:spPr>
           <a:xfrm>
-            <a:off x="512064" y="1883664"/>
-            <a:ext cx="6254496" cy="768096"/>
+            <a:off x="493776" y="1682496"/>
+            <a:ext cx="6291072" cy="822960"/>
           </a:xfrm>
           <a:prstGeom prst="rect">
             <a:avLst/>
@@ -6145,7 +6329,7 @@
           <a:p>
             <a:pPr algn="l">
               <a:lnSpc>
-                <a:spcPct val="105000"/>
+                <a:spcPct val="104000"/>
               </a:lnSpc>
               <a:spcAft>
                 <a:spcPts val="100"/>
@@ -6159,7 +6343,7 @@
                 <a:latin typeface="WenQuanYi Micro Hei"/>
                 <a:ea typeface="WenQuanYi Micro Hei"/>
               </a:rPr>
-              <a:t>消费者看见的是可订购、可计量、可追责的服务，而不是内部网元名称。</a:t>
+              <a:t>消费者看见的是可订购、可计量、可追责的服务，而不是内部网元名称。TMF/GSMA/CAMARA会先冻结这些外部行为，倒逼上游给出稳定语义和责任映射。</a:t>
             </a:r>
           </a:p>
         </p:txBody>
@@ -6172,8 +6356,8 @@
         </p:nvSpPr>
         <p:spPr>
           <a:xfrm>
-            <a:off x="347472" y="2907792"/>
-            <a:ext cx="6583680" cy="1389888"/>
+            <a:off x="347472" y="2743200"/>
+            <a:ext cx="6583680" cy="1371600"/>
           </a:xfrm>
           <a:prstGeom prst="roundRect">
             <a:avLst/>
@@ -6215,8 +6399,8 @@
         </p:nvSpPr>
         <p:spPr>
           <a:xfrm>
-            <a:off x="512064" y="2980944"/>
-            <a:ext cx="6254496" cy="182880"/>
+            <a:off x="493776" y="2798064"/>
+            <a:ext cx="6291072" cy="164592"/>
           </a:xfrm>
           <a:prstGeom prst="rect">
             <a:avLst/>
@@ -6256,8 +6440,8 @@
         </p:nvSpPr>
         <p:spPr>
           <a:xfrm>
-            <a:off x="512064" y="3163824"/>
-            <a:ext cx="6254496" cy="256032"/>
+            <a:off x="493776" y="2962656"/>
+            <a:ext cx="6291072" cy="237744"/>
           </a:xfrm>
           <a:prstGeom prst="rect">
             <a:avLst/>
@@ -6277,7 +6461,7 @@
               </a:spcAft>
             </a:pPr>
             <a:r>
-              <a:rPr sz="1400" b="1">
+              <a:rPr sz="1300" b="1">
                 <a:solidFill>
                   <a:srgbClr val="FFFFFF"/>
                 </a:solidFill>
@@ -6297,8 +6481,8 @@
         </p:nvSpPr>
         <p:spPr>
           <a:xfrm>
-            <a:off x="512064" y="3438144"/>
-            <a:ext cx="6254496" cy="768096"/>
+            <a:off x="493776" y="3218688"/>
+            <a:ext cx="6291072" cy="822960"/>
           </a:xfrm>
           <a:prstGeom prst="rect">
             <a:avLst/>
@@ -6311,7 +6495,7 @@
           <a:p>
             <a:pPr algn="l">
               <a:lnSpc>
-                <a:spcPct val="105000"/>
+                <a:spcPct val="104000"/>
               </a:lnSpc>
               <a:spcAft>
                 <a:spcPts val="100"/>
@@ -6325,7 +6509,7 @@
                 <a:latin typeface="WenQuanYi Micro Hei"/>
                 <a:ea typeface="WenQuanYi Micro Hei"/>
               </a:rPr>
-              <a:t>跨域复用真正依赖的是对象能否对齐、质量能否声明、动作能否回证。</a:t>
+              <a:t>跨域复用真正依赖对象能否对齐、质量能否声明、授权能否传递、动作能否回证。这是标准最可能先下手的控制层，也是三条路线最终都要交出的接口。</a:t>
             </a:r>
           </a:p>
         </p:txBody>
@@ -6338,8 +6522,8 @@
         </p:nvSpPr>
         <p:spPr>
           <a:xfrm>
-            <a:off x="347472" y="4462272"/>
-            <a:ext cx="6583680" cy="1389888"/>
+            <a:off x="347472" y="4279392"/>
+            <a:ext cx="6583680" cy="1371600"/>
           </a:xfrm>
           <a:prstGeom prst="roundRect">
             <a:avLst/>
@@ -6381,8 +6565,8 @@
         </p:nvSpPr>
         <p:spPr>
           <a:xfrm>
-            <a:off x="512064" y="4535424"/>
-            <a:ext cx="6254496" cy="182880"/>
+            <a:off x="493776" y="4334255"/>
+            <a:ext cx="6291072" cy="164592"/>
           </a:xfrm>
           <a:prstGeom prst="rect">
             <a:avLst/>
@@ -6422,8 +6606,8 @@
         </p:nvSpPr>
         <p:spPr>
           <a:xfrm>
-            <a:off x="512064" y="4718304"/>
-            <a:ext cx="6254496" cy="256032"/>
+            <a:off x="493776" y="4498848"/>
+            <a:ext cx="6291072" cy="237744"/>
           </a:xfrm>
           <a:prstGeom prst="rect">
             <a:avLst/>
@@ -6443,7 +6627,7 @@
               </a:spcAft>
             </a:pPr>
             <a:r>
-              <a:rPr sz="1400" b="1">
+              <a:rPr sz="1300" b="1">
                 <a:solidFill>
                   <a:srgbClr val="FFFFFF"/>
                 </a:solidFill>
@@ -6463,8 +6647,8 @@
         </p:nvSpPr>
         <p:spPr>
           <a:xfrm>
-            <a:off x="512064" y="4992624"/>
-            <a:ext cx="6254496" cy="768096"/>
+            <a:off x="493776" y="4754879"/>
+            <a:ext cx="6291072" cy="822960"/>
           </a:xfrm>
           <a:prstGeom prst="rect">
             <a:avLst/>
@@ -6477,7 +6661,7 @@
           <a:p>
             <a:pPr algn="l">
               <a:lnSpc>
-                <a:spcPct val="105000"/>
+                <a:spcPct val="104000"/>
               </a:lnSpc>
               <a:spcAft>
                 <a:spcPts val="100"/>
@@ -6491,7 +6675,7 @@
                 <a:latin typeface="WenQuanYi Micro Hei"/>
                 <a:ea typeface="WenQuanYi Micro Hei"/>
               </a:rPr>
-              <a:t>无线、会话和运维事实仍由网络域产生；标准先承认这些权威源，而不是另造一个总库。</a:t>
+              <a:t>无线、会话和运维事实仍由网络域产生。标准先承认这些权威源，而不是另造一个总库来替代RAN快环、会话状态或OAM对象。</a:t>
             </a:r>
           </a:p>
         </p:txBody>
@@ -6504,8 +6688,8 @@
         </p:nvSpPr>
         <p:spPr>
           <a:xfrm>
-            <a:off x="3364992" y="4187952"/>
-            <a:ext cx="384048" cy="256032"/>
+            <a:off x="3364992" y="4023360"/>
+            <a:ext cx="384048" cy="237744"/>
           </a:xfrm>
           <a:prstGeom prst="upArrow">
             <a:avLst/>
@@ -6547,8 +6731,8 @@
         </p:nvSpPr>
         <p:spPr>
           <a:xfrm>
-            <a:off x="3364992" y="2633472"/>
-            <a:ext cx="384048" cy="256032"/>
+            <a:off x="3364992" y="2487168"/>
+            <a:ext cx="384048" cy="237744"/>
           </a:xfrm>
           <a:prstGeom prst="upArrow">
             <a:avLst/>
@@ -6590,8 +6774,8 @@
         </p:nvSpPr>
         <p:spPr>
           <a:xfrm>
-            <a:off x="7114032" y="1353312"/>
-            <a:ext cx="4709160" cy="2084831"/>
+            <a:off x="7114032" y="1207008"/>
+            <a:ext cx="4709160" cy="2157984"/>
           </a:xfrm>
           <a:prstGeom prst="roundRect">
             <a:avLst/>
@@ -6635,8 +6819,8 @@
         </p:nvSpPr>
         <p:spPr>
           <a:xfrm>
-            <a:off x="7114032" y="1353312"/>
-            <a:ext cx="64008" cy="2084831"/>
+            <a:off x="7114032" y="1207008"/>
+            <a:ext cx="64008" cy="2157984"/>
           </a:xfrm>
           <a:prstGeom prst="rect">
             <a:avLst/>
@@ -6678,8 +6862,8 @@
         </p:nvSpPr>
         <p:spPr>
           <a:xfrm>
-            <a:off x="7260336" y="1417320"/>
-            <a:ext cx="4471416" cy="237744"/>
+            <a:off x="7260336" y="1252728"/>
+            <a:ext cx="4471416" cy="219456"/>
           </a:xfrm>
           <a:prstGeom prst="rect">
             <a:avLst/>
@@ -6719,8 +6903,8 @@
         </p:nvSpPr>
         <p:spPr>
           <a:xfrm>
-            <a:off x="7260336" y="1664208"/>
-            <a:ext cx="4471416" cy="1700784"/>
+            <a:off x="7260336" y="1481328"/>
+            <a:ext cx="4471416" cy="1828800"/>
           </a:xfrm>
           <a:prstGeom prst="rect">
             <a:avLst/>
@@ -6733,21 +6917,41 @@
           <a:p>
             <a:pPr algn="l">
               <a:lnSpc>
-                <a:spcPct val="106000"/>
-              </a:lnSpc>
-              <a:spcAft>
-                <a:spcPts val="100"/>
-              </a:spcAft>
-            </a:pPr>
-            <a:r>
-              <a:rPr sz="1100" b="0">
+                <a:spcPct val="104000"/>
+              </a:lnSpc>
+              <a:spcAft>
+                <a:spcPts val="100"/>
+              </a:spcAft>
+            </a:pPr>
+            <a:r>
+              <a:rPr sz="1050" b="0">
                 <a:solidFill>
                   <a:srgbClr val="2C3E50"/>
                 </a:solidFill>
                 <a:latin typeface="WenQuanYi Micro Hei"/>
                 <a:ea typeface="WenQuanYi Micro Hei"/>
               </a:rPr>
-              <a:t>角色、稳定标识、最小元数据、交付控制、QoD/授权/证据挂钩点，以及一致性测试。ZSM 029对注册、发现、资产和工作流的研究也指向这一方向。</a:t>
+              <a:t>角色、稳定标识、最小元数据、交付控制、QoD/授权/证据挂钩点，以及一致性测试。</a:t>
+            </a:r>
+          </a:p>
+          <a:p>
+            <a:pPr algn="l">
+              <a:lnSpc>
+                <a:spcPct val="104000"/>
+              </a:lnSpc>
+              <a:spcAft>
+                <a:spcPts val="100"/>
+              </a:spcAft>
+            </a:pPr>
+            <a:r>
+              <a:rPr sz="1050" b="0">
+                <a:solidFill>
+                  <a:srgbClr val="2C3E50"/>
+                </a:solidFill>
+                <a:latin typeface="WenQuanYi Micro Hei"/>
+                <a:ea typeface="WenQuanYi Micro Hei"/>
+              </a:rPr>
+              <a:t>ZSM 029对注册、发现、资产和工作流的研究也指向同一组外部行为，而不是指向某个平台形态。</a:t>
             </a:r>
           </a:p>
         </p:txBody>
@@ -6760,8 +6964,8 @@
         </p:nvSpPr>
         <p:spPr>
           <a:xfrm>
-            <a:off x="7114032" y="3566160"/>
-            <a:ext cx="4709160" cy="2084831"/>
+            <a:off x="7114032" y="3474720"/>
+            <a:ext cx="4709160" cy="2176272"/>
           </a:xfrm>
           <a:prstGeom prst="roundRect">
             <a:avLst/>
@@ -6805,8 +7009,8 @@
         </p:nvSpPr>
         <p:spPr>
           <a:xfrm>
-            <a:off x="7114032" y="3566160"/>
-            <a:ext cx="64008" cy="2084831"/>
+            <a:off x="7114032" y="3474720"/>
+            <a:ext cx="64008" cy="2176272"/>
           </a:xfrm>
           <a:prstGeom prst="rect">
             <a:avLst/>
@@ -6848,8 +7052,8 @@
         </p:nvSpPr>
         <p:spPr>
           <a:xfrm>
-            <a:off x="7260336" y="3630168"/>
-            <a:ext cx="4471416" cy="237744"/>
+            <a:off x="7260336" y="3520439"/>
+            <a:ext cx="4471416" cy="219456"/>
           </a:xfrm>
           <a:prstGeom prst="rect">
             <a:avLst/>
@@ -6889,8 +7093,8 @@
         </p:nvSpPr>
         <p:spPr>
           <a:xfrm>
-            <a:off x="7260336" y="3877056"/>
-            <a:ext cx="4471416" cy="1700784"/>
+            <a:off x="7260336" y="3749039"/>
+            <a:ext cx="4471416" cy="1847088"/>
           </a:xfrm>
           <a:prstGeom prst="rect">
             <a:avLst/>
@@ -6903,21 +7107,41 @@
           <a:p>
             <a:pPr algn="l">
               <a:lnSpc>
-                <a:spcPct val="106000"/>
-              </a:lnSpc>
-              <a:spcAft>
-                <a:spcPts val="100"/>
-              </a:spcAft>
-            </a:pPr>
-            <a:r>
-              <a:rPr sz="1100" b="0">
+                <a:spcPct val="104000"/>
+              </a:lnSpc>
+              <a:spcAft>
+                <a:spcPts val="100"/>
+              </a:spcAft>
+            </a:pPr>
+            <a:r>
+              <a:rPr sz="1050" b="0">
                 <a:solidFill>
                   <a:srgbClr val="2C3E50"/>
                 </a:solidFill>
                 <a:latin typeface="WenQuanYi Micro Hei"/>
                 <a:ea typeface="WenQuanYi Micro Hei"/>
               </a:rPr>
-              <a:t>既有NF增强、新NF、边缘Agent、管理侧服务、湖仓、消息运行时，以及是否存在独立Fabric，都仍是实现选择。标准不替厂商选定内部拓扑。</a:t>
+              <a:t>既有NF增强、新NF、边缘Agent、管理侧服务、湖仓和消息运行时，都可能承载同一外部行为。</a:t>
+            </a:r>
+          </a:p>
+          <a:p>
+            <a:pPr algn="l">
+              <a:lnSpc>
+                <a:spcPct val="104000"/>
+              </a:lnSpc>
+              <a:spcAft>
+                <a:spcPts val="100"/>
+              </a:spcAft>
+            </a:pPr>
+            <a:r>
+              <a:rPr sz="1050" b="0">
+                <a:solidFill>
+                  <a:srgbClr val="2C3E50"/>
+                </a:solidFill>
+                <a:latin typeface="WenQuanYi Micro Hei"/>
+                <a:ea typeface="WenQuanYi Micro Hei"/>
+              </a:rPr>
+              <a:t>是否存在独立Fabric仍是实现选择。标准不替厂商选定内部拓扑，也不把某家组件写成行业唯一答案。</a:t>
             </a:r>
           </a:p>
         </p:txBody>
@@ -6930,8 +7154,8 @@
         </p:nvSpPr>
         <p:spPr>
           <a:xfrm>
-            <a:off x="347472" y="5779008"/>
-            <a:ext cx="11475720" cy="731520"/>
+            <a:off x="347472" y="5742432"/>
+            <a:ext cx="11475720" cy="786384"/>
           </a:xfrm>
           <a:prstGeom prst="roundRect">
             <a:avLst/>
@@ -6975,8 +7199,8 @@
         </p:nvSpPr>
         <p:spPr>
           <a:xfrm>
-            <a:off x="457200" y="5824728"/>
-            <a:ext cx="5573268" cy="182880"/>
+            <a:off x="457200" y="5779008"/>
+            <a:ext cx="3691128" cy="164592"/>
           </a:xfrm>
           <a:prstGeom prst="rect">
             <a:avLst/>
@@ -7016,8 +7240,8 @@
         </p:nvSpPr>
         <p:spPr>
           <a:xfrm>
-            <a:off x="457200" y="5998464"/>
-            <a:ext cx="5573268" cy="457200"/>
+            <a:off x="457200" y="5943600"/>
+            <a:ext cx="3691128" cy="530352"/>
           </a:xfrm>
           <a:prstGeom prst="rect">
             <a:avLst/>
@@ -7044,7 +7268,7 @@
                 <a:latin typeface="WenQuanYi Micro Hei"/>
                 <a:ea typeface="WenQuanYi Micro Hei"/>
               </a:rPr>
-              <a:t>竞争从“组件是否存在”转向“接口能否互操作、后端能否替换、责任能否跨域传递”。</a:t>
+              <a:t>竞争从“组件是否存在”转向“接口能否互操作、后端能否替换、责任能否跨域传递”。名称相似不等于控制体系已经统一。</a:t>
             </a:r>
           </a:p>
         </p:txBody>
@@ -7057,8 +7281,8 @@
         </p:nvSpPr>
         <p:spPr>
           <a:xfrm>
-            <a:off x="6140196" y="5824728"/>
-            <a:ext cx="5573268" cy="182880"/>
+            <a:off x="4239768" y="5779008"/>
+            <a:ext cx="3691128" cy="164592"/>
           </a:xfrm>
           <a:prstGeom prst="rect">
             <a:avLst/>
@@ -7080,12 +7304,12 @@
             <a:r>
               <a:rPr sz="800" b="1">
                 <a:solidFill>
-                  <a:srgbClr val="B8860B"/>
-                </a:solidFill>
-                <a:latin typeface="WenQuanYi Micro Hei"/>
-                <a:ea typeface="WenQuanYi Micro Hei"/>
-              </a:rPr>
-              <a:t>停止线</a:t>
+                  <a:srgbClr val="0B1F3A"/>
+                </a:solidFill>
+                <a:latin typeface="WenQuanYi Micro Hei"/>
+                <a:ea typeface="WenQuanYi Micro Hei"/>
+              </a:rPr>
+              <a:t>判断含义</a:t>
             </a:r>
           </a:p>
         </p:txBody>
@@ -7098,8 +7322,8 @@
         </p:nvSpPr>
         <p:spPr>
           <a:xfrm>
-            <a:off x="6140196" y="5998464"/>
-            <a:ext cx="5573268" cy="457200"/>
+            <a:off x="4239768" y="5943600"/>
+            <a:ext cx="3691128" cy="530352"/>
           </a:xfrm>
           <a:prstGeom prst="rect">
             <a:avLst/>
@@ -7126,14 +7350,96 @@
                 <a:latin typeface="WenQuanYi Micro Hei"/>
                 <a:ea typeface="WenQuanYi Micro Hei"/>
               </a:rPr>
-              <a:t>Kafka、湖仓、完整知识图谱或独立Fabric都不是标准预设终点。</a:t>
-            </a:r>
-          </a:p>
-        </p:txBody>
-      </p:sp>
-      <p:sp>
-        <p:nvSpPr>
-          <p:cNvPr id="34" name="Rectangle 33"/>
+              <a:t>同一外部行为可以由网络原生功能、管理域服务或外部数据层分别实现；不同数据族也可以选择不同后端。</a:t>
+            </a:r>
+          </a:p>
+        </p:txBody>
+      </p:sp>
+      <p:sp>
+        <p:nvSpPr>
+          <p:cNvPr id="34" name="TextBox 33"/>
+          <p:cNvSpPr txBox="1"/>
+          <p:nvPr/>
+        </p:nvSpPr>
+        <p:spPr>
+          <a:xfrm>
+            <a:off x="8022336" y="5779008"/>
+            <a:ext cx="3691128" cy="164592"/>
+          </a:xfrm>
+          <a:prstGeom prst="rect">
+            <a:avLst/>
+          </a:prstGeom>
+          <a:noFill/>
+        </p:spPr>
+        <p:txBody>
+          <a:bodyPr wrap="square"/>
+          <a:lstStyle/>
+          <a:p>
+            <a:pPr algn="l">
+              <a:lnSpc>
+                <a:spcPct val="105000"/>
+              </a:lnSpc>
+              <a:spcAft>
+                <a:spcPts val="100"/>
+              </a:spcAft>
+            </a:pPr>
+            <a:r>
+              <a:rPr sz="800" b="1">
+                <a:solidFill>
+                  <a:srgbClr val="C0392B"/>
+                </a:solidFill>
+                <a:latin typeface="WenQuanYi Micro Hei"/>
+                <a:ea typeface="WenQuanYi Micro Hei"/>
+              </a:rPr>
+              <a:t>停止线</a:t>
+            </a:r>
+          </a:p>
+        </p:txBody>
+      </p:sp>
+      <p:sp>
+        <p:nvSpPr>
+          <p:cNvPr id="35" name="TextBox 34"/>
+          <p:cNvSpPr txBox="1"/>
+          <p:nvPr/>
+        </p:nvSpPr>
+        <p:spPr>
+          <a:xfrm>
+            <a:off x="8022336" y="5943600"/>
+            <a:ext cx="3691128" cy="530352"/>
+          </a:xfrm>
+          <a:prstGeom prst="rect">
+            <a:avLst/>
+          </a:prstGeom>
+          <a:noFill/>
+        </p:spPr>
+        <p:txBody>
+          <a:bodyPr wrap="square"/>
+          <a:lstStyle/>
+          <a:p>
+            <a:pPr algn="l">
+              <a:lnSpc>
+                <a:spcPct val="102000"/>
+              </a:lnSpc>
+              <a:spcAft>
+                <a:spcPts val="100"/>
+              </a:spcAft>
+            </a:pPr>
+            <a:r>
+              <a:rPr sz="800" b="0">
+                <a:solidFill>
+                  <a:srgbClr val="2C3E50"/>
+                </a:solidFill>
+                <a:latin typeface="WenQuanYi Micro Hei"/>
+                <a:ea typeface="WenQuanYi Micro Hei"/>
+              </a:rPr>
+              <a:t>Kafka、湖仓、完整知识图谱或独立Fabric都不是标准预设终点。不能用接口清单反推统一平台已经形成。</a:t>
+            </a:r>
+          </a:p>
+        </p:txBody>
+      </p:sp>
+      <p:sp>
+        <p:nvSpPr>
+          <p:cNvPr id="36" name="Rectangle 35"/>
           <p:cNvSpPr/>
           <p:nvPr/>
         </p:nvSpPr>
@@ -7176,7 +7482,7 @@
       </p:sp>
       <p:sp>
         <p:nvSpPr>
-          <p:cNvPr id="35" name="TextBox 34"/>
+          <p:cNvPr id="37" name="TextBox 36"/>
           <p:cNvSpPr txBox="1"/>
           <p:nvPr/>
         </p:nvSpPr>
@@ -7217,7 +7523,7 @@
       </p:sp>
       <p:sp>
         <p:nvSpPr>
-          <p:cNvPr id="36" name="TextBox 35"/>
+          <p:cNvPr id="38" name="TextBox 37"/>
           <p:cNvSpPr txBox="1"/>
           <p:nvPr/>
         </p:nvSpPr>
@@ -7451,7 +7757,7 @@
         <p:spPr>
           <a:xfrm>
             <a:off x="347472" y="640080"/>
-            <a:ext cx="11475720" cy="420624"/>
+            <a:ext cx="11475720" cy="493776"/>
           </a:xfrm>
           <a:prstGeom prst="roundRect">
             <a:avLst/>
@@ -7485,10 +7791,10 @@
           <a:p>
             <a:pPr algn="l">
               <a:lnSpc>
-                <a:spcPct val="105000"/>
+                <a:spcPct val="104000"/>
               </a:lnSpc>
               <a:spcBef>
-                <a:spcPts val="300"/>
+                <a:spcPts val="200"/>
               </a:spcBef>
               <a:spcAft>
                 <a:spcPts val="100"/>
@@ -7502,7 +7808,7 @@
                 <a:latin typeface="WenQuanYi Micro Hei"/>
                 <a:ea typeface="WenQuanYi Micro Hei"/>
               </a:rPr>
-              <a:t>数据在域内加工、按需联邦消费；统一的是治理视图，不是全部运行时。官方血缘是 Mediation→Telco DataOps，不是 EDCA→DataOps。</a:t>
+              <a:t>这是一条“先联邦、后治理”的路线：数据在域内加工、按需联邦消费，统一的是治理视图而不是全部运行时。公开材料支持架构思想连续，不支持已经形成一个统一商用Data Fabric SKU。官方产品血缘是 Mediation→Telco DataOps，不是 EDCA→DataOps。</a:t>
             </a:r>
           </a:p>
         </p:txBody>
@@ -7515,8 +7821,8 @@
         </p:nvSpPr>
         <p:spPr>
           <a:xfrm>
-            <a:off x="347472" y="1152144"/>
-            <a:ext cx="7059168" cy="4572000"/>
+            <a:off x="347472" y="1188720"/>
+            <a:ext cx="7059168" cy="4462272"/>
           </a:xfrm>
           <a:prstGeom prst="roundRect">
             <a:avLst/>
@@ -7568,8 +7874,8 @@
         </p:blipFill>
         <p:spPr>
           <a:xfrm>
-            <a:off x="751354" y="1225296"/>
-            <a:ext cx="6251402" cy="2697480"/>
+            <a:off x="995053" y="1243584"/>
+            <a:ext cx="5764004" cy="2487168"/>
           </a:xfrm>
           <a:prstGeom prst="rect">
             <a:avLst/>
@@ -7584,8 +7890,8 @@
         </p:nvSpPr>
         <p:spPr>
           <a:xfrm>
-            <a:off x="751354" y="1225296"/>
-            <a:ext cx="6251402" cy="2697480"/>
+            <a:off x="995053" y="1243584"/>
+            <a:ext cx="5764004" cy="2487168"/>
           </a:xfrm>
           <a:prstGeom prst="rect">
             <a:avLst/>
@@ -7627,8 +7933,8 @@
         </p:nvSpPr>
         <p:spPr>
           <a:xfrm>
-            <a:off x="512064" y="1280160"/>
-            <a:ext cx="1417320" cy="219456"/>
+            <a:off x="512064" y="1298448"/>
+            <a:ext cx="1417320" cy="201168"/>
           </a:xfrm>
           <a:prstGeom prst="roundRect">
             <a:avLst/>
@@ -7670,8 +7976,8 @@
         </p:nvSpPr>
         <p:spPr>
           <a:xfrm>
-            <a:off x="512064" y="1298448"/>
-            <a:ext cx="1417320" cy="201168"/>
+            <a:off x="512064" y="1316736"/>
+            <a:ext cx="1417320" cy="182880"/>
           </a:xfrm>
           <a:prstGeom prst="rect">
             <a:avLst/>
@@ -7711,8 +8017,8 @@
         </p:nvSpPr>
         <p:spPr>
           <a:xfrm>
-            <a:off x="457200" y="3931920"/>
-            <a:ext cx="6839712" cy="182880"/>
+            <a:off x="457200" y="3749039"/>
+            <a:ext cx="6839712" cy="164592"/>
           </a:xfrm>
           <a:prstGeom prst="rect">
             <a:avLst/>
@@ -7760,8 +8066,8 @@
         </p:blipFill>
         <p:spPr>
           <a:xfrm>
-            <a:off x="747268" y="4133087"/>
-            <a:ext cx="2665983" cy="1499616"/>
+            <a:off x="564896" y="3931920"/>
+            <a:ext cx="2893568" cy="1627632"/>
           </a:xfrm>
           <a:prstGeom prst="rect">
             <a:avLst/>
@@ -7776,8 +8082,8 @@
         </p:nvSpPr>
         <p:spPr>
           <a:xfrm>
-            <a:off x="747268" y="4133087"/>
-            <a:ext cx="2665983" cy="1499616"/>
+            <a:off x="564896" y="3931920"/>
+            <a:ext cx="2893568" cy="1627632"/>
           </a:xfrm>
           <a:prstGeom prst="rect">
             <a:avLst/>
@@ -7819,8 +8125,8 @@
         </p:nvSpPr>
         <p:spPr>
           <a:xfrm>
-            <a:off x="512064" y="4187952"/>
-            <a:ext cx="1234440" cy="201168"/>
+            <a:off x="512064" y="3986784"/>
+            <a:ext cx="1234440" cy="182880"/>
           </a:xfrm>
           <a:prstGeom prst="roundRect">
             <a:avLst/>
@@ -7862,8 +8168,8 @@
         </p:nvSpPr>
         <p:spPr>
           <a:xfrm>
-            <a:off x="512064" y="4206240"/>
-            <a:ext cx="1234440" cy="182880"/>
+            <a:off x="512064" y="4005072"/>
+            <a:ext cx="1234440" cy="164592"/>
           </a:xfrm>
           <a:prstGeom prst="rect">
             <a:avLst/>
@@ -7903,8 +8209,8 @@
         </p:nvSpPr>
         <p:spPr>
           <a:xfrm>
-            <a:off x="3803904" y="4133087"/>
-            <a:ext cx="3474720" cy="1499616"/>
+            <a:off x="3657600" y="3931920"/>
+            <a:ext cx="3621024" cy="1627632"/>
           </a:xfrm>
           <a:prstGeom prst="rect">
             <a:avLst/>
@@ -7917,61 +8223,61 @@
           <a:p>
             <a:pPr algn="l">
               <a:lnSpc>
-                <a:spcPct val="112000"/>
-              </a:lnSpc>
-              <a:spcAft>
-                <a:spcPts val="100"/>
-              </a:spcAft>
-            </a:pPr>
-            <a:r>
-              <a:rPr sz="950" b="0">
+                <a:spcPct val="106000"/>
+              </a:lnSpc>
+              <a:spcAft>
+                <a:spcPts val="100"/>
+              </a:spcAft>
+            </a:pPr>
+            <a:r>
+              <a:rPr sz="900" b="0">
                 <a:solidFill>
                   <a:srgbClr val="2C3E50"/>
                 </a:solidFill>
                 <a:latin typeface="WenQuanYi Micro Hei"/>
                 <a:ea typeface="WenQuanYi Micro Hei"/>
               </a:rPr>
-              <a:t>① 近源摄取仍保留：EDCA、DRG在Figure 18继续存在。</a:t>
+              <a:t>① 近源摄取仍保留：EDCA、DRG在2026 Figure 18继续存在，证明联邦摄取机制没有被废弃。</a:t>
             </a:r>
           </a:p>
           <a:p>
             <a:pPr algn="l">
               <a:lnSpc>
-                <a:spcPct val="112000"/>
-              </a:lnSpc>
-              <a:spcAft>
-                <a:spcPts val="100"/>
-              </a:spcAft>
-            </a:pPr>
-            <a:r>
-              <a:rPr sz="950" b="0">
+                <a:spcPct val="106000"/>
+              </a:lnSpc>
+              <a:spcAft>
+                <a:spcPts val="100"/>
+              </a:spcAft>
+            </a:pPr>
+            <a:r>
+              <a:rPr sz="900" b="0">
                 <a:solidFill>
                   <a:srgbClr val="2C3E50"/>
                 </a:solidFill>
                 <a:latin typeface="WenQuanYi Micro Hei"/>
                 <a:ea typeface="WenQuanYi Micro Hei"/>
               </a:rPr>
-              <a:t>② 联邦边界被扩展：客户侧DMF连接Ericsson侧EFDL/Data Fabric。</a:t>
+              <a:t>② 联邦边界被扩展：客户侧DMF连接Ericsson侧EFDL/Data Fabric，权威数据不必先搬迁。</a:t>
             </a:r>
           </a:p>
           <a:p>
             <a:pPr algn="l">
               <a:lnSpc>
-                <a:spcPct val="112000"/>
-              </a:lnSpc>
-              <a:spcAft>
-                <a:spcPts val="100"/>
-              </a:spcAft>
-            </a:pPr>
-            <a:r>
-              <a:rPr sz="950" b="0">
+                <a:spcPct val="106000"/>
+              </a:lnSpc>
+              <a:spcAft>
+                <a:spcPts val="100"/>
+              </a:spcAft>
+            </a:pPr>
+            <a:r>
+              <a:rPr sz="900" b="0">
                 <a:solidFill>
                   <a:srgbClr val="2C3E50"/>
                 </a:solidFill>
                 <a:latin typeface="WenQuanYi Micro Hei"/>
                 <a:ea typeface="WenQuanYi Micro Hei"/>
               </a:rPr>
-              <a:t>③ 治理范围上移：North Star增加目录、质量、血缘、语义/KG和数据产品。</a:t>
+              <a:t>③ 治理范围上移：North Star增加目录、质量、血缘、语义/KG和数据产品，但是future-state参考架构，不是已交付统一SKU。</a:t>
             </a:r>
           </a:p>
         </p:txBody>
@@ -7984,8 +8290,8 @@
         </p:nvSpPr>
         <p:spPr>
           <a:xfrm>
-            <a:off x="7534656" y="1152144"/>
-            <a:ext cx="4306824" cy="1444752"/>
+            <a:off x="7534656" y="1188720"/>
+            <a:ext cx="4306824" cy="1408176"/>
           </a:xfrm>
           <a:prstGeom prst="roundRect">
             <a:avLst/>
@@ -8029,8 +8335,8 @@
         </p:nvSpPr>
         <p:spPr>
           <a:xfrm>
-            <a:off x="7534656" y="1152144"/>
-            <a:ext cx="64008" cy="1444752"/>
+            <a:off x="7534656" y="1188720"/>
+            <a:ext cx="64008" cy="1408176"/>
           </a:xfrm>
           <a:prstGeom prst="rect">
             <a:avLst/>
@@ -8072,8 +8378,8 @@
         </p:nvSpPr>
         <p:spPr>
           <a:xfrm>
-            <a:off x="7680960" y="1216152"/>
-            <a:ext cx="4069080" cy="237744"/>
+            <a:off x="7680960" y="1234440"/>
+            <a:ext cx="4069080" cy="219456"/>
           </a:xfrm>
           <a:prstGeom prst="rect">
             <a:avLst/>
@@ -8114,7 +8420,7 @@
         <p:spPr>
           <a:xfrm>
             <a:off x="7680960" y="1463040"/>
-            <a:ext cx="4069080" cy="1060704"/>
+            <a:ext cx="4069080" cy="1078992"/>
           </a:xfrm>
           <a:prstGeom prst="rect">
             <a:avLst/>
@@ -8127,21 +8433,41 @@
           <a:p>
             <a:pPr algn="l">
               <a:lnSpc>
-                <a:spcPct val="106000"/>
-              </a:lnSpc>
-              <a:spcAft>
-                <a:spcPts val="100"/>
-              </a:spcAft>
-            </a:pPr>
-            <a:r>
-              <a:rPr sz="1000" b="0">
+                <a:spcPct val="104000"/>
+              </a:lnSpc>
+              <a:spcAft>
+                <a:spcPts val="100"/>
+              </a:spcAft>
+            </a:pPr>
+            <a:r>
+              <a:rPr sz="950" b="0">
                 <a:solidFill>
                   <a:srgbClr val="2C3E50"/>
                 </a:solidFill>
                 <a:latin typeface="WenQuanYi Micro Hei"/>
                 <a:ea typeface="WenQuanYi Micro Hei"/>
               </a:rPr>
-              <a:t>数据在域内采集加工，经联邦访问和智能移动供跨域消费。目录、策略和治理提供统一视图；执行仍分散在DataOps、NWDAF、EIAP/rApps和域系统。</a:t>
+              <a:t>数据在域内采集加工，经联邦访问和智能移动供跨域消费，重点不是把数据集中到一个湖。</a:t>
+            </a:r>
+          </a:p>
+          <a:p>
+            <a:pPr algn="l">
+              <a:lnSpc>
+                <a:spcPct val="104000"/>
+              </a:lnSpc>
+              <a:spcAft>
+                <a:spcPts val="100"/>
+              </a:spcAft>
+            </a:pPr>
+            <a:r>
+              <a:rPr sz="950" b="0">
+                <a:solidFill>
+                  <a:srgbClr val="2C3E50"/>
+                </a:solidFill>
+                <a:latin typeface="WenQuanYi Micro Hei"/>
+                <a:ea typeface="WenQuanYi Micro Hei"/>
+              </a:rPr>
+              <a:t>目录、策略、质量与血缘提供跨岛视图；执行仍分散在DataOps、NWDAF、EIAP/rApps和域系统。</a:t>
             </a:r>
           </a:p>
         </p:txBody>
@@ -8154,8 +8480,8 @@
         </p:nvSpPr>
         <p:spPr>
           <a:xfrm>
-            <a:off x="7534656" y="2706624"/>
-            <a:ext cx="4306824" cy="1444752"/>
+            <a:off x="7534656" y="2688336"/>
+            <a:ext cx="4306824" cy="1408176"/>
           </a:xfrm>
           <a:prstGeom prst="roundRect">
             <a:avLst/>
@@ -8199,8 +8525,8 @@
         </p:nvSpPr>
         <p:spPr>
           <a:xfrm>
-            <a:off x="7534656" y="2706624"/>
-            <a:ext cx="64008" cy="1444752"/>
+            <a:off x="7534656" y="2688336"/>
+            <a:ext cx="64008" cy="1408176"/>
           </a:xfrm>
           <a:prstGeom prst="rect">
             <a:avLst/>
@@ -8242,8 +8568,8 @@
         </p:nvSpPr>
         <p:spPr>
           <a:xfrm>
-            <a:off x="7680960" y="2770632"/>
-            <a:ext cx="4069080" cy="237744"/>
+            <a:off x="7680960" y="2734056"/>
+            <a:ext cx="4069080" cy="219456"/>
           </a:xfrm>
           <a:prstGeom prst="rect">
             <a:avLst/>
@@ -8283,8 +8609,8 @@
         </p:nvSpPr>
         <p:spPr>
           <a:xfrm>
-            <a:off x="7680960" y="3017520"/>
-            <a:ext cx="4069080" cy="1060704"/>
+            <a:off x="7680960" y="2962656"/>
+            <a:ext cx="4069080" cy="1078992"/>
           </a:xfrm>
           <a:prstGeom prst="rect">
             <a:avLst/>
@@ -8297,21 +8623,41 @@
           <a:p>
             <a:pPr algn="l">
               <a:lnSpc>
-                <a:spcPct val="106000"/>
-              </a:lnSpc>
-              <a:spcAft>
-                <a:spcPts val="100"/>
-              </a:spcAft>
-            </a:pPr>
-            <a:r>
-              <a:rPr sz="1000" b="0">
+                <a:spcPct val="104000"/>
+              </a:lnSpc>
+              <a:spcAft>
+                <a:spcPts val="100"/>
+              </a:spcAft>
+            </a:pPr>
+            <a:r>
+              <a:rPr sz="950" b="0">
                 <a:solidFill>
                   <a:srgbClr val="2C3E50"/>
                 </a:solidFill>
                 <a:latin typeface="WenQuanYi Micro Hei"/>
                 <a:ea typeface="WenQuanYi Micro Hei"/>
               </a:rPr>
-              <a:t>RAN、Core、OSS/BSS和边缘权威源天然分散；Mediation、NWDAF、SMO/RIC和客户湖仓不可跳过。先连接数据岛，再逐步补齐治理。</a:t>
+              <a:t>RAN、Core、OSS/BSS和边缘拥有不同对象、时标和故障域，权威源天然分散。</a:t>
+            </a:r>
+          </a:p>
+          <a:p>
+            <a:pPr algn="l">
+              <a:lnSpc>
+                <a:spcPct val="104000"/>
+              </a:lnSpc>
+              <a:spcAft>
+                <a:spcPts val="100"/>
+              </a:spcAft>
+            </a:pPr>
+            <a:r>
+              <a:rPr sz="950" b="0">
+                <a:solidFill>
+                  <a:srgbClr val="2C3E50"/>
+                </a:solidFill>
+                <a:latin typeface="WenQuanYi Micro Hei"/>
+                <a:ea typeface="WenQuanYi Micro Hei"/>
+              </a:rPr>
+              <a:t>Mediation、NWDAF、SMO/RIC和客户湖仓不可跳过。先连接数据岛、对齐外部行为，再决定内部控制是否值得收敛。</a:t>
             </a:r>
           </a:p>
         </p:txBody>
@@ -8324,7 +8670,7 @@
         </p:nvSpPr>
         <p:spPr>
           <a:xfrm>
-            <a:off x="7534656" y="4261104"/>
+            <a:off x="7534656" y="4187952"/>
             <a:ext cx="4306824" cy="1463040"/>
           </a:xfrm>
           <a:prstGeom prst="roundRect">
@@ -8369,7 +8715,7 @@
         </p:nvSpPr>
         <p:spPr>
           <a:xfrm>
-            <a:off x="7534656" y="4261104"/>
+            <a:off x="7534656" y="4187952"/>
             <a:ext cx="64008" cy="1463040"/>
           </a:xfrm>
           <a:prstGeom prst="rect">
@@ -8412,8 +8758,8 @@
         </p:nvSpPr>
         <p:spPr>
           <a:xfrm>
-            <a:off x="7680960" y="4325112"/>
-            <a:ext cx="4069080" cy="237744"/>
+            <a:off x="7680960" y="4233672"/>
+            <a:ext cx="4069080" cy="219456"/>
           </a:xfrm>
           <a:prstGeom prst="rect">
             <a:avLst/>
@@ -8453,8 +8799,8 @@
         </p:nvSpPr>
         <p:spPr>
           <a:xfrm>
-            <a:off x="7680960" y="4572000"/>
-            <a:ext cx="4069080" cy="1078992"/>
+            <a:off x="7680960" y="4462272"/>
+            <a:ext cx="4069080" cy="1133856"/>
           </a:xfrm>
           <a:prstGeom prst="rect">
             <a:avLst/>
@@ -8467,21 +8813,41 @@
           <a:p>
             <a:pPr algn="l">
               <a:lnSpc>
-                <a:spcPct val="106000"/>
-              </a:lnSpc>
-              <a:spcAft>
-                <a:spcPts val="100"/>
-              </a:spcAft>
-            </a:pPr>
-            <a:r>
-              <a:rPr sz="1000" b="0">
+                <a:spcPct val="104000"/>
+              </a:lnSpc>
+              <a:spcAft>
+                <a:spcPts val="100"/>
+              </a:spcAft>
+            </a:pPr>
+            <a:r>
+              <a:rPr sz="950" b="0">
                 <a:solidFill>
                   <a:srgbClr val="2C3E50"/>
                 </a:solidFill>
                 <a:latin typeface="WenQuanYi Micro Hei"/>
                 <a:ea typeface="WenQuanYi Micro Hei"/>
               </a:rPr>
-              <a:t>优势是渐进接入、多后端、迁移风险低。代价是跨产品Schema、QoD、策略和版本可能长期碎片化。</a:t>
+              <a:t>优势是渐进接入、多后端和源侧权威，迁移风险低，也更容易进入异构数据栈。</a:t>
+            </a:r>
+          </a:p>
+          <a:p>
+            <a:pPr algn="l">
+              <a:lnSpc>
+                <a:spcPct val="104000"/>
+              </a:lnSpc>
+              <a:spcAft>
+                <a:spcPts val="100"/>
+              </a:spcAft>
+            </a:pPr>
+            <a:r>
+              <a:rPr sz="950" b="0">
+                <a:solidFill>
+                  <a:srgbClr val="2C3E50"/>
+                </a:solidFill>
+                <a:latin typeface="WenQuanYi Micro Hei"/>
+                <a:ea typeface="WenQuanYi Micro Hei"/>
+              </a:rPr>
+              <a:t>代价是跨产品Schema、QoD、策略和版本可能长期碎片化；协调成本若高于替换成本，联邦优势会下降。</a:t>
             </a:r>
           </a:p>
         </p:txBody>
@@ -8494,8 +8860,8 @@
         </p:nvSpPr>
         <p:spPr>
           <a:xfrm>
-            <a:off x="347472" y="5833872"/>
-            <a:ext cx="11475720" cy="694944"/>
+            <a:off x="347472" y="5742432"/>
+            <a:ext cx="11475720" cy="786384"/>
           </a:xfrm>
           <a:prstGeom prst="roundRect">
             <a:avLst/>
@@ -8539,8 +8905,8 @@
         </p:nvSpPr>
         <p:spPr>
           <a:xfrm>
-            <a:off x="457200" y="5879592"/>
-            <a:ext cx="3678936" cy="182880"/>
+            <a:off x="457200" y="5779008"/>
+            <a:ext cx="3691128" cy="164592"/>
           </a:xfrm>
           <a:prstGeom prst="rect">
             <a:avLst/>
@@ -8580,8 +8946,8 @@
         </p:nvSpPr>
         <p:spPr>
           <a:xfrm>
-            <a:off x="457200" y="6053328"/>
-            <a:ext cx="3678936" cy="420624"/>
+            <a:off x="457200" y="5943600"/>
+            <a:ext cx="3691128" cy="530352"/>
           </a:xfrm>
           <a:prstGeom prst="rect">
             <a:avLst/>
@@ -8608,7 +8974,7 @@
                 <a:latin typeface="WenQuanYi Micro Hei"/>
                 <a:ea typeface="WenQuanYi Micro Hei"/>
               </a:rPr>
-              <a:t>Figure 18延续EDCA/DRG；Mediation、EIAP、NWDAF分别有产品或部署锚点。</a:t>
+              <a:t>Figure 18延续EDCA/DRG；Mediation、EIAP、NWDAF和API渠道分别有产品或部署锚点。North Star把范围扩到语义/KG、质量和数据产品，但仍是参考架构。</a:t>
             </a:r>
           </a:p>
         </p:txBody>
@@ -8621,8 +8987,8 @@
         </p:nvSpPr>
         <p:spPr>
           <a:xfrm>
-            <a:off x="4245864" y="5879592"/>
-            <a:ext cx="3678936" cy="182880"/>
+            <a:off x="4239768" y="5779008"/>
+            <a:ext cx="3691128" cy="164592"/>
           </a:xfrm>
           <a:prstGeom prst="rect">
             <a:avLst/>
@@ -8662,8 +9028,8 @@
         </p:nvSpPr>
         <p:spPr>
           <a:xfrm>
-            <a:off x="4245864" y="6053328"/>
-            <a:ext cx="3678936" cy="420624"/>
+            <a:off x="4239768" y="5943600"/>
+            <a:ext cx="3691128" cy="530352"/>
           </a:xfrm>
           <a:prstGeom prst="rect">
             <a:avLst/>
@@ -8690,7 +9056,7 @@
                 <a:latin typeface="WenQuanYi Micro Hei"/>
                 <a:ea typeface="WenQuanYi Micro Hei"/>
               </a:rPr>
-              <a:t>官方产品血缘是 Mediation→Telco DataOps，不是 EDCA→DataOps。</a:t>
+              <a:t>官方产品血缘是 Mediation→Telco DataOps，不是 EDCA→DataOps。DDC/GDC名称消失只能说明功能重组。“no data copy”应读成减少不必要复制。</a:t>
             </a:r>
           </a:p>
         </p:txBody>
@@ -8703,8 +9069,8 @@
         </p:nvSpPr>
         <p:spPr>
           <a:xfrm>
-            <a:off x="8034528" y="5879592"/>
-            <a:ext cx="3678936" cy="182880"/>
+            <a:off x="8022336" y="5779008"/>
+            <a:ext cx="3691128" cy="164592"/>
           </a:xfrm>
           <a:prstGeom prst="rect">
             <a:avLst/>
@@ -8744,8 +9110,8 @@
         </p:nvSpPr>
         <p:spPr>
           <a:xfrm>
-            <a:off x="8034528" y="6053328"/>
-            <a:ext cx="3678936" cy="420624"/>
+            <a:off x="8022336" y="5943600"/>
+            <a:ext cx="3691128" cy="530352"/>
           </a:xfrm>
           <a:prstGeom prst="rect">
             <a:avLst/>
@@ -8772,7 +9138,7 @@
                 <a:latin typeface="WenQuanYi Micro Hei"/>
                 <a:ea typeface="WenQuanYi Micro Hei"/>
               </a:rPr>
-              <a:t>同一版本化数据产品能否跨DataOps、EIAP、NWDAF及第三方后端复用，无需项目级重写。</a:t>
+              <a:t>同一版本化数据产品能否跨DataOps、EIAP、NWDAF及第三方后端复用，无需项目级重写，并在断链、回退与动作回证上满足通信预算。</a:t>
             </a:r>
           </a:p>
         </p:txBody>
@@ -9097,7 +9463,7 @@
         <p:spPr>
           <a:xfrm>
             <a:off x="347472" y="640080"/>
-            <a:ext cx="11475720" cy="420624"/>
+            <a:ext cx="11475720" cy="493776"/>
           </a:xfrm>
           <a:prstGeom prst="roundRect">
             <a:avLst/>
@@ -9131,10 +9497,10 @@
           <a:p>
             <a:pPr algn="l">
               <a:lnSpc>
-                <a:spcPct val="105000"/>
+                <a:spcPct val="104000"/>
               </a:lnSpc>
               <a:spcBef>
-                <a:spcPts val="300"/>
+                <a:spcPts val="200"/>
               </a:spcBef>
               <a:spcAft>
                 <a:spcPts val="100"/>
@@ -9148,7 +9514,7 @@
                 <a:latin typeface="WenQuanYi Micro Hei"/>
                 <a:ea typeface="WenQuanYi Micro Hei"/>
               </a:rPr>
-              <a:t>DO编排拓扑，DA近源处理，DCP异步分发。这首先是6G数据面机制，不能把“补成Fabric”当成唯一终点。</a:t>
+              <a:t>这是一条“先重构执行、再决定治理边界”的路线：DO编排拓扑，DA近源处理，DCP异步分发。它首先是6G数据面机制，能吸收部分发现、编排和交付能力，但不会自动解决跨域语义、QoD、血缘与产品责任。不能把“补成Fabric”当成唯一终点。</a:t>
             </a:r>
           </a:p>
         </p:txBody>
@@ -9161,8 +9527,8 @@
         </p:nvSpPr>
         <p:spPr>
           <a:xfrm>
-            <a:off x="347472" y="1152144"/>
-            <a:ext cx="7059168" cy="4572000"/>
+            <a:off x="347472" y="1188720"/>
+            <a:ext cx="7059168" cy="4462272"/>
           </a:xfrm>
           <a:prstGeom prst="roundRect">
             <a:avLst/>
@@ -9214,8 +9580,8 @@
         </p:blipFill>
         <p:spPr>
           <a:xfrm>
-            <a:off x="855401" y="1243584"/>
-            <a:ext cx="6043308" cy="3246120"/>
+            <a:off x="1085217" y="1243584"/>
+            <a:ext cx="5583676" cy="2999232"/>
           </a:xfrm>
           <a:prstGeom prst="rect">
             <a:avLst/>
@@ -9230,8 +9596,8 @@
         </p:nvSpPr>
         <p:spPr>
           <a:xfrm>
-            <a:off x="855401" y="1243584"/>
-            <a:ext cx="6043308" cy="3246120"/>
+            <a:off x="1085217" y="1243584"/>
+            <a:ext cx="5583676" cy="2999232"/>
           </a:xfrm>
           <a:prstGeom prst="rect">
             <a:avLst/>
@@ -9274,7 +9640,7 @@
         <p:spPr>
           <a:xfrm>
             <a:off x="512064" y="1298448"/>
-            <a:ext cx="1417320" cy="219456"/>
+            <a:ext cx="1417320" cy="201168"/>
           </a:xfrm>
           <a:prstGeom prst="roundRect">
             <a:avLst/>
@@ -9317,7 +9683,7 @@
         <p:spPr>
           <a:xfrm>
             <a:off x="512064" y="1316736"/>
-            <a:ext cx="1417320" cy="201168"/>
+            <a:ext cx="1417320" cy="182880"/>
           </a:xfrm>
           <a:prstGeom prst="rect">
             <a:avLst/>
@@ -9357,8 +9723,8 @@
         </p:nvSpPr>
         <p:spPr>
           <a:xfrm>
-            <a:off x="457200" y="4572000"/>
-            <a:ext cx="2194560" cy="182880"/>
+            <a:off x="457200" y="4315968"/>
+            <a:ext cx="2194560" cy="164592"/>
           </a:xfrm>
           <a:prstGeom prst="rect">
             <a:avLst/>
@@ -9398,8 +9764,8 @@
         </p:nvSpPr>
         <p:spPr>
           <a:xfrm>
-            <a:off x="457200" y="4754880"/>
-            <a:ext cx="2194560" cy="841248"/>
+            <a:off x="457200" y="4480560"/>
+            <a:ext cx="2194560" cy="1060704"/>
           </a:xfrm>
           <a:prstGeom prst="rect">
             <a:avLst/>
@@ -9412,7 +9778,7 @@
           <a:p>
             <a:pPr algn="l">
               <a:lnSpc>
-                <a:spcPct val="104000"/>
+                <a:spcPct val="103000"/>
               </a:lnSpc>
               <a:spcAft>
                 <a:spcPts val="100"/>
@@ -9426,7 +9792,7 @@
                 <a:latin typeface="WenQuanYi Micro Hei"/>
                 <a:ea typeface="WenQuanYi Micro Hei"/>
               </a:rPr>
-              <a:t>能力注册、操作DAG分解、选点与策略下发。登记的是执行能力，不是通用资产目录。</a:t>
+              <a:t>能力注册、操作DAG分解、选点与策略下发。登记的是“谁能执行什么”，不是通用资产目录。</a:t>
             </a:r>
           </a:p>
         </p:txBody>
@@ -9439,8 +9805,8 @@
         </p:nvSpPr>
         <p:spPr>
           <a:xfrm>
-            <a:off x="2743200" y="4572000"/>
-            <a:ext cx="2194560" cy="182880"/>
+            <a:off x="2743200" y="4315968"/>
+            <a:ext cx="2194560" cy="164592"/>
           </a:xfrm>
           <a:prstGeom prst="rect">
             <a:avLst/>
@@ -9480,8 +9846,8 @@
         </p:nvSpPr>
         <p:spPr>
           <a:xfrm>
-            <a:off x="2743200" y="4754880"/>
-            <a:ext cx="2194560" cy="841248"/>
+            <a:off x="2743200" y="4480560"/>
+            <a:ext cx="2194560" cy="1060704"/>
           </a:xfrm>
           <a:prstGeom prst="rect">
             <a:avLst/>
@@ -9494,7 +9860,7 @@
           <a:p>
             <a:pPr algn="l">
               <a:lnSpc>
-                <a:spcPct val="104000"/>
+                <a:spcPct val="103000"/>
               </a:lnSpc>
               <a:spcAft>
                 <a:spcPts val="100"/>
@@ -9508,7 +9874,7 @@
                 <a:latin typeface="WenQuanYi Micro Hei"/>
                 <a:ea typeface="WenQuanYi Micro Hei"/>
               </a:rPr>
-              <a:t>在UE、RAN、边缘和Core近源采集、处理、推理与存储。</a:t>
+              <a:t>在UE、RAN、边缘和Core近源采集、过滤、推理与存储，把计算放到数据所在故障域。</a:t>
             </a:r>
           </a:p>
         </p:txBody>
@@ -9521,8 +9887,8 @@
         </p:nvSpPr>
         <p:spPr>
           <a:xfrm>
-            <a:off x="5029200" y="4572000"/>
-            <a:ext cx="2194560" cy="182880"/>
+            <a:off x="5029200" y="4315968"/>
+            <a:ext cx="2194560" cy="164592"/>
           </a:xfrm>
           <a:prstGeom prst="rect">
             <a:avLst/>
@@ -9562,8 +9928,8 @@
         </p:nvSpPr>
         <p:spPr>
           <a:xfrm>
-            <a:off x="5029200" y="4754880"/>
-            <a:ext cx="2194560" cy="841248"/>
+            <a:off x="5029200" y="4480560"/>
+            <a:ext cx="2194560" cy="1060704"/>
           </a:xfrm>
           <a:prstGeom prst="rect">
             <a:avLst/>
@@ -9576,7 +9942,7 @@
           <a:p>
             <a:pPr algn="l">
               <a:lnSpc>
-                <a:spcPct val="104000"/>
+                <a:spcPct val="103000"/>
               </a:lnSpc>
               <a:spcAft>
                 <a:spcPts val="100"/>
@@ -9590,7 +9956,7 @@
                 <a:latin typeface="WenQuanYi Micro Hei"/>
                 <a:ea typeface="WenQuanYi Micro Hei"/>
               </a:rPr>
-              <a:t>以Pub/Sub解耦生产者和多消费者，服务AI/ISAC扇出。</a:t>
+              <a:t>以Pub/Sub解耦生产者和多消费者，服务AI/ISAC扇出，而不是沿用GTP会话模型。</a:t>
             </a:r>
           </a:p>
         </p:txBody>
@@ -9603,8 +9969,8 @@
         </p:nvSpPr>
         <p:spPr>
           <a:xfrm>
-            <a:off x="7534656" y="1152144"/>
-            <a:ext cx="4306824" cy="1444752"/>
+            <a:off x="7534656" y="1188720"/>
+            <a:ext cx="4306824" cy="1408176"/>
           </a:xfrm>
           <a:prstGeom prst="roundRect">
             <a:avLst/>
@@ -9648,8 +10014,8 @@
         </p:nvSpPr>
         <p:spPr>
           <a:xfrm>
-            <a:off x="7534656" y="1152144"/>
-            <a:ext cx="64008" cy="1444752"/>
+            <a:off x="7534656" y="1188720"/>
+            <a:ext cx="64008" cy="1408176"/>
           </a:xfrm>
           <a:prstGeom prst="rect">
             <a:avLst/>
@@ -9691,8 +10057,8 @@
         </p:nvSpPr>
         <p:spPr>
           <a:xfrm>
-            <a:off x="7680960" y="1216152"/>
-            <a:ext cx="4069080" cy="237744"/>
+            <a:off x="7680960" y="1234440"/>
+            <a:ext cx="4069080" cy="219456"/>
           </a:xfrm>
           <a:prstGeom prst="rect">
             <a:avLst/>
@@ -9733,7 +10099,7 @@
         <p:spPr>
           <a:xfrm>
             <a:off x="7680960" y="1463040"/>
-            <a:ext cx="4069080" cy="1060704"/>
+            <a:ext cx="4069080" cy="1078992"/>
           </a:xfrm>
           <a:prstGeom prst="rect">
             <a:avLst/>
@@ -9746,21 +10112,41 @@
           <a:p>
             <a:pPr algn="l">
               <a:lnSpc>
-                <a:spcPct val="106000"/>
-              </a:lnSpc>
-              <a:spcAft>
-                <a:spcPts val="100"/>
-              </a:spcAft>
-            </a:pPr>
-            <a:r>
-              <a:rPr sz="1050" b="0">
+                <a:spcPct val="104000"/>
+              </a:lnSpc>
+              <a:spcAft>
+                <a:spcPts val="100"/>
+              </a:spcAft>
+            </a:pPr>
+            <a:r>
+              <a:rPr sz="950" b="0">
                 <a:solidFill>
                   <a:srgbClr val="2C3E50"/>
                 </a:solidFill>
                 <a:latin typeface="WenQuanYi Micro Hei"/>
                 <a:ea typeface="WenQuanYi Micro Hei"/>
               </a:rPr>
-              <a:t>服务意图进入DO。DO选择执行能力、生成数据处理拓扑，并下发访问、隐私与资源策略。</a:t>
+              <a:t>服务请求向DO声明采集、过滤、聚合、转换、分析或推理目标。</a:t>
+            </a:r>
+          </a:p>
+          <a:p>
+            <a:pPr algn="l">
+              <a:lnSpc>
+                <a:spcPct val="104000"/>
+              </a:lnSpc>
+              <a:spcAft>
+                <a:spcPts val="100"/>
+              </a:spcAft>
+            </a:pPr>
+            <a:r>
+              <a:rPr sz="950" b="0">
+                <a:solidFill>
+                  <a:srgbClr val="2C3E50"/>
+                </a:solidFill>
+                <a:latin typeface="WenQuanYi Micro Hei"/>
+                <a:ea typeface="WenQuanYi Micro Hei"/>
+              </a:rPr>
+              <a:t>DO从能力注册中选择执行节点，拆解操作DAG，并下发拓扑、访问、隐私与资源策略。</a:t>
             </a:r>
           </a:p>
         </p:txBody>
@@ -9773,8 +10159,8 @@
         </p:nvSpPr>
         <p:spPr>
           <a:xfrm>
-            <a:off x="7534656" y="2706624"/>
-            <a:ext cx="4306824" cy="1444752"/>
+            <a:off x="7534656" y="2688336"/>
+            <a:ext cx="4306824" cy="1408176"/>
           </a:xfrm>
           <a:prstGeom prst="roundRect">
             <a:avLst/>
@@ -9818,8 +10204,8 @@
         </p:nvSpPr>
         <p:spPr>
           <a:xfrm>
-            <a:off x="7534656" y="2706624"/>
-            <a:ext cx="64008" cy="1444752"/>
+            <a:off x="7534656" y="2688336"/>
+            <a:ext cx="64008" cy="1408176"/>
           </a:xfrm>
           <a:prstGeom prst="rect">
             <a:avLst/>
@@ -9861,8 +10247,8 @@
         </p:nvSpPr>
         <p:spPr>
           <a:xfrm>
-            <a:off x="7680960" y="2770632"/>
-            <a:ext cx="4069080" cy="237744"/>
+            <a:off x="7680960" y="2734056"/>
+            <a:ext cx="4069080" cy="219456"/>
           </a:xfrm>
           <a:prstGeom prst="rect">
             <a:avLst/>
@@ -9902,8 +10288,8 @@
         </p:nvSpPr>
         <p:spPr>
           <a:xfrm>
-            <a:off x="7680960" y="3017520"/>
-            <a:ext cx="4069080" cy="1060704"/>
+            <a:off x="7680960" y="2962656"/>
+            <a:ext cx="4069080" cy="1078992"/>
           </a:xfrm>
           <a:prstGeom prst="rect">
             <a:avLst/>
@@ -9916,21 +10302,41 @@
           <a:p>
             <a:pPr algn="l">
               <a:lnSpc>
-                <a:spcPct val="106000"/>
-              </a:lnSpc>
-              <a:spcAft>
-                <a:spcPts val="100"/>
-              </a:spcAft>
-            </a:pPr>
-            <a:r>
-              <a:rPr sz="1050" b="0">
+                <a:spcPct val="104000"/>
+              </a:lnSpc>
+              <a:spcAft>
+                <a:spcPts val="100"/>
+              </a:spcAft>
+            </a:pPr>
+            <a:r>
+              <a:rPr sz="950" b="0">
                 <a:solidFill>
                   <a:srgbClr val="2C3E50"/>
                 </a:solidFill>
                 <a:latin typeface="WenQuanYi Micro Hei"/>
                 <a:ea typeface="WenQuanYi Micro Hei"/>
               </a:rPr>
-              <a:t>源DA发布数据，DCP异步分发；DA/DPF沿途过滤、压缩、特征化和推理，上游模型输出可成为下游输入。</a:t>
+              <a:t>源DA发布topic，DCP按订阅或带内拓扑把数据异步送往多个处理/消费节点。</a:t>
+            </a:r>
+          </a:p>
+          <a:p>
+            <a:pPr algn="l">
+              <a:lnSpc>
+                <a:spcPct val="104000"/>
+              </a:lnSpc>
+              <a:spcAft>
+                <a:spcPts val="100"/>
+              </a:spcAft>
+            </a:pPr>
+            <a:r>
+              <a:rPr sz="950" b="0">
+                <a:solidFill>
+                  <a:srgbClr val="2C3E50"/>
+                </a:solidFill>
+                <a:latin typeface="WenQuanYi Micro Hei"/>
+                <a:ea typeface="WenQuanYi Micro Hei"/>
+              </a:rPr>
+              <a:t>DA/DPF沿途过滤、压缩、特征化和本地推理，上游模型输出还可成为下游输入。</a:t>
             </a:r>
           </a:p>
         </p:txBody>
@@ -9943,7 +10349,7 @@
         </p:nvSpPr>
         <p:spPr>
           <a:xfrm>
-            <a:off x="7534656" y="4261104"/>
+            <a:off x="7534656" y="4187952"/>
             <a:ext cx="4306824" cy="1463040"/>
           </a:xfrm>
           <a:prstGeom prst="roundRect">
@@ -9988,7 +10394,7 @@
         </p:nvSpPr>
         <p:spPr>
           <a:xfrm>
-            <a:off x="7534656" y="4261104"/>
+            <a:off x="7534656" y="4187952"/>
             <a:ext cx="64008" cy="1463040"/>
           </a:xfrm>
           <a:prstGeom prst="rect">
@@ -10031,8 +10437,8 @@
         </p:nvSpPr>
         <p:spPr>
           <a:xfrm>
-            <a:off x="7680960" y="4325112"/>
-            <a:ext cx="4069080" cy="237744"/>
+            <a:off x="7680960" y="4233672"/>
+            <a:ext cx="4069080" cy="219456"/>
           </a:xfrm>
           <a:prstGeom prst="rect">
             <a:avLst/>
@@ -10072,8 +10478,8 @@
         </p:nvSpPr>
         <p:spPr>
           <a:xfrm>
-            <a:off x="7680960" y="4572000"/>
-            <a:ext cx="4069080" cy="1078992"/>
+            <a:off x="7680960" y="4462272"/>
+            <a:ext cx="4069080" cy="1133856"/>
           </a:xfrm>
           <a:prstGeom prst="rect">
             <a:avLst/>
@@ -10086,21 +10492,41 @@
           <a:p>
             <a:pPr algn="l">
               <a:lnSpc>
-                <a:spcPct val="106000"/>
-              </a:lnSpc>
-              <a:spcAft>
-                <a:spcPts val="100"/>
-              </a:spcAft>
-            </a:pPr>
-            <a:r>
-              <a:rPr sz="1000" b="0">
+                <a:spcPct val="104000"/>
+              </a:lnSpc>
+              <a:spcAft>
+                <a:spcPts val="100"/>
+              </a:spcAft>
+            </a:pPr>
+            <a:r>
+              <a:rPr sz="950" b="0">
                 <a:solidFill>
                   <a:srgbClr val="2C3E50"/>
                 </a:solidFill>
                 <a:latin typeface="WenQuanYi Micro Hei"/>
                 <a:ea typeface="WenQuanYi Micro Hei"/>
               </a:rPr>
-              <a:t>AI/ISAC的多源、多处理、多汇和派生数据链，不完全适配围绕控制消息与连接设计的CP/UP。AUTINOps不是DCP商用证明。</a:t>
+              <a:t>SBI偏控制消息，PDU会话围绕连接；AI/ISAC需要多源、多处理、多汇和派生数据链。</a:t>
+            </a:r>
+          </a:p>
+          <a:p>
+            <a:pPr algn="l">
+              <a:lnSpc>
+                <a:spcPct val="104000"/>
+              </a:lnSpc>
+              <a:spcAft>
+                <a:spcPts val="100"/>
+              </a:spcAft>
+            </a:pPr>
+            <a:r>
+              <a:rPr sz="950" b="0">
+                <a:solidFill>
+                  <a:srgbClr val="2C3E50"/>
+                </a:solidFill>
+                <a:latin typeface="WenQuanYi Micro Hei"/>
+                <a:ea typeface="WenQuanYi Micro Hei"/>
+              </a:rPr>
+              <a:t>跨域语义与产品契约可能被网络原生吸收，也可能由管理域补充。AUTINOps不是DCP商用证明。</a:t>
             </a:r>
           </a:p>
         </p:txBody>
@@ -10113,8 +10539,8 @@
         </p:nvSpPr>
         <p:spPr>
           <a:xfrm>
-            <a:off x="347472" y="5833872"/>
-            <a:ext cx="11475720" cy="694944"/>
+            <a:off x="347472" y="5742432"/>
+            <a:ext cx="11475720" cy="786384"/>
           </a:xfrm>
           <a:prstGeom prst="roundRect">
             <a:avLst/>
@@ -10158,8 +10584,8 @@
         </p:nvSpPr>
         <p:spPr>
           <a:xfrm>
-            <a:off x="457200" y="5879592"/>
-            <a:ext cx="3678936" cy="182880"/>
+            <a:off x="457200" y="5779008"/>
+            <a:ext cx="3691128" cy="164592"/>
           </a:xfrm>
           <a:prstGeom prst="rect">
             <a:avLst/>
@@ -10199,8 +10625,8 @@
         </p:nvSpPr>
         <p:spPr>
           <a:xfrm>
-            <a:off x="457200" y="6053328"/>
-            <a:ext cx="3678936" cy="420624"/>
+            <a:off x="457200" y="5943600"/>
+            <a:ext cx="3691128" cy="530352"/>
           </a:xfrm>
           <a:prstGeom prst="rect">
             <a:avLst/>
@@ -10227,7 +10653,7 @@
                 <a:latin typeface="WenQuanYi Micro Hei"/>
                 <a:ea typeface="WenQuanYi Micro Hei"/>
               </a:rPr>
-              <a:t>DCP公开实验约2ms；10 broker、128KB消息约2,394.6MB/s。</a:t>
+              <a:t>DCP公开实验约2ms；10 broker、128KB消息约2,394.6MB/s，说明精简路径与横向吞吐具有潜力，仍属研究原型。</a:t>
             </a:r>
           </a:p>
         </p:txBody>
@@ -10240,8 +10666,8 @@
         </p:nvSpPr>
         <p:spPr>
           <a:xfrm>
-            <a:off x="4245864" y="5879592"/>
-            <a:ext cx="3678936" cy="182880"/>
+            <a:off x="4239768" y="5779008"/>
+            <a:ext cx="3691128" cy="164592"/>
           </a:xfrm>
           <a:prstGeom prst="rect">
             <a:avLst/>
@@ -10281,8 +10707,8 @@
         </p:nvSpPr>
         <p:spPr>
           <a:xfrm>
-            <a:off x="4245864" y="6053328"/>
-            <a:ext cx="3678936" cy="420624"/>
+            <a:off x="4239768" y="5943600"/>
+            <a:ext cx="3691128" cy="530352"/>
           </a:xfrm>
           <a:prstGeom prst="rect">
             <a:avLst/>
@@ -10309,7 +10735,7 @@
                 <a:latin typeface="WenQuanYi Micro Hei"/>
                 <a:ea typeface="WenQuanYi Micro Hei"/>
               </a:rPr>
-              <a:t>DCP移除持久化，RocketMQ对照开启持久化，不能外推为同功能全面领先。</a:t>
+              <a:t>DCP移除持久化，而RocketMQ对照开启持久化；结果不能外推为同功能全面领先，也没有证明长期可靠性。</a:t>
             </a:r>
           </a:p>
         </p:txBody>
@@ -10322,8 +10748,8 @@
         </p:nvSpPr>
         <p:spPr>
           <a:xfrm>
-            <a:off x="8034528" y="5879592"/>
-            <a:ext cx="3678936" cy="182880"/>
+            <a:off x="8022336" y="5779008"/>
+            <a:ext cx="3691128" cy="164592"/>
           </a:xfrm>
           <a:prstGeom prst="rect">
             <a:avLst/>
@@ -10363,8 +10789,8 @@
         </p:nvSpPr>
         <p:spPr>
           <a:xfrm>
-            <a:off x="8034528" y="6053328"/>
-            <a:ext cx="3678936" cy="420624"/>
+            <a:off x="8022336" y="5943600"/>
+            <a:ext cx="3691128" cy="530352"/>
           </a:xfrm>
           <a:prstGeom prst="rect">
             <a:avLst/>
@@ -10391,7 +10817,7 @@
                 <a:latin typeface="WenQuanYi Micro Hei"/>
                 <a:ea typeface="WenQuanYi Micro Hei"/>
               </a:rPr>
-              <a:t>同等持久化条件下的跨站故障、移动性、断链回退、多租户SLA和第三方算子。</a:t>
+              <a:t>同等持久化条件下的跨站故障、移动性、断链回退、多租户SLA和第三方算子测试。增强SBA/UP若已够用，新增平面必要性下降。</a:t>
             </a:r>
           </a:p>
         </p:txBody>
@@ -10716,7 +11142,7 @@
         <p:spPr>
           <a:xfrm>
             <a:off x="347472" y="640080"/>
-            <a:ext cx="11475720" cy="420624"/>
+            <a:ext cx="11475720" cy="493776"/>
           </a:xfrm>
           <a:prstGeom prst="roundRect">
             <a:avLst/>
@@ -10750,10 +11176,10 @@
           <a:p>
             <a:pPr algn="l">
               <a:lnSpc>
-                <a:spcPct val="105000"/>
+                <a:spcPct val="104000"/>
               </a:lnSpc>
               <a:spcBef>
-                <a:spcPts val="300"/>
+                <a:spcPts val="200"/>
               </a:spcBef>
               <a:spcAft>
                 <a:spcPts val="100"/>
@@ -10767,7 +11193,7 @@
                 <a:latin typeface="WenQuanYi Micro Hei"/>
                 <a:ea typeface="WenQuanYi Micro Hei"/>
               </a:rPr>
-              <a:t>Data Suite是数据管理层，AN Fabric是智能消费层；动作仍回OSS/RIC/SON，数据默认留域。两套Fabric不是同一层。</a:t>
+              <a:t>这是一条“先产品化能力、再验证统一控制”的路线。Data Suite是数据管理层，AN Fabric是智能消费层；动作仍回OSS/RIC/SON，数据默认留域。两套Fabric不是同一层。真正的竞争问题是它们能否共享契约并贯通到动作证据。</a:t>
             </a:r>
           </a:p>
         </p:txBody>
@@ -10780,8 +11206,8 @@
         </p:nvSpPr>
         <p:spPr>
           <a:xfrm>
-            <a:off x="347472" y="1152144"/>
-            <a:ext cx="7059168" cy="4572000"/>
+            <a:off x="347472" y="1188720"/>
+            <a:ext cx="7059168" cy="4462272"/>
           </a:xfrm>
           <a:prstGeom prst="roundRect">
             <a:avLst/>
@@ -10825,8 +11251,8 @@
         </p:nvSpPr>
         <p:spPr>
           <a:xfrm>
-            <a:off x="475488" y="1207008"/>
-            <a:ext cx="4160520" cy="201168"/>
+            <a:off x="475488" y="1225296"/>
+            <a:ext cx="4160520" cy="164592"/>
           </a:xfrm>
           <a:prstGeom prst="rect">
             <a:avLst/>
@@ -10846,7 +11272,7 @@
               </a:spcAft>
             </a:pPr>
             <a:r>
-              <a:rPr sz="900" b="1">
+              <a:rPr sz="850" b="1">
                 <a:solidFill>
                   <a:srgbClr val="0E7C7B"/>
                 </a:solidFill>
@@ -10866,7 +11292,7 @@
         </p:nvSpPr>
         <p:spPr>
           <a:xfrm>
-            <a:off x="475488" y="1426464"/>
+            <a:off x="475488" y="1408176"/>
             <a:ext cx="4160520" cy="658368"/>
           </a:xfrm>
           <a:prstGeom prst="roundRect">
@@ -10909,8 +11335,8 @@
         </p:nvSpPr>
         <p:spPr>
           <a:xfrm>
-            <a:off x="603504" y="1481328"/>
-            <a:ext cx="3904487" cy="256032"/>
+            <a:off x="603504" y="1453896"/>
+            <a:ext cx="3904487" cy="237744"/>
           </a:xfrm>
           <a:prstGeom prst="rect">
             <a:avLst/>
@@ -10930,7 +11356,7 @@
               </a:spcAft>
             </a:pPr>
             <a:r>
-              <a:rPr sz="1200" b="1">
+              <a:rPr sz="1100" b="1">
                 <a:solidFill>
                   <a:srgbClr val="FFFFFF"/>
                 </a:solidFill>
@@ -10950,8 +11376,8 @@
         </p:nvSpPr>
         <p:spPr>
           <a:xfrm>
-            <a:off x="603504" y="1737360"/>
-            <a:ext cx="3904487" cy="274320"/>
+            <a:off x="603504" y="1700784"/>
+            <a:ext cx="3904487" cy="310896"/>
           </a:xfrm>
           <a:prstGeom prst="rect">
             <a:avLst/>
@@ -10971,14 +11397,14 @@
               </a:spcAft>
             </a:pPr>
             <a:r>
-              <a:rPr sz="950" b="0">
+              <a:rPr sz="900" b="0">
                 <a:solidFill>
                   <a:srgbClr val="FFFFFF"/>
                 </a:solidFill>
                 <a:latin typeface="WenQuanYi Micro Hei"/>
                 <a:ea typeface="WenQuanYi Micro Hei"/>
               </a:rPr>
-              <a:t>Domain lakehouse  ·  本地权威事实</a:t>
+              <a:t>Domain lakehouse  ·  各域本地采集、加工与存储</a:t>
             </a:r>
           </a:p>
         </p:txBody>
@@ -10991,8 +11417,8 @@
         </p:nvSpPr>
         <p:spPr>
           <a:xfrm>
-            <a:off x="2395728" y="2066543"/>
-            <a:ext cx="201168" cy="146304"/>
+            <a:off x="2395728" y="2048256"/>
+            <a:ext cx="201168" cy="128016"/>
           </a:xfrm>
           <a:prstGeom prst="downArrow">
             <a:avLst/>
@@ -11034,7 +11460,7 @@
         </p:nvSpPr>
         <p:spPr>
           <a:xfrm>
-            <a:off x="475488" y="2231136"/>
+            <a:off x="475488" y="2194560"/>
             <a:ext cx="4160520" cy="658368"/>
           </a:xfrm>
           <a:prstGeom prst="roundRect">
@@ -11077,8 +11503,8 @@
         </p:nvSpPr>
         <p:spPr>
           <a:xfrm>
-            <a:off x="603504" y="2286000"/>
-            <a:ext cx="3904487" cy="256032"/>
+            <a:off x="603504" y="2240279"/>
+            <a:ext cx="3904487" cy="237744"/>
           </a:xfrm>
           <a:prstGeom prst="rect">
             <a:avLst/>
@@ -11098,7 +11524,7 @@
               </a:spcAft>
             </a:pPr>
             <a:r>
-              <a:rPr sz="1200" b="1">
+              <a:rPr sz="1100" b="1">
                 <a:solidFill>
                   <a:srgbClr val="FFFFFF"/>
                 </a:solidFill>
@@ -11118,8 +11544,8 @@
         </p:nvSpPr>
         <p:spPr>
           <a:xfrm>
-            <a:off x="603504" y="2542032"/>
-            <a:ext cx="3904487" cy="274320"/>
+            <a:off x="603504" y="2487168"/>
+            <a:ext cx="3904487" cy="310896"/>
           </a:xfrm>
           <a:prstGeom prst="rect">
             <a:avLst/>
@@ -11139,14 +11565,14 @@
               </a:spcAft>
             </a:pPr>
             <a:r>
-              <a:rPr sz="950" b="0">
+              <a:rPr sz="900" b="0">
                 <a:solidFill>
                   <a:srgbClr val="FFFFFF"/>
                 </a:solidFill>
                 <a:latin typeface="WenQuanYi Micro Hei"/>
                 <a:ea typeface="WenQuanYi Micro Hei"/>
               </a:rPr>
-              <a:t>适配  ·  抽象  ·  联邦访问，而非强制集中</a:t>
+              <a:t>适配、抽象和联邦访问，提供逻辑视图而非强制集中</a:t>
             </a:r>
           </a:p>
         </p:txBody>
@@ -11159,8 +11585,8 @@
         </p:nvSpPr>
         <p:spPr>
           <a:xfrm>
-            <a:off x="2395728" y="2871215"/>
-            <a:ext cx="201168" cy="146304"/>
+            <a:off x="2395728" y="2834639"/>
+            <a:ext cx="201168" cy="128016"/>
           </a:xfrm>
           <a:prstGeom prst="downArrow">
             <a:avLst/>
@@ -11202,7 +11628,7 @@
         </p:nvSpPr>
         <p:spPr>
           <a:xfrm>
-            <a:off x="475488" y="3035808"/>
+            <a:off x="475488" y="2980944"/>
             <a:ext cx="4160520" cy="658368"/>
           </a:xfrm>
           <a:prstGeom prst="roundRect">
@@ -11245,8 +11671,8 @@
         </p:nvSpPr>
         <p:spPr>
           <a:xfrm>
-            <a:off x="603504" y="3090672"/>
-            <a:ext cx="3904487" cy="256032"/>
+            <a:off x="603504" y="3026663"/>
+            <a:ext cx="3904487" cy="237744"/>
           </a:xfrm>
           <a:prstGeom prst="rect">
             <a:avLst/>
@@ -11266,7 +11692,7 @@
               </a:spcAft>
             </a:pPr>
             <a:r>
-              <a:rPr sz="1200" b="1">
+              <a:rPr sz="1100" b="1">
                 <a:solidFill>
                   <a:srgbClr val="FFFFFF"/>
                 </a:solidFill>
@@ -11286,8 +11712,8 @@
         </p:nvSpPr>
         <p:spPr>
           <a:xfrm>
-            <a:off x="603504" y="3346704"/>
-            <a:ext cx="3904487" cy="274320"/>
+            <a:off x="603504" y="3273551"/>
+            <a:ext cx="3904487" cy="310896"/>
           </a:xfrm>
           <a:prstGeom prst="rect">
             <a:avLst/>
@@ -11307,14 +11733,14 @@
               </a:spcAft>
             </a:pPr>
             <a:r>
-              <a:rPr sz="950" b="0">
+              <a:rPr sz="900" b="0">
                 <a:solidFill>
                   <a:srgbClr val="FFFFFF"/>
                 </a:solidFill>
                 <a:latin typeface="WenQuanYi Micro Hei"/>
                 <a:ea typeface="WenQuanYi Micro Hei"/>
               </a:rPr>
-              <a:t>语义  ·  QoD  ·  血缘  ·  数据产品</a:t>
+              <a:t>目录、语义、QoD、血缘和数据产品，与治理最直接重合</a:t>
             </a:r>
           </a:p>
         </p:txBody>
@@ -11327,8 +11753,8 @@
         </p:nvSpPr>
         <p:spPr>
           <a:xfrm>
-            <a:off x="2395728" y="3675888"/>
-            <a:ext cx="201168" cy="146304"/>
+            <a:off x="2395728" y="3621024"/>
+            <a:ext cx="201168" cy="128016"/>
           </a:xfrm>
           <a:prstGeom prst="downArrow">
             <a:avLst/>
@@ -11370,7 +11796,7 @@
         </p:nvSpPr>
         <p:spPr>
           <a:xfrm>
-            <a:off x="475488" y="3840480"/>
+            <a:off x="475488" y="3767328"/>
             <a:ext cx="4160520" cy="658368"/>
           </a:xfrm>
           <a:prstGeom prst="roundRect">
@@ -11413,8 +11839,8 @@
         </p:nvSpPr>
         <p:spPr>
           <a:xfrm>
-            <a:off x="603504" y="3895344"/>
-            <a:ext cx="3904487" cy="256032"/>
+            <a:off x="603504" y="3813048"/>
+            <a:ext cx="3904487" cy="237744"/>
           </a:xfrm>
           <a:prstGeom prst="rect">
             <a:avLst/>
@@ -11434,7 +11860,7 @@
               </a:spcAft>
             </a:pPr>
             <a:r>
-              <a:rPr sz="1200" b="1">
+              <a:rPr sz="1100" b="1">
                 <a:solidFill>
                   <a:srgbClr val="FFFFFF"/>
                 </a:solidFill>
@@ -11454,8 +11880,8 @@
         </p:nvSpPr>
         <p:spPr>
           <a:xfrm>
-            <a:off x="603504" y="4151376"/>
-            <a:ext cx="3904487" cy="274320"/>
+            <a:off x="603504" y="4059936"/>
+            <a:ext cx="3904487" cy="310896"/>
           </a:xfrm>
           <a:prstGeom prst="rect">
             <a:avLst/>
@@ -11475,14 +11901,14 @@
               </a:spcAft>
             </a:pPr>
             <a:r>
-              <a:rPr sz="950" b="0">
+              <a:rPr sz="900" b="0">
                 <a:solidFill>
                   <a:srgbClr val="FFFFFF"/>
                 </a:solidFill>
                 <a:latin typeface="WenQuanYi Micro Hei"/>
                 <a:ea typeface="WenQuanYi Micro Hei"/>
               </a:rPr>
-              <a:t>Sense  ·  Think  ·  Act  智能消费层</a:t>
+              <a:t>Sense–Think–Act 智能消费与编排，不是数据管理Fabric</a:t>
             </a:r>
           </a:p>
         </p:txBody>
@@ -11495,8 +11921,8 @@
         </p:nvSpPr>
         <p:spPr>
           <a:xfrm>
-            <a:off x="2395728" y="4480560"/>
-            <a:ext cx="201168" cy="146304"/>
+            <a:off x="2395728" y="4407408"/>
+            <a:ext cx="201168" cy="128016"/>
           </a:xfrm>
           <a:prstGeom prst="downArrow">
             <a:avLst/>
@@ -11538,7 +11964,7 @@
         </p:nvSpPr>
         <p:spPr>
           <a:xfrm>
-            <a:off x="475488" y="4645152"/>
+            <a:off x="475488" y="4553712"/>
             <a:ext cx="4160520" cy="658368"/>
           </a:xfrm>
           <a:prstGeom prst="roundRect">
@@ -11581,8 +12007,8 @@
         </p:nvSpPr>
         <p:spPr>
           <a:xfrm>
-            <a:off x="603504" y="4700016"/>
-            <a:ext cx="3904487" cy="256032"/>
+            <a:off x="603504" y="4599432"/>
+            <a:ext cx="3904487" cy="237744"/>
           </a:xfrm>
           <a:prstGeom prst="rect">
             <a:avLst/>
@@ -11602,7 +12028,7 @@
               </a:spcAft>
             </a:pPr>
             <a:r>
-              <a:rPr sz="1200" b="1">
+              <a:rPr sz="1100" b="1">
                 <a:solidFill>
                   <a:srgbClr val="FFFFFF"/>
                 </a:solidFill>
@@ -11622,8 +12048,8 @@
         </p:nvSpPr>
         <p:spPr>
           <a:xfrm>
-            <a:off x="603504" y="4956048"/>
-            <a:ext cx="3904487" cy="274320"/>
+            <a:off x="603504" y="4846320"/>
+            <a:ext cx="3904487" cy="310896"/>
           </a:xfrm>
           <a:prstGeom prst="rect">
             <a:avLst/>
@@ -11643,14 +12069,14 @@
               </a:spcAft>
             </a:pPr>
             <a:r>
-              <a:rPr sz="950" b="0">
+              <a:rPr sz="900" b="0">
                 <a:solidFill>
                   <a:srgbClr val="FFFFFF"/>
                 </a:solidFill>
                 <a:latin typeface="WenQuanYi Micro Hei"/>
                 <a:ea typeface="WenQuanYi Micro Hei"/>
               </a:rPr>
-              <a:t>OSS / RIC / SON 动作  ·  商业外延</a:t>
+              <a:t>高风险动作回OSS/RIC/SON，再向计量和渠道外延</a:t>
             </a:r>
           </a:p>
         </p:txBody>
@@ -11671,7 +12097,7 @@
         </p:blipFill>
         <p:spPr>
           <a:xfrm>
-            <a:off x="4754880" y="1662654"/>
+            <a:off x="4754880" y="1584930"/>
             <a:ext cx="2487168" cy="1859339"/>
           </a:xfrm>
           <a:prstGeom prst="rect">
@@ -11687,7 +12113,7 @@
         </p:nvSpPr>
         <p:spPr>
           <a:xfrm>
-            <a:off x="4754880" y="1662654"/>
+            <a:off x="4754880" y="1584930"/>
             <a:ext cx="2487168" cy="1859339"/>
           </a:xfrm>
           <a:prstGeom prst="rect">
@@ -11730,8 +12156,8 @@
         </p:nvSpPr>
         <p:spPr>
           <a:xfrm>
-            <a:off x="4809744" y="1481328"/>
-            <a:ext cx="2011680" cy="201168"/>
+            <a:off x="4809744" y="1463040"/>
+            <a:ext cx="2011680" cy="182880"/>
           </a:xfrm>
           <a:prstGeom prst="roundRect">
             <a:avLst/>
@@ -11773,8 +12199,8 @@
         </p:nvSpPr>
         <p:spPr>
           <a:xfrm>
-            <a:off x="4809744" y="1499616"/>
-            <a:ext cx="2011680" cy="182880"/>
+            <a:off x="4809744" y="1481328"/>
+            <a:ext cx="2011680" cy="164592"/>
           </a:xfrm>
           <a:prstGeom prst="rect">
             <a:avLst/>
@@ -11814,8 +12240,8 @@
         </p:nvSpPr>
         <p:spPr>
           <a:xfrm>
-            <a:off x="4754880" y="3840480"/>
-            <a:ext cx="2487168" cy="1737360"/>
+            <a:off x="4754880" y="3694176"/>
+            <a:ext cx="2487168" cy="1865376"/>
           </a:xfrm>
           <a:prstGeom prst="rect">
             <a:avLst/>
@@ -11828,61 +12254,61 @@
           <a:p>
             <a:pPr algn="l">
               <a:lnSpc>
-                <a:spcPct val="110000"/>
-              </a:lnSpc>
-              <a:spcAft>
-                <a:spcPts val="100"/>
-              </a:spcAft>
-            </a:pPr>
-            <a:r>
-              <a:rPr sz="950" b="0">
+                <a:spcPct val="106000"/>
+              </a:lnSpc>
+              <a:spcAft>
+                <a:spcPts val="100"/>
+              </a:spcAft>
+            </a:pPr>
+            <a:r>
+              <a:rPr sz="900" b="0">
                 <a:solidFill>
                   <a:srgbClr val="2C3E50"/>
                 </a:solidFill>
                 <a:latin typeface="WenQuanYi Micro Hei"/>
                 <a:ea typeface="WenQuanYi Micro Hei"/>
               </a:rPr>
-              <a:t>官方AN Fabric图只证明Sense–Think–Act智能层。</a:t>
+              <a:t>官方AN Fabric图只证明Sense–Think–Act智能层和Marketplace外延。</a:t>
             </a:r>
           </a:p>
           <a:p>
             <a:pPr algn="l">
               <a:lnSpc>
-                <a:spcPct val="110000"/>
-              </a:lnSpc>
-              <a:spcAft>
-                <a:spcPts val="100"/>
-              </a:spcAft>
-            </a:pPr>
-            <a:r>
-              <a:rPr sz="950" b="0">
+                <a:spcPct val="106000"/>
+              </a:lnSpc>
+              <a:spcAft>
+                <a:spcPts val="100"/>
+              </a:spcAft>
+            </a:pPr>
+            <a:r>
+              <a:rPr sz="900" b="0">
                 <a:solidFill>
                   <a:srgbClr val="2C3E50"/>
                 </a:solidFill>
                 <a:latin typeface="WenQuanYi Micro Hei"/>
                 <a:ea typeface="WenQuanYi Micro Hei"/>
               </a:rPr>
-              <a:t>Data Suite、域数据底座和公共湖仓不在这张图里，必须靠左侧自绘链路补齐。</a:t>
+              <a:t>Data Suite、域数据底座和公共湖仓不在这张图里，必须靠左侧自绘链路补齐，否则会把两套Fabric读成同一层。</a:t>
             </a:r>
           </a:p>
           <a:p>
             <a:pPr algn="l">
               <a:lnSpc>
-                <a:spcPct val="110000"/>
-              </a:lnSpc>
-              <a:spcAft>
-                <a:spcPts val="100"/>
-              </a:spcAft>
-            </a:pPr>
-            <a:r>
-              <a:rPr sz="950" b="0">
+                <a:spcPct val="106000"/>
+              </a:lnSpc>
+              <a:spcAft>
+                <a:spcPts val="100"/>
+              </a:spcAft>
+            </a:pPr>
+            <a:r>
+              <a:rPr sz="900" b="0">
                 <a:solidFill>
                   <a:srgbClr val="2C3E50"/>
                 </a:solidFill>
                 <a:latin typeface="WenQuanYi Micro Hei"/>
                 <a:ea typeface="WenQuanYi Micro Hei"/>
               </a:rPr>
-              <a:t>高风险动作仍经AN Apps回到域控制器。</a:t>
+              <a:t>高风险动作仍经AN Apps回到域控制器；公共层偏Non-RT，不能替代RAN快环。</a:t>
             </a:r>
           </a:p>
         </p:txBody>
@@ -11895,8 +12321,8 @@
         </p:nvSpPr>
         <p:spPr>
           <a:xfrm>
-            <a:off x="7534656" y="1152144"/>
-            <a:ext cx="4306824" cy="1444752"/>
+            <a:off x="7534656" y="1188720"/>
+            <a:ext cx="4306824" cy="1408176"/>
           </a:xfrm>
           <a:prstGeom prst="roundRect">
             <a:avLst/>
@@ -11940,8 +12366,8 @@
         </p:nvSpPr>
         <p:spPr>
           <a:xfrm>
-            <a:off x="7534656" y="1152144"/>
-            <a:ext cx="64008" cy="1444752"/>
+            <a:off x="7534656" y="1188720"/>
+            <a:ext cx="64008" cy="1408176"/>
           </a:xfrm>
           <a:prstGeom prst="rect">
             <a:avLst/>
@@ -11983,8 +12409,8 @@
         </p:nvSpPr>
         <p:spPr>
           <a:xfrm>
-            <a:off x="7680960" y="1216152"/>
-            <a:ext cx="4069080" cy="237744"/>
+            <a:off x="7680960" y="1234440"/>
+            <a:ext cx="4069080" cy="219456"/>
           </a:xfrm>
           <a:prstGeom prst="rect">
             <a:avLst/>
@@ -12025,7 +12451,7 @@
         <p:spPr>
           <a:xfrm>
             <a:off x="7680960" y="1463040"/>
-            <a:ext cx="4069080" cy="1060704"/>
+            <a:ext cx="4069080" cy="1078992"/>
           </a:xfrm>
           <a:prstGeom prst="rect">
             <a:avLst/>
@@ -12038,21 +12464,41 @@
           <a:p>
             <a:pPr algn="l">
               <a:lnSpc>
-                <a:spcPct val="106000"/>
-              </a:lnSpc>
-              <a:spcAft>
-                <a:spcPts val="100"/>
-              </a:spcAft>
-            </a:pPr>
-            <a:r>
-              <a:rPr sz="1000" b="0">
+                <a:spcPct val="104000"/>
+              </a:lnSpc>
+              <a:spcAft>
+                <a:spcPts val="100"/>
+              </a:spcAft>
+            </a:pPr>
+            <a:r>
+              <a:rPr sz="950" b="0">
                 <a:solidFill>
                   <a:srgbClr val="2C3E50"/>
                 </a:solidFill>
                 <a:latin typeface="WenQuanYi Micro Hei"/>
                 <a:ea typeface="WenQuanYi Micro Hei"/>
               </a:rPr>
-              <a:t>Data Suite管目录、语义、质量、血缘和产品；AN Fabric管智能消费与编排。数据默认留域，公共层只做适配、抽象和联邦访问。</a:t>
+              <a:t>Data Suite管目录、语义、质量、血缘和产品；AN Fabric管智能消费与编排。</a:t>
+            </a:r>
+          </a:p>
+          <a:p>
+            <a:pPr algn="l">
+              <a:lnSpc>
+                <a:spcPct val="104000"/>
+              </a:lnSpc>
+              <a:spcAft>
+                <a:spcPts val="100"/>
+              </a:spcAft>
+            </a:pPr>
+            <a:r>
+              <a:rPr sz="950" b="0">
+                <a:solidFill>
+                  <a:srgbClr val="2C3E50"/>
+                </a:solidFill>
+                <a:latin typeface="WenQuanYi Micro Hei"/>
+                <a:ea typeface="WenQuanYi Micro Hei"/>
+              </a:rPr>
+              <a:t>数据默认留域，公共层只做适配、抽象和联邦访问。支持多厂商只有经过第三方互操作和双向迁移，才构成中立性证据。</a:t>
             </a:r>
           </a:p>
         </p:txBody>
@@ -12065,8 +12511,8 @@
         </p:nvSpPr>
         <p:spPr>
           <a:xfrm>
-            <a:off x="7534656" y="2706624"/>
-            <a:ext cx="4306824" cy="1444752"/>
+            <a:off x="7534656" y="2688336"/>
+            <a:ext cx="4306824" cy="1408176"/>
           </a:xfrm>
           <a:prstGeom prst="roundRect">
             <a:avLst/>
@@ -12110,8 +12556,8 @@
         </p:nvSpPr>
         <p:spPr>
           <a:xfrm>
-            <a:off x="7534656" y="2706624"/>
-            <a:ext cx="64008" cy="1444752"/>
+            <a:off x="7534656" y="2688336"/>
+            <a:ext cx="64008" cy="1408176"/>
           </a:xfrm>
           <a:prstGeom prst="rect">
             <a:avLst/>
@@ -12153,8 +12599,8 @@
         </p:nvSpPr>
         <p:spPr>
           <a:xfrm>
-            <a:off x="7680960" y="2770632"/>
-            <a:ext cx="4069080" cy="237744"/>
+            <a:off x="7680960" y="2734056"/>
+            <a:ext cx="4069080" cy="219456"/>
           </a:xfrm>
           <a:prstGeom prst="rect">
             <a:avLst/>
@@ -12194,8 +12640,8 @@
         </p:nvSpPr>
         <p:spPr>
           <a:xfrm>
-            <a:off x="7680960" y="3017520"/>
-            <a:ext cx="4069080" cy="1060704"/>
+            <a:off x="7680960" y="2962656"/>
+            <a:ext cx="4069080" cy="1078992"/>
           </a:xfrm>
           <a:prstGeom prst="rect">
             <a:avLst/>
@@ -12208,21 +12654,41 @@
           <a:p>
             <a:pPr algn="l">
               <a:lnSpc>
-                <a:spcPct val="106000"/>
-              </a:lnSpc>
-              <a:spcAft>
-                <a:spcPts val="100"/>
-              </a:spcAft>
-            </a:pPr>
-            <a:r>
-              <a:rPr sz="1000" b="0">
+                <a:spcPct val="104000"/>
+              </a:lnSpc>
+              <a:spcAft>
+                <a:spcPts val="100"/>
+              </a:spcAft>
+            </a:pPr>
+            <a:r>
+              <a:rPr sz="950" b="0">
                 <a:solidFill>
                   <a:srgbClr val="2C3E50"/>
                 </a:solidFill>
                 <a:latin typeface="WenQuanYi Micro Hei"/>
                 <a:ea typeface="WenQuanYi Micro Hei"/>
               </a:rPr>
-              <a:t>域湖仓完成本地加工，经公共层进入Data Suite，再进入Sense。Think之后，Act通过AN Apps调用既有OSS/RIC/SON。</a:t>
+              <a:t>域湖仓完成本地加工，经公共层进入Data Suite，再进入Sense，建立观察与chain-of-custody。</a:t>
+            </a:r>
+          </a:p>
+          <a:p>
+            <a:pPr algn="l">
+              <a:lnSpc>
+                <a:spcPct val="104000"/>
+              </a:lnSpc>
+              <a:spcAft>
+                <a:spcPts val="100"/>
+              </a:spcAft>
+            </a:pPr>
+            <a:r>
+              <a:rPr sz="950" b="0">
+                <a:solidFill>
+                  <a:srgbClr val="2C3E50"/>
+                </a:solidFill>
+                <a:latin typeface="WenQuanYi Micro Hei"/>
+                <a:ea typeface="WenQuanYi Micro Hei"/>
+              </a:rPr>
+              <a:t>Think使用电信模型和Glass-Box推理；Act通过AN Apps调用既有OSS/RIC/SON，再向计量和Marketplace延伸。</a:t>
             </a:r>
           </a:p>
         </p:txBody>
@@ -12235,7 +12701,7 @@
         </p:nvSpPr>
         <p:spPr>
           <a:xfrm>
-            <a:off x="7534656" y="4261104"/>
+            <a:off x="7534656" y="4187952"/>
             <a:ext cx="4306824" cy="1463040"/>
           </a:xfrm>
           <a:prstGeom prst="roundRect">
@@ -12280,7 +12746,7 @@
         </p:nvSpPr>
         <p:spPr>
           <a:xfrm>
-            <a:off x="7534656" y="4261104"/>
+            <a:off x="7534656" y="4187952"/>
             <a:ext cx="64008" cy="1463040"/>
           </a:xfrm>
           <a:prstGeom prst="rect">
@@ -12323,8 +12789,8 @@
         </p:nvSpPr>
         <p:spPr>
           <a:xfrm>
-            <a:off x="7680960" y="4325112"/>
-            <a:ext cx="4069080" cy="237744"/>
+            <a:off x="7680960" y="4233672"/>
+            <a:ext cx="4069080" cy="219456"/>
           </a:xfrm>
           <a:prstGeom prst="rect">
             <a:avLst/>
@@ -12364,8 +12830,8 @@
         </p:nvSpPr>
         <p:spPr>
           <a:xfrm>
-            <a:off x="7680960" y="4572000"/>
-            <a:ext cx="4069080" cy="1078992"/>
+            <a:off x="7680960" y="4462272"/>
+            <a:ext cx="4069080" cy="1133856"/>
           </a:xfrm>
           <a:prstGeom prst="rect">
             <a:avLst/>
@@ -12378,21 +12844,41 @@
           <a:p>
             <a:pPr algn="l">
               <a:lnSpc>
-                <a:spcPct val="106000"/>
-              </a:lnSpc>
-              <a:spcAft>
-                <a:spcPts val="100"/>
-              </a:spcAft>
-            </a:pPr>
-            <a:r>
-              <a:rPr sz="1000" b="0">
+                <a:spcPct val="104000"/>
+              </a:lnSpc>
+              <a:spcAft>
+                <a:spcPts val="100"/>
+              </a:spcAft>
+            </a:pPr>
+            <a:r>
+              <a:rPr sz="950" b="0">
                 <a:solidFill>
                   <a:srgbClr val="2C3E50"/>
                 </a:solidFill>
                 <a:latin typeface="WenQuanYi Micro Hei"/>
                 <a:ea typeface="WenQuanYi Micro Hei"/>
               </a:rPr>
-              <a:t>优势是SKU可组合、进入现网快。代价是各层可能只在品牌层组合，并形成语义、应用与云后端的软锁定。</a:t>
+              <a:t>优势是SKU可组合、进入现网快，不必等待6G新网元标准。</a:t>
+            </a:r>
+          </a:p>
+          <a:p>
+            <a:pPr algn="l">
+              <a:lnSpc>
+                <a:spcPct val="104000"/>
+              </a:lnSpc>
+              <a:spcAft>
+                <a:spcPts val="100"/>
+              </a:spcAft>
+            </a:pPr>
+            <a:r>
+              <a:rPr sz="950" b="0">
+                <a:solidFill>
+                  <a:srgbClr val="2C3E50"/>
+                </a:solidFill>
+                <a:latin typeface="WenQuanYi Micro Hei"/>
+                <a:ea typeface="WenQuanYi Micro Hei"/>
+              </a:rPr>
+              <a:t>代价是各层可能只在品牌层组合，并形成语义、应用与云后端的软锁定。客户若只买域App，分层复利就落空。</a:t>
             </a:r>
           </a:p>
         </p:txBody>
@@ -12405,8 +12891,8 @@
         </p:nvSpPr>
         <p:spPr>
           <a:xfrm>
-            <a:off x="347472" y="5833872"/>
-            <a:ext cx="11475720" cy="694944"/>
+            <a:off x="347472" y="5742432"/>
+            <a:ext cx="11475720" cy="786384"/>
           </a:xfrm>
           <a:prstGeom prst="roundRect">
             <a:avLst/>
@@ -12450,8 +12936,8 @@
         </p:nvSpPr>
         <p:spPr>
           <a:xfrm>
-            <a:off x="457200" y="5879592"/>
-            <a:ext cx="3678936" cy="182880"/>
+            <a:off x="457200" y="5779008"/>
+            <a:ext cx="3691128" cy="164592"/>
           </a:xfrm>
           <a:prstGeom prst="rect">
             <a:avLst/>
@@ -12491,8 +12977,8 @@
         </p:nvSpPr>
         <p:spPr>
           <a:xfrm>
-            <a:off x="457200" y="6053328"/>
-            <a:ext cx="3678936" cy="420624"/>
+            <a:off x="457200" y="5943600"/>
+            <a:ext cx="3691128" cy="530352"/>
           </a:xfrm>
           <a:prstGeom prst="rect">
             <a:avLst/>
@@ -12519,7 +13005,7 @@
                 <a:latin typeface="WenQuanYi Micro Hei"/>
                 <a:ea typeface="WenQuanYi Micro Hei"/>
               </a:rPr>
-              <a:t>KDDI覆盖20万4G/5G RAN；stc披露超过1万次自动动作；Indosat证明节能应用可扩展。</a:t>
+              <a:t>KDDI覆盖20万4G/5G RAN；stc披露超过1万次自动动作和性能改善；Indosat证明节能应用可扩展。它们证明域级闭环，不证明统一跨域Fabric。</a:t>
             </a:r>
           </a:p>
         </p:txBody>
@@ -12532,8 +13018,8 @@
         </p:nvSpPr>
         <p:spPr>
           <a:xfrm>
-            <a:off x="4245864" y="5879592"/>
-            <a:ext cx="3678936" cy="182880"/>
+            <a:off x="4239768" y="5779008"/>
+            <a:ext cx="3691128" cy="164592"/>
           </a:xfrm>
           <a:prstGeom prst="rect">
             <a:avLst/>
@@ -12573,8 +13059,8 @@
         </p:nvSpPr>
         <p:spPr>
           <a:xfrm>
-            <a:off x="4245864" y="6053328"/>
-            <a:ext cx="3678936" cy="420624"/>
+            <a:off x="4239768" y="5943600"/>
+            <a:ext cx="3691128" cy="530352"/>
           </a:xfrm>
           <a:prstGeom prst="rect">
             <a:avLst/>
@@ -12601,7 +13087,7 @@
                 <a:latin typeface="WenQuanYi Micro Hei"/>
                 <a:ea typeface="WenQuanYi Micro Hei"/>
               </a:rPr>
-              <a:t>匿名Tier-1：25万小区、27万报告/秒，仅支持摄取与关联潜力。</a:t>
+              <a:t>匿名Tier-1：25万小区、27万报告/秒，仅支持摄取与关联潜力。因客户未具名，不能外推广泛跨域商用。</a:t>
             </a:r>
           </a:p>
         </p:txBody>
@@ -12614,8 +13100,8 @@
         </p:nvSpPr>
         <p:spPr>
           <a:xfrm>
-            <a:off x="8034528" y="5879592"/>
-            <a:ext cx="3678936" cy="182880"/>
+            <a:off x="8022336" y="5779008"/>
+            <a:ext cx="3691128" cy="164592"/>
           </a:xfrm>
           <a:prstGeom prst="rect">
             <a:avLst/>
@@ -12655,8 +13141,8 @@
         </p:nvSpPr>
         <p:spPr>
           <a:xfrm>
-            <a:off x="8034528" y="6053328"/>
-            <a:ext cx="3678936" cy="420624"/>
+            <a:off x="8022336" y="5943600"/>
+            <a:ext cx="3691128" cy="530352"/>
           </a:xfrm>
           <a:prstGeom prst="rect">
             <a:avLst/>
@@ -12683,7 +13169,7 @@
                 <a:latin typeface="WenQuanYi Micro Hei"/>
                 <a:ea typeface="WenQuanYi Micro Hei"/>
               </a:rPr>
-              <a:t>同一契约是否共享、第三方后端/Agent能否双向替换、动作与回滚证据能否贯通。</a:t>
+              <a:t>Data Suite与AN Fabric是否共享同一契约，第三方后端/Agent能否双向替换，动作与回滚证据能否贯通域控制器。</a:t>
             </a:r>
           </a:p>
         </p:txBody>
@@ -13008,7 +13494,7 @@
         <p:spPr>
           <a:xfrm>
             <a:off x="347472" y="640080"/>
-            <a:ext cx="11475720" cy="420624"/>
+            <a:ext cx="11475720" cy="493776"/>
           </a:xfrm>
           <a:prstGeom prst="roundRect">
             <a:avLst/>
@@ -13042,10 +13528,10 @@
           <a:p>
             <a:pPr algn="l">
               <a:lnSpc>
-                <a:spcPct val="105000"/>
+                <a:spcPct val="104000"/>
               </a:lnSpc>
               <a:spcBef>
-                <a:spcPts val="300"/>
+                <a:spcPts val="200"/>
               </a:spcBef>
               <a:spcAft>
                 <a:spcPts val="100"/>
@@ -13059,7 +13545,7 @@
                 <a:latin typeface="WenQuanYi Micro Hei"/>
                 <a:ea typeface="WenQuanYi Micro Hei"/>
               </a:rPr>
-              <a:t>Ericsson争联邦治理，Huawei争近源运行时，Nokia争语义产品与应用入口。平台地位取决于外部契约，而不是把数据集中到一个名字。</a:t>
+              <a:t>Ericsson争联邦治理，Huawei争近源运行时，Nokia争语义产品与应用入口。谁能定义这些能力的外部接口，同时允许执行层和后端替换，谁才更接近长期平台位置；谁只提供封闭组件或单点应用，谁就仍停留在项目层。</a:t>
             </a:r>
           </a:p>
         </p:txBody>
@@ -13073,8 +13559,8 @@
           <p:nvPr/>
         </p:nvGraphicFramePr>
         <p:xfrm>
-          <a:off x="347472" y="1133856"/>
-          <a:ext cx="11475720" cy="2359152"/>
+          <a:off x="347472" y="1170432"/>
+          <a:ext cx="11475720" cy="2450592"/>
         </p:xfrm>
         <a:graphic>
           <a:graphicData uri="http://schemas.openxmlformats.org/drawingml/2006/table">
@@ -13083,12 +13569,12 @@
                 <a:tableStyleId>{5C22544A-7EE6-4342-B048-85BDC9FD1C3A}</a:tableStyleId>
               </a:tblPr>
               <a:tblGrid>
-                <a:gridCol w="1554480"/>
-                <a:gridCol w="3310128"/>
-                <a:gridCol w="3310128"/>
-                <a:gridCol w="3300984"/>
+                <a:gridCol w="1417320"/>
+                <a:gridCol w="3355848"/>
+                <a:gridCol w="3355848"/>
+                <a:gridCol w="3346704"/>
               </a:tblGrid>
-              <a:tr h="337021">
+              <a:tr h="350084">
                 <a:tc>
                   <a:txBody>
                     <a:bodyPr wrap="square" lIns="45720" rIns="36576" tIns="27432" bIns="27432"/>
@@ -13096,7 +13582,7 @@
                     <a:p>
                       <a:pPr algn="l"/>
                       <a:r>
-                        <a:rPr sz="900" b="1">
+                        <a:rPr sz="850" b="1">
                           <a:solidFill>
                             <a:srgbClr val="FFFFFF"/>
                           </a:solidFill>
@@ -13120,7 +13606,7 @@
                     <a:p>
                       <a:pPr algn="l"/>
                       <a:r>
-                        <a:rPr sz="900" b="1">
+                        <a:rPr sz="850" b="1">
                           <a:solidFill>
                             <a:srgbClr val="FFFFFF"/>
                           </a:solidFill>
@@ -13144,7 +13630,7 @@
                     <a:p>
                       <a:pPr algn="l"/>
                       <a:r>
-                        <a:rPr sz="900" b="1">
+                        <a:rPr sz="850" b="1">
                           <a:solidFill>
                             <a:srgbClr val="FFFFFF"/>
                           </a:solidFill>
@@ -13168,7 +13654,7 @@
                     <a:p>
                       <a:pPr algn="l"/>
                       <a:r>
-                        <a:rPr sz="900" b="1">
+                        <a:rPr sz="850" b="1">
                           <a:solidFill>
                             <a:srgbClr val="FFFFFF"/>
                           </a:solidFill>
@@ -13186,7 +13672,7 @@
                   </a:tcPr>
                 </a:tc>
               </a:tr>
-              <a:tr h="337021">
+              <a:tr h="350084">
                 <a:tc>
                   <a:txBody>
                     <a:bodyPr wrap="square" lIns="45720" rIns="36576" tIns="27432" bIns="27432"/>
@@ -13194,7 +13680,7 @@
                     <a:p>
                       <a:pPr algn="l"/>
                       <a:r>
-                        <a:rPr sz="900" b="1">
+                        <a:rPr sz="850" b="1">
                           <a:solidFill>
                             <a:srgbClr val="1A1A1A"/>
                           </a:solidFill>
@@ -13218,14 +13704,14 @@
                     <a:p>
                       <a:pPr algn="l"/>
                       <a:r>
-                        <a:rPr sz="900" b="0">
+                        <a:rPr sz="850" b="0">
                           <a:solidFill>
                             <a:srgbClr val="1A1A1A"/>
                           </a:solidFill>
                           <a:latin typeface="WenQuanYi Micro Hei"/>
                           <a:ea typeface="WenQuanYi Micro Hei"/>
                         </a:rPr>
-                        <a:t>连接既有数据岛</a:t>
+                        <a:t>分散数据岛和既有产品如何少迁移、可复用</a:t>
                       </a:r>
                     </a:p>
                   </a:txBody>
@@ -13242,14 +13728,14 @@
                     <a:p>
                       <a:pPr algn="l"/>
                       <a:r>
-                        <a:rPr sz="900" b="0">
+                        <a:rPr sz="850" b="0">
                           <a:solidFill>
                             <a:srgbClr val="1A1A1A"/>
                           </a:solidFill>
                           <a:latin typeface="WenQuanYi Micro Hei"/>
                           <a:ea typeface="WenQuanYi Micro Hei"/>
                         </a:rPr>
-                        <a:t>重构数据处理拓扑</a:t>
+                        <a:t>AI/ISAC多源多处理多汇如何低时延流动</a:t>
                       </a:r>
                     </a:p>
                   </a:txBody>
@@ -13266,14 +13752,14 @@
                     <a:p>
                       <a:pPr algn="l"/>
                       <a:r>
-                        <a:rPr sz="900" b="0">
+                        <a:rPr sz="850" b="0">
                           <a:solidFill>
                             <a:srgbClr val="1A1A1A"/>
                           </a:solidFill>
                           <a:latin typeface="WenQuanYi Micro Hei"/>
                           <a:ea typeface="WenQuanYi Micro Hei"/>
                         </a:rPr>
-                        <a:t>组合数据与自治软件</a:t>
+                        <a:t>数据管理、自治应用和商业外延如何形成可售组合</a:t>
                       </a:r>
                     </a:p>
                   </a:txBody>
@@ -13284,7 +13770,7 @@
                   </a:tcPr>
                 </a:tc>
               </a:tr>
-              <a:tr h="337021">
+              <a:tr h="350084">
                 <a:tc>
                   <a:txBody>
                     <a:bodyPr wrap="square" lIns="45720" rIns="36576" tIns="27432" bIns="27432"/>
@@ -13292,7 +13778,7 @@
                     <a:p>
                       <a:pPr algn="l"/>
                       <a:r>
-                        <a:rPr sz="900" b="1">
+                        <a:rPr sz="850" b="1">
                           <a:solidFill>
                             <a:srgbClr val="1A1A1A"/>
                           </a:solidFill>
@@ -13316,14 +13802,14 @@
                     <a:p>
                       <a:pPr algn="l"/>
                       <a:r>
-                        <a:rPr sz="900" b="0">
+                        <a:rPr sz="850" b="0">
                           <a:solidFill>
                             <a:srgbClr val="1A1A1A"/>
                           </a:solidFill>
                           <a:latin typeface="WenQuanYi Micro Hei"/>
                           <a:ea typeface="WenQuanYi Micro Hei"/>
                         </a:rPr>
-                        <a:t>联邦目录、治理与策略</a:t>
+                        <a:t>目录、治理和策略逻辑联邦；产品控制仍分散</a:t>
                       </a:r>
                     </a:p>
                   </a:txBody>
@@ -13340,14 +13826,14 @@
                     <a:p>
                       <a:pPr algn="l"/>
                       <a:r>
-                        <a:rPr sz="900" b="0">
+                        <a:rPr sz="850" b="0">
                           <a:solidFill>
                             <a:srgbClr val="1A1A1A"/>
                           </a:solidFill>
                           <a:latin typeface="WenQuanYi Micro Hei"/>
                           <a:ea typeface="WenQuanYi Micro Hei"/>
                         </a:rPr>
-                        <a:t>DO与网络原生拓扑</a:t>
+                        <a:t>DO编排执行能力与数据拓扑</a:t>
                       </a:r>
                     </a:p>
                   </a:txBody>
@@ -13364,14 +13850,14 @@
                     <a:p>
                       <a:pPr algn="l"/>
                       <a:r>
-                        <a:rPr sz="900" b="0">
+                        <a:rPr sz="850" b="0">
                           <a:solidFill>
                             <a:srgbClr val="1A1A1A"/>
                           </a:solidFill>
                           <a:latin typeface="WenQuanYi Micro Hei"/>
                           <a:ea typeface="WenQuanYi Micro Hei"/>
                         </a:rPr>
-                        <a:t>Data Suite + AN Fabric分层</a:t>
+                        <a:t>Data Suite管数据产品，AN Fabric管智能消费</a:t>
                       </a:r>
                     </a:p>
                   </a:txBody>
@@ -13382,7 +13868,7 @@
                   </a:tcPr>
                 </a:tc>
               </a:tr>
-              <a:tr h="337021">
+              <a:tr h="350084">
                 <a:tc>
                   <a:txBody>
                     <a:bodyPr wrap="square" lIns="45720" rIns="36576" tIns="27432" bIns="27432"/>
@@ -13390,7 +13876,7 @@
                     <a:p>
                       <a:pPr algn="l"/>
                       <a:r>
-                        <a:rPr sz="900" b="1">
+                        <a:rPr sz="850" b="1">
                           <a:solidFill>
                             <a:srgbClr val="1A1A1A"/>
                           </a:solidFill>
@@ -13414,14 +13900,14 @@
                     <a:p>
                       <a:pPr algn="l"/>
                       <a:r>
-                        <a:rPr sz="900" b="0">
+                        <a:rPr sz="850" b="0">
                           <a:solidFill>
                             <a:srgbClr val="1A1A1A"/>
                           </a:solidFill>
                           <a:latin typeface="WenQuanYi Micro Hei"/>
                           <a:ea typeface="WenQuanYi Micro Hei"/>
                         </a:rPr>
-                        <a:t>域内产品与数据湖</a:t>
+                        <a:t>域内产品、EDCA/DMF与数据湖按需访问</a:t>
                       </a:r>
                     </a:p>
                   </a:txBody>
@@ -13438,14 +13924,14 @@
                     <a:p>
                       <a:pPr algn="l"/>
                       <a:r>
-                        <a:rPr sz="900" b="0">
+                        <a:rPr sz="850" b="0">
                           <a:solidFill>
                             <a:srgbClr val="1A1A1A"/>
                           </a:solidFill>
                           <a:latin typeface="WenQuanYi Micro Hei"/>
                           <a:ea typeface="WenQuanYi Micro Hei"/>
                         </a:rPr>
-                        <a:t>UE / RAN / 边缘 / Core近源</a:t>
+                        <a:t>DA/DPF/DSF在UE/RAN/边缘/Core近源执行</a:t>
                       </a:r>
                     </a:p>
                   </a:txBody>
@@ -13462,14 +13948,14 @@
                     <a:p>
                       <a:pPr algn="l"/>
                       <a:r>
-                        <a:rPr sz="900" b="0">
+                        <a:rPr sz="850" b="0">
                           <a:solidFill>
                             <a:srgbClr val="1A1A1A"/>
                           </a:solidFill>
                           <a:latin typeface="WenQuanYi Micro Hei"/>
                           <a:ea typeface="WenQuanYi Micro Hei"/>
                         </a:rPr>
-                        <a:t>域湖仓与OSS / RIC / SON</a:t>
+                        <a:t>数据留域；动作经AN Apps回OSS/RIC/SON</a:t>
                       </a:r>
                     </a:p>
                   </a:txBody>
@@ -13480,7 +13966,7 @@
                   </a:tcPr>
                 </a:tc>
               </a:tr>
-              <a:tr h="337021">
+              <a:tr h="350084">
                 <a:tc>
                   <a:txBody>
                     <a:bodyPr wrap="square" lIns="45720" rIns="36576" tIns="27432" bIns="27432"/>
@@ -13488,7 +13974,7 @@
                     <a:p>
                       <a:pPr algn="l"/>
                       <a:r>
-                        <a:rPr sz="900" b="1">
+                        <a:rPr sz="850" b="1">
                           <a:solidFill>
                             <a:srgbClr val="1A1A1A"/>
                           </a:solidFill>
@@ -13512,14 +13998,14 @@
                     <a:p>
                       <a:pPr algn="l"/>
                       <a:r>
-                        <a:rPr sz="900" b="0">
+                        <a:rPr sz="850" b="0">
                           <a:solidFill>
                             <a:srgbClr val="1A1A1A"/>
                           </a:solidFill>
                           <a:latin typeface="WenQuanYi Micro Hei"/>
                           <a:ea typeface="WenQuanYi Micro Hei"/>
                         </a:rPr>
-                        <a:t>迁移连续性</a:t>
+                        <a:t>保护存量、降低迁移风险、允许多后端</a:t>
                       </a:r>
                     </a:p>
                   </a:txBody>
@@ -13536,14 +14022,14 @@
                     <a:p>
                       <a:pPr algn="l"/>
                       <a:r>
-                        <a:rPr sz="900" b="0">
+                        <a:rPr sz="850" b="0">
                           <a:solidFill>
                             <a:srgbClr val="1A1A1A"/>
                           </a:solidFill>
                           <a:latin typeface="WenQuanYi Micro Hei"/>
                           <a:ea typeface="WenQuanYi Micro Hei"/>
                         </a:rPr>
-                        <a:t>近源执行控制</a:t>
+                        <a:t>降低全量搬运，获得可编排近源处理</a:t>
                       </a:r>
                     </a:p>
                   </a:txBody>
@@ -13560,14 +14046,14 @@
                     <a:p>
                       <a:pPr algn="l"/>
                       <a:r>
-                        <a:rPr sz="900" b="0">
+                        <a:rPr sz="850" b="0">
                           <a:solidFill>
                             <a:srgbClr val="1A1A1A"/>
                           </a:solidFill>
                           <a:latin typeface="WenQuanYi Micro Hei"/>
                           <a:ea typeface="WenQuanYi Micro Hei"/>
                         </a:rPr>
-                        <a:t>产品化速度</a:t>
+                        <a:t>能力可分别产品化并快速进入现网</a:t>
                       </a:r>
                     </a:p>
                   </a:txBody>
@@ -13578,7 +14064,7 @@
                   </a:tcPr>
                 </a:tc>
               </a:tr>
-              <a:tr h="337021">
+              <a:tr h="350084">
                 <a:tc>
                   <a:txBody>
                     <a:bodyPr wrap="square" lIns="45720" rIns="36576" tIns="27432" bIns="27432"/>
@@ -13586,7 +14072,7 @@
                     <a:p>
                       <a:pPr algn="l"/>
                       <a:r>
-                        <a:rPr sz="900" b="1">
+                        <a:rPr sz="850" b="1">
                           <a:solidFill>
                             <a:srgbClr val="1A1A1A"/>
                           </a:solidFill>
@@ -13610,14 +14096,14 @@
                     <a:p>
                       <a:pPr algn="l"/>
                       <a:r>
-                        <a:rPr sz="900" b="0">
+                        <a:rPr sz="850" b="0">
                           <a:solidFill>
                             <a:srgbClr val="1A1A1A"/>
                           </a:solidFill>
                           <a:latin typeface="WenQuanYi Micro Hei"/>
                           <a:ea typeface="WenQuanYi Micro Hei"/>
                         </a:rPr>
-                        <a:t>跨产品协调复杂度</a:t>
+                        <a:t>跨产品语义、QoD、策略和版本协调持续存在</a:t>
                       </a:r>
                     </a:p>
                   </a:txBody>
@@ -13634,14 +14120,14 @@
                     <a:p>
                       <a:pPr algn="l"/>
                       <a:r>
-                        <a:rPr sz="900" b="0">
+                        <a:rPr sz="850" b="0">
                           <a:solidFill>
                             <a:srgbClr val="1A1A1A"/>
                           </a:solidFill>
                           <a:latin typeface="WenQuanYi Micro Hei"/>
                           <a:ea typeface="WenQuanYi Micro Hei"/>
                         </a:rPr>
-                        <a:t>新平面可靠性与状态复杂度</a:t>
+                        <a:t>新增顺序、持久化、容灾、移动性与可移植性</a:t>
                       </a:r>
                     </a:p>
                   </a:txBody>
@@ -13658,14 +14144,14 @@
                     <a:p>
                       <a:pPr algn="l"/>
                       <a:r>
-                        <a:rPr sz="900" b="0">
+                        <a:rPr sz="850" b="0">
                           <a:solidFill>
                             <a:srgbClr val="1A1A1A"/>
                           </a:solidFill>
                           <a:latin typeface="WenQuanYi Micro Hei"/>
                           <a:ea typeface="WenQuanYi Micro Hei"/>
                         </a:rPr>
-                        <a:t>多层SKU与软锁定</a:t>
+                        <a:t>多层SKU可能只在品牌层组合并形成软锁定</a:t>
                       </a:r>
                     </a:p>
                   </a:txBody>
@@ -13676,7 +14162,7 @@
                   </a:tcPr>
                 </a:tc>
               </a:tr>
-              <a:tr h="337026">
+              <a:tr h="350088">
                 <a:tc>
                   <a:txBody>
                     <a:bodyPr wrap="square" lIns="45720" rIns="36576" tIns="27432" bIns="27432"/>
@@ -13684,7 +14170,7 @@
                     <a:p>
                       <a:pPr algn="l"/>
                       <a:r>
-                        <a:rPr sz="900" b="1">
+                        <a:rPr sz="850" b="1">
                           <a:solidFill>
                             <a:srgbClr val="1A1A1A"/>
                           </a:solidFill>
@@ -13708,14 +14194,14 @@
                     <a:p>
                       <a:pPr algn="l"/>
                       <a:r>
-                        <a:rPr sz="900" b="0">
+                        <a:rPr sz="850" b="0">
                           <a:solidFill>
                             <a:srgbClr val="1A1A1A"/>
                           </a:solidFill>
                           <a:latin typeface="WenQuanYi Micro Hei"/>
                           <a:ea typeface="WenQuanYi Micro Hei"/>
                         </a:rPr>
-                        <a:t>跨产品、跨后端复用</a:t>
+                        <a:t>同一数据产品跨DataOps、EIAP、NWDAF和第三方复用</a:t>
                       </a:r>
                     </a:p>
                   </a:txBody>
@@ -13732,14 +14218,14 @@
                     <a:p>
                       <a:pPr algn="l"/>
                       <a:r>
-                        <a:rPr sz="900" b="0">
+                        <a:rPr sz="850" b="0">
                           <a:solidFill>
                             <a:srgbClr val="1A1A1A"/>
                           </a:solidFill>
                           <a:latin typeface="WenQuanYi Micro Hei"/>
                           <a:ea typeface="WenQuanYi Micro Hei"/>
                         </a:rPr>
-                        <a:t>同功能可靠性与多厂商测试</a:t>
+                        <a:t>同功能对比下通过持久化、故障、移动性和租户SLA</a:t>
                       </a:r>
                     </a:p>
                   </a:txBody>
@@ -13756,14 +14242,14 @@
                     <a:p>
                       <a:pPr algn="l"/>
                       <a:r>
-                        <a:rPr sz="900" b="0">
+                        <a:rPr sz="850" b="0">
                           <a:solidFill>
                             <a:srgbClr val="1A1A1A"/>
                           </a:solidFill>
                           <a:latin typeface="WenQuanYi Micro Hei"/>
                           <a:ea typeface="WenQuanYi Micro Hei"/>
                         </a:rPr>
-                        <a:t>统一契约、动作贯通、后端可替换</a:t>
+                        <a:t>三层共享契约，并支持第三方双向替换</a:t>
                       </a:r>
                     </a:p>
                   </a:txBody>
@@ -13786,8 +14272,8 @@
         </p:nvSpPr>
         <p:spPr>
           <a:xfrm>
-            <a:off x="347472" y="3602736"/>
-            <a:ext cx="2816352" cy="1298448"/>
+            <a:off x="347472" y="3712463"/>
+            <a:ext cx="2816352" cy="1243584"/>
           </a:xfrm>
           <a:prstGeom prst="roundRect">
             <a:avLst/>
@@ -13831,8 +14317,8 @@
         </p:nvSpPr>
         <p:spPr>
           <a:xfrm>
-            <a:off x="347472" y="3602736"/>
-            <a:ext cx="64008" cy="1298448"/>
+            <a:off x="347472" y="3712463"/>
+            <a:ext cx="64008" cy="1243584"/>
           </a:xfrm>
           <a:prstGeom prst="rect">
             <a:avLst/>
@@ -13874,8 +14360,8 @@
         </p:nvSpPr>
         <p:spPr>
           <a:xfrm>
-            <a:off x="493776" y="3666744"/>
-            <a:ext cx="2578608" cy="237744"/>
+            <a:off x="493776" y="3758183"/>
+            <a:ext cx="2578608" cy="219456"/>
           </a:xfrm>
           <a:prstGeom prst="rect">
             <a:avLst/>
@@ -13915,7 +14401,7 @@
         </p:nvSpPr>
         <p:spPr>
           <a:xfrm>
-            <a:off x="493776" y="3913632"/>
+            <a:off x="493776" y="3986783"/>
             <a:ext cx="2578608" cy="914400"/>
           </a:xfrm>
           <a:prstGeom prst="rect">
@@ -13929,21 +14415,21 @@
           <a:p>
             <a:pPr algn="l">
               <a:lnSpc>
-                <a:spcPct val="106000"/>
-              </a:lnSpc>
-              <a:spcAft>
-                <a:spcPts val="100"/>
-              </a:spcAft>
-            </a:pPr>
-            <a:r>
-              <a:rPr sz="950" b="0">
+                <a:spcPct val="104000"/>
+              </a:lnSpc>
+              <a:spcAft>
+                <a:spcPts val="100"/>
+              </a:spcAft>
+            </a:pPr>
+            <a:r>
+              <a:rPr sz="900" b="0">
                 <a:solidFill>
                   <a:srgbClr val="2C3E50"/>
                 </a:solidFill>
                 <a:latin typeface="WenQuanYi Micro Hei"/>
                 <a:ea typeface="WenQuanYi Micro Hei"/>
               </a:rPr>
-              <a:t>稳定ID、权威源、配置版本和对象映射，使同一小区、会话、模型能跨接口关联。</a:t>
+              <a:t>定义稳定ID、权威源、配置版本和对象映射，使同一小区、会话、模型与业务对象能跨接口关联。谁掌握这组映射，谁就能让模型和产品复用。</a:t>
             </a:r>
           </a:p>
         </p:txBody>
@@ -13956,8 +14442,8 @@
         </p:nvSpPr>
         <p:spPr>
           <a:xfrm>
-            <a:off x="3273552" y="3602736"/>
-            <a:ext cx="2816352" cy="1298448"/>
+            <a:off x="3273552" y="3712463"/>
+            <a:ext cx="2816352" cy="1243584"/>
           </a:xfrm>
           <a:prstGeom prst="roundRect">
             <a:avLst/>
@@ -14001,8 +14487,8 @@
         </p:nvSpPr>
         <p:spPr>
           <a:xfrm>
-            <a:off x="3273552" y="3602736"/>
-            <a:ext cx="64008" cy="1298448"/>
+            <a:off x="3273552" y="3712463"/>
+            <a:ext cx="64008" cy="1243584"/>
           </a:xfrm>
           <a:prstGeom prst="rect">
             <a:avLst/>
@@ -14044,8 +14530,8 @@
         </p:nvSpPr>
         <p:spPr>
           <a:xfrm>
-            <a:off x="3419856" y="3666744"/>
-            <a:ext cx="2578608" cy="237744"/>
+            <a:off x="3419856" y="3758183"/>
+            <a:ext cx="2578608" cy="219456"/>
           </a:xfrm>
           <a:prstGeom prst="rect">
             <a:avLst/>
@@ -14085,7 +14571,7 @@
         </p:nvSpPr>
         <p:spPr>
           <a:xfrm>
-            <a:off x="3419856" y="3913632"/>
+            <a:off x="3419856" y="3986783"/>
             <a:ext cx="2578608" cy="914400"/>
           </a:xfrm>
           <a:prstGeom prst="rect">
@@ -14099,21 +14585,21 @@
           <a:p>
             <a:pPr algn="l">
               <a:lnSpc>
-                <a:spcPct val="106000"/>
-              </a:lnSpc>
-              <a:spcAft>
-                <a:spcPts val="100"/>
-              </a:spcAft>
-            </a:pPr>
-            <a:r>
-              <a:rPr sz="950" b="0">
+                <a:spcPct val="104000"/>
+              </a:lnSpc>
+              <a:spcAft>
+                <a:spcPts val="100"/>
+              </a:spcAft>
+            </a:pPr>
+            <a:r>
+              <a:rPr sz="900" b="0">
                 <a:solidFill>
                   <a:srgbClr val="2C3E50"/>
                 </a:solidFill>
                 <a:latin typeface="WenQuanYi Micro Hei"/>
                 <a:ea typeface="WenQuanYi Micro Hei"/>
               </a:rPr>
-              <a:t>用途适用性、Owner、SLO、计量、降级与退出，决定数据对特定任务是否可交付。</a:t>
+              <a:t>定义数据对特定任务是否适用、谁负责、满足何种SLO、如何计量、何时降级或退出。没有契约，跨域交付只能停留在项目集成。</a:t>
             </a:r>
           </a:p>
         </p:txBody>
@@ -14126,8 +14612,8 @@
         </p:nvSpPr>
         <p:spPr>
           <a:xfrm>
-            <a:off x="6199632" y="3602736"/>
-            <a:ext cx="2816352" cy="1298448"/>
+            <a:off x="6199632" y="3712463"/>
+            <a:ext cx="2816352" cy="1243584"/>
           </a:xfrm>
           <a:prstGeom prst="roundRect">
             <a:avLst/>
@@ -14171,8 +14657,8 @@
         </p:nvSpPr>
         <p:spPr>
           <a:xfrm>
-            <a:off x="6199632" y="3602736"/>
-            <a:ext cx="64008" cy="1298448"/>
+            <a:off x="6199632" y="3712463"/>
+            <a:ext cx="64008" cy="1243584"/>
           </a:xfrm>
           <a:prstGeom prst="rect">
             <a:avLst/>
@@ -14214,8 +14700,8 @@
         </p:nvSpPr>
         <p:spPr>
           <a:xfrm>
-            <a:off x="6345936" y="3666744"/>
-            <a:ext cx="2578608" cy="237744"/>
+            <a:off x="6345936" y="3758183"/>
+            <a:ext cx="2578608" cy="219456"/>
           </a:xfrm>
           <a:prstGeom prst="rect">
             <a:avLst/>
@@ -14255,7 +14741,7 @@
         </p:nvSpPr>
         <p:spPr>
           <a:xfrm>
-            <a:off x="6345936" y="3913632"/>
+            <a:off x="6345936" y="3986783"/>
             <a:ext cx="2578608" cy="914400"/>
           </a:xfrm>
           <a:prstGeom prst="rect">
@@ -14269,21 +14755,21 @@
           <a:p>
             <a:pPr algn="l">
               <a:lnSpc>
-                <a:spcPct val="106000"/>
-              </a:lnSpc>
-              <a:spcAft>
-                <a:spcPts val="100"/>
-              </a:spcAft>
-            </a:pPr>
-            <a:r>
-              <a:rPr sz="950" b="0">
+                <a:spcPct val="104000"/>
+              </a:lnSpc>
+              <a:spcAft>
+                <a:spcPts val="100"/>
+              </a:spcAft>
+            </a:pPr>
+            <a:r>
+              <a:rPr sz="900" b="0">
                 <a:solidFill>
                   <a:srgbClr val="2C3E50"/>
                 </a:solidFill>
                 <a:latin typeface="WenQuanYi Micro Hei"/>
                 <a:ea typeface="WenQuanYi Micro Hei"/>
               </a:rPr>
-              <a:t>算子放置、策略下发、断链生存和版本回退，决定快环能否留在故障域内。</a:t>
+              <a:t>决定过滤、特征、推理与缓存放在哪里，策略如何下发，断链如何生存，版本如何回退。快环不能外包给远端目录或云平台。</a:t>
             </a:r>
           </a:p>
         </p:txBody>
@@ -14296,8 +14782,8 @@
         </p:nvSpPr>
         <p:spPr>
           <a:xfrm>
-            <a:off x="9125712" y="3602736"/>
-            <a:ext cx="2816352" cy="1298448"/>
+            <a:off x="9125712" y="3712463"/>
+            <a:ext cx="2816352" cy="1243584"/>
           </a:xfrm>
           <a:prstGeom prst="roundRect">
             <a:avLst/>
@@ -14341,8 +14827,8 @@
         </p:nvSpPr>
         <p:spPr>
           <a:xfrm>
-            <a:off x="9125712" y="3602736"/>
-            <a:ext cx="64008" cy="1298448"/>
+            <a:off x="9125712" y="3712463"/>
+            <a:ext cx="64008" cy="1243584"/>
           </a:xfrm>
           <a:prstGeom prst="rect">
             <a:avLst/>
@@ -14384,8 +14870,8 @@
         </p:nvSpPr>
         <p:spPr>
           <a:xfrm>
-            <a:off x="9272016" y="3666744"/>
-            <a:ext cx="2578608" cy="237744"/>
+            <a:off x="9272016" y="3758183"/>
+            <a:ext cx="2578608" cy="219456"/>
           </a:xfrm>
           <a:prstGeom prst="rect">
             <a:avLst/>
@@ -14425,7 +14911,7 @@
         </p:nvSpPr>
         <p:spPr>
           <a:xfrm>
-            <a:off x="9272016" y="3913632"/>
+            <a:off x="9272016" y="3986783"/>
             <a:ext cx="2578608" cy="914400"/>
           </a:xfrm>
           <a:prstGeom prst="rect">
@@ -14439,21 +14925,21 @@
           <a:p>
             <a:pPr algn="l">
               <a:lnSpc>
-                <a:spcPct val="106000"/>
-              </a:lnSpc>
-              <a:spcAft>
-                <a:spcPts val="100"/>
-              </a:spcAft>
-            </a:pPr>
-            <a:r>
-              <a:rPr sz="950" b="0">
+                <a:spcPct val="104000"/>
+              </a:lnSpc>
+              <a:spcAft>
+                <a:spcPts val="100"/>
+              </a:spcAft>
+            </a:pPr>
+            <a:r>
+              <a:rPr sz="900" b="0">
                 <a:solidFill>
                   <a:srgbClr val="2C3E50"/>
                 </a:solidFill>
                 <a:latin typeface="WenQuanYi Micro Hei"/>
                 <a:ea typeface="WenQuanYi Micro Hei"/>
               </a:rPr>
-              <a:t>数据—模型—策略—动作—结果—回滚的关联，并能被导出、审计与一致性测试。</a:t>
+              <a:t>把数据、模型、策略、动作、结果和回滚关联起来，并能被第三方审计、导出与一致性测试。没有证据链，自治权限扩不出去。</a:t>
             </a:r>
           </a:p>
         </p:txBody>
@@ -14466,8 +14952,8 @@
         </p:nvSpPr>
         <p:spPr>
           <a:xfrm>
-            <a:off x="347472" y="4992624"/>
-            <a:ext cx="11475720" cy="1517904"/>
+            <a:off x="347472" y="5029200"/>
+            <a:ext cx="11475720" cy="1481328"/>
           </a:xfrm>
           <a:prstGeom prst="roundRect">
             <a:avLst/>
@@ -14511,8 +14997,8 @@
         </p:nvSpPr>
         <p:spPr>
           <a:xfrm>
-            <a:off x="493776" y="5047488"/>
-            <a:ext cx="11183112" cy="201168"/>
+            <a:off x="493776" y="5065776"/>
+            <a:ext cx="11183112" cy="164592"/>
           </a:xfrm>
           <a:prstGeom prst="rect">
             <a:avLst/>
@@ -14539,7 +15025,7 @@
                 <a:latin typeface="WenQuanYi Micro Hei"/>
                 <a:ea typeface="WenQuanYi Micro Hei"/>
               </a:rPr>
-              <a:t>路线落点</a:t>
+              <a:t>路线落点与竞合边界</a:t>
             </a:r>
           </a:p>
         </p:txBody>
@@ -14553,7 +15039,7 @@
         <p:spPr>
           <a:xfrm>
             <a:off x="493776" y="5248656"/>
-            <a:ext cx="11183112" cy="384048"/>
+            <a:ext cx="11183112" cy="329184"/>
           </a:xfrm>
           <a:prstGeom prst="rect">
             <a:avLst/>
@@ -14566,21 +15052,21 @@
           <a:p>
             <a:pPr algn="l">
               <a:lnSpc>
-                <a:spcPct val="105000"/>
-              </a:lnSpc>
-              <a:spcAft>
-                <a:spcPts val="100"/>
-              </a:spcAft>
-            </a:pPr>
-            <a:r>
-              <a:rPr sz="1100" b="1">
+                <a:spcPct val="103000"/>
+              </a:lnSpc>
+              <a:spcAft>
+                <a:spcPts val="100"/>
+              </a:spcAft>
+            </a:pPr>
+            <a:r>
+              <a:rPr sz="1050" b="1">
                 <a:solidFill>
                   <a:srgbClr val="0B1F3A"/>
                 </a:solidFill>
                 <a:latin typeface="WenQuanYi Micro Hei"/>
                 <a:ea typeface="WenQuanYi Micro Hei"/>
               </a:rPr>
-              <a:t>Ericsson争夺联邦目录与渐进治理控制权。  Huawei争夺数据拓扑与近源运行时控制权。  Nokia争夺语义产品与自治应用入口控制权。</a:t>
+              <a:t>Ericsson争夺联邦目录与渐进治理控制权。Huawei争夺数据拓扑与近源运行时控制权。Nokia争夺语义产品与自治应用入口控制权。三者可替代也可互补，但都不是一条通向统一Fabric的成熟度阶梯。</a:t>
             </a:r>
           </a:p>
         </p:txBody>
@@ -14593,8 +15079,8 @@
         </p:nvSpPr>
         <p:spPr>
           <a:xfrm>
-            <a:off x="493776" y="5632704"/>
-            <a:ext cx="11183112" cy="384048"/>
+            <a:off x="493776" y="5596128"/>
+            <a:ext cx="11183112" cy="365760"/>
           </a:xfrm>
           <a:prstGeom prst="rect">
             <a:avLst/>
@@ -14607,21 +15093,21 @@
           <a:p>
             <a:pPr algn="l">
               <a:lnSpc>
-                <a:spcPct val="105000"/>
-              </a:lnSpc>
-              <a:spcAft>
-                <a:spcPts val="100"/>
-              </a:spcAft>
-            </a:pPr>
-            <a:r>
-              <a:rPr sz="1100" b="0">
+                <a:spcPct val="103000"/>
+              </a:lnSpc>
+              <a:spcAft>
+                <a:spcPts val="100"/>
+              </a:spcAft>
+            </a:pPr>
+            <a:r>
+              <a:rPr sz="1050" b="0">
                 <a:solidFill>
                   <a:srgbClr val="2C3E50"/>
                 </a:solidFill>
                 <a:latin typeface="WenQuanYi Micro Hei"/>
                 <a:ea typeface="WenQuanYi Micro Hei"/>
               </a:rPr>
-              <a:t>真正的平台地位不是把所有数据收到一个平台，而是让跨域消费者遵循自己的语义、QoD和证据契约，同时证明运行时、后端和渠道仍可互操作、可替换。</a:t>
+              <a:t>真正的平台地位不是把所有数据收到一个平台，而是让跨域消费者遵循自己的语义、QoD和证据契约，同时证明运行时、后端和渠道仍可互操作、可替换。标准更可能冻结这些外部行为，而不是替市场选出唯一Data Fabric。</a:t>
             </a:r>
           </a:p>
         </p:txBody>
@@ -14634,8 +15120,8 @@
         </p:nvSpPr>
         <p:spPr>
           <a:xfrm>
-            <a:off x="493776" y="6016752"/>
-            <a:ext cx="11183112" cy="384048"/>
+            <a:off x="493776" y="5980176"/>
+            <a:ext cx="11183112" cy="438912"/>
           </a:xfrm>
           <a:prstGeom prst="rect">
             <a:avLst/>
@@ -14648,7 +15134,7 @@
           <a:p>
             <a:pPr algn="l">
               <a:lnSpc>
-                <a:spcPct val="104000"/>
+                <a:spcPct val="103000"/>
               </a:lnSpc>
               <a:spcAft>
                 <a:spcPts val="100"/>
@@ -14662,7 +15148,7 @@
                 <a:latin typeface="WenQuanYi Micro Hei"/>
                 <a:ea typeface="WenQuanYi Micro Hei"/>
               </a:rPr>
-              <a:t>竞合边界：设备商更接近网络语义、近源执行与动作权限；云和湖仓更接近规模数据/模型运行时；聚合商更接近跨网分发与结算。三者可以组合，但RAN快环和网元动作权限不能外移。</a:t>
+              <a:t>竞合边界：设备商更接近网络语义、近源执行与动作权限；云和湖仓更接近规模数据/模型运行时；聚合商更接近跨网分发与结算。三者可以组合，但RAN快环和网元动作权限不能外移。Google Telecom Data Fabric仍为Private Preview，不能外推为已形成的跨网统一平台。</a:t>
             </a:r>
           </a:p>
         </p:txBody>

</xml_diff>

<commit_message>
Regenerate section 2.3 deck with Nokia reframing
Co-authored-by: newmanxiang <newmanxiang@users.noreply.github.com>
</commit_message>
<xml_diff>
--- a/reports/6g-data-fabric-section-23-deck.pptx
+++ b/reports/6g-data-fabric-section-23-deck.pptx
@@ -3256,7 +3256,7 @@
                 <a:latin typeface="WenQuanYi Micro Hei"/>
                 <a:ea typeface="WenQuanYi Micro Hei"/>
               </a:rPr>
-              <a:t>6G数据能力不会收敛为单一Fabric；三条路线围绕同一组控制能力竞争</a:t>
+              <a:t>6G数据能力不会收敛为单一Fabric；两类技术架构承载三种竞争位置</a:t>
             </a:r>
           </a:p>
         </p:txBody>
@@ -3321,7 +3321,7 @@
                 <a:latin typeface="WenQuanYi Micro Hei"/>
                 <a:ea typeface="WenQuanYi Micro Hei"/>
               </a:rPr>
-              <a:t>三条路线来自同一组架构矛盾，不是对Fabric理解不同，更不是成熟度阶梯。Ericsson优先低风险演进，Huawei优先近源执行，Nokia优先产品化速度；真正要比较的是控制权放在哪里、以什么代价换什么优势。</a:t>
+              <a:t>产品命名和SKU边界不必然构成新的数据拓扑。Ericsson与Nokia共享相近的联邦分层骨架，分别从治理和自智应用进入；Huawei重构网络内数据处理拓扑。真正要比较的是技术底座、控制入口，以及以什么代价换什么优势。</a:t>
             </a:r>
           </a:p>
         </p:txBody>
@@ -4539,7 +4539,7 @@
                 <a:latin typeface="WenQuanYi Micro Hei"/>
                 <a:ea typeface="WenQuanYi Micro Hei"/>
               </a:rPr>
-              <a:t>决定路线</a:t>
+              <a:t>决定位置</a:t>
             </a:r>
           </a:p>
         </p:txBody>
@@ -4711,7 +4711,7 @@
                 <a:latin typeface="WenQuanYi Micro Hei"/>
                 <a:ea typeface="WenQuanYi Micro Hei"/>
               </a:rPr>
-              <a:t>Ericsson  ·  存量联邦</a:t>
+              <a:t>Ericsson  ·  联邦分层 / 治理入口</a:t>
             </a:r>
           </a:p>
         </p:txBody>
@@ -4922,7 +4922,7 @@
                 <a:latin typeface="WenQuanYi Micro Hei"/>
                 <a:ea typeface="WenQuanYi Micro Hei"/>
               </a:rPr>
-              <a:t>Huawei  ·  网络原生拓扑</a:t>
+              <a:t>Huawei  ·  网络原生 / 执行入口</a:t>
             </a:r>
           </a:p>
         </p:txBody>
@@ -5133,7 +5133,7 @@
                 <a:latin typeface="WenQuanYi Micro Hei"/>
                 <a:ea typeface="WenQuanYi Micro Hei"/>
               </a:rPr>
-              <a:t>Nokia  ·  分层商品化</a:t>
+              <a:t>Nokia  ·  联邦分层 / 应用入口</a:t>
             </a:r>
           </a:p>
         </p:txBody>
@@ -5174,7 +5174,7 @@
                 <a:latin typeface="WenQuanYi Micro Hei"/>
                 <a:ea typeface="WenQuanYi Micro Hei"/>
               </a:rPr>
-              <a:t>组合数据与自治软件</a:t>
+              <a:t>产品化数据—自智软件链</a:t>
             </a:r>
           </a:p>
         </p:txBody>
@@ -5215,7 +5215,7 @@
                 <a:latin typeface="WenQuanYi Micro Hei"/>
                 <a:ea typeface="WenQuanYi Micro Hei"/>
               </a:rPr>
-              <a:t>以分层SKU换产品化速度。先让目录、AI和应用可分别销售并进入现网，再验证各层是否共享同一契约和控制体系。</a:t>
+              <a:t>技术底座与Ericsson高度相似，差别在产品组织：把数据契约、智能消费和AN Apps包装成可售软件链，而不是形成第三种数据架构。</a:t>
             </a:r>
           </a:p>
         </p:txBody>
@@ -6177,7 +6177,7 @@
                 <a:latin typeface="WenQuanYi Micro Hei"/>
                 <a:ea typeface="WenQuanYi Micro Hei"/>
               </a:rPr>
-              <a:t>ITU-R、SA2/SA5、O-RAN和外部运营接口正在形成一条可组合链路，但并不共同要求一个名为Data Fabric的网元。标准冻结跨厂商必须一致的对象与接口，不替厂商选择内部拓扑，因此三条路线可以长期并存。</a:t>
+              <a:t>ITU-R、SA2/SA5、O-RAN和外部运营接口正在形成一条可组合链路，但并不共同要求一个名为Data Fabric的网元。标准冻结跨厂商必须一致的对象与接口，不替厂商选择内部拓扑，因此两类技术架构和不同产品入口可以长期并存。</a:t>
             </a:r>
           </a:p>
         </p:txBody>
@@ -6509,7 +6509,7 @@
                 <a:latin typeface="WenQuanYi Micro Hei"/>
                 <a:ea typeface="WenQuanYi Micro Hei"/>
               </a:rPr>
-              <a:t>跨域复用真正依赖对象能否对齐、质量能否声明、授权能否传递、动作能否回证。这是标准最可能先下手的控制层，也是三条路线最终都要交出的接口。</a:t>
+              <a:t>跨域复用真正依赖对象能否对齐、质量能否声明、授权能否传递、动作能否回证。这是标准最可能先下手的控制层，也是两类技术架构最终都要交出的接口。</a:t>
             </a:r>
           </a:p>
         </p:txBody>
@@ -11128,7 +11128,7 @@
                 <a:latin typeface="WenQuanYi Micro Hei"/>
                 <a:ea typeface="WenQuanYi Micro Hei"/>
               </a:rPr>
-              <a:t>Nokia分层商品化：产品进入现网最快，统一控制与开放性仍待证明</a:t>
+              <a:t>Nokia将联邦数据能力组织成自智软件链：优势在产品化入口，而非独立架构</a:t>
             </a:r>
           </a:p>
         </p:txBody>
@@ -11193,7 +11193,7 @@
                 <a:latin typeface="WenQuanYi Micro Hei"/>
                 <a:ea typeface="WenQuanYi Micro Hei"/>
               </a:rPr>
-              <a:t>这是一条“先产品化能力、再验证统一控制”的路线。Data Suite是数据管理层，AN Fabric是智能消费层；动作仍回OSS/RIC/SON，数据默认留域。两套Fabric不是同一层。真正的竞争问题是它们能否共享契约并贯通到动作证据。</a:t>
+              <a:t>Nokia与Ericsson共享“域内事实—联邦访问—治理语义—应用消费—域控制器动作”的相近骨架。Data Suite是数据供给与契约层，AN Fabric是智能消费层；Data Mesh主要支撑Sense，不是自智网络内核。真正的内核是状态—意图—策略—动作—结果—回滚闭环。</a:t>
             </a:r>
           </a:p>
         </p:txBody>
@@ -11699,7 +11699,7 @@
                 <a:latin typeface="WenQuanYi Micro Hei"/>
                 <a:ea typeface="WenQuanYi Micro Hei"/>
               </a:rPr>
-              <a:t>3  Data Suite</a:t>
+              <a:t>3  数据契约层 / Data Suite</a:t>
             </a:r>
           </a:p>
         </p:txBody>
@@ -11740,7 +11740,7 @@
                 <a:latin typeface="WenQuanYi Micro Hei"/>
                 <a:ea typeface="WenQuanYi Micro Hei"/>
               </a:rPr>
-              <a:t>目录、语义、QoD、血缘和数据产品，与治理最直接重合</a:t>
+              <a:t>稳定ID、语义、QoD、Owner、版本和血缘，统一数据供给</a:t>
             </a:r>
           </a:p>
         </p:txBody>
@@ -11867,7 +11867,7 @@
                 <a:latin typeface="WenQuanYi Micro Hei"/>
                 <a:ea typeface="WenQuanYi Micro Hei"/>
               </a:rPr>
-              <a:t>4  AN Fabric / AN Apps</a:t>
+              <a:t>4  自智消费层 / AN Fabric</a:t>
             </a:r>
           </a:p>
         </p:txBody>
@@ -11908,7 +11908,7 @@
                 <a:latin typeface="WenQuanYi Micro Hei"/>
                 <a:ea typeface="WenQuanYi Micro Hei"/>
               </a:rPr>
-              <a:t>Sense–Think–Act 智能消费与编排，不是数据管理Fabric</a:t>
+              <a:t>Sense–Think及应用编排；不统一实时状态、策略冲突和动作权限</a:t>
             </a:r>
           </a:p>
         </p:txBody>
@@ -12035,7 +12035,7 @@
                 <a:latin typeface="WenQuanYi Micro Hei"/>
                 <a:ea typeface="WenQuanYi Micro Hei"/>
               </a:rPr>
-              <a:t>5  域控制器 + API / Marketplace</a:t>
+              <a:t>5  动作闭环 + 商业外延</a:t>
             </a:r>
           </a:p>
         </p:txBody>
@@ -12076,7 +12076,7 @@
                 <a:latin typeface="WenQuanYi Micro Hei"/>
                 <a:ea typeface="WenQuanYi Micro Hei"/>
               </a:rPr>
-              <a:t>高风险动作回OSS/RIC/SON，再向计量和渠道外延</a:t>
+              <a:t>域控制器执行、结果验证和回滚，再连接API、计量与Marketplace</a:t>
             </a:r>
           </a:p>
         </p:txBody>
@@ -12268,7 +12268,7 @@
                 <a:latin typeface="WenQuanYi Micro Hei"/>
                 <a:ea typeface="WenQuanYi Micro Hei"/>
               </a:rPr>
-              <a:t>官方AN Fabric图只证明Sense–Think–Act智能层和Marketplace外延。</a:t>
+              <a:t>官方AN Fabric图只证明智能消费层和Marketplace外延，不能证明Data Mesh成为自智统一层。</a:t>
             </a:r>
           </a:p>
           <a:p>
@@ -12288,7 +12288,7 @@
                 <a:latin typeface="WenQuanYi Micro Hei"/>
                 <a:ea typeface="WenQuanYi Micro Hei"/>
               </a:rPr>
-              <a:t>Data Suite、域数据底座和公共湖仓不在这张图里，必须靠左侧自绘链路补齐，否则会把两套Fabric读成同一层。</a:t>
+              <a:t>Data Suite、域数据底座和公共湖仓不在图中；数据契约层与控制闭环必须分开读取。</a:t>
             </a:r>
           </a:p>
           <a:p>
@@ -12308,7 +12308,7 @@
                 <a:latin typeface="WenQuanYi Micro Hei"/>
                 <a:ea typeface="WenQuanYi Micro Hei"/>
               </a:rPr>
-              <a:t>高风险动作仍经AN Apps回到域控制器；公共层偏Non-RT，不能替代RAN快环。</a:t>
+              <a:t>高风险动作仍经AN Apps回到域控制器；公共层偏Non-RT，不能替代RAN快环、动作授权和回滚。</a:t>
             </a:r>
           </a:p>
         </p:txBody>
@@ -12437,7 +12437,7 @@
                 <a:latin typeface="WenQuanYi Micro Hei"/>
                 <a:ea typeface="WenQuanYi Micro Hei"/>
               </a:rPr>
-              <a:t>必须分层</a:t>
+              <a:t>统一的是数据契约</a:t>
             </a:r>
           </a:p>
         </p:txBody>
@@ -12478,7 +12478,7 @@
                 <a:latin typeface="WenQuanYi Micro Hei"/>
                 <a:ea typeface="WenQuanYi Micro Hei"/>
               </a:rPr>
-              <a:t>Data Suite管目录、语义、质量、血缘和产品；AN Fabric管智能消费与编排。</a:t>
+              <a:t>Data Suite可统一稳定ID、Schema、QoD、Owner、版本和血缘，使域数据被自智应用重复消费。</a:t>
             </a:r>
           </a:p>
           <a:p>
@@ -12498,7 +12498,7 @@
                 <a:latin typeface="WenQuanYi Micro Hei"/>
                 <a:ea typeface="WenQuanYi Micro Hei"/>
               </a:rPr>
-              <a:t>数据默认留域，公共层只做适配、抽象和联邦访问。支持多厂商只有经过第三方互操作和双向迁移，才构成中立性证据。</a:t>
+              <a:t>它不统一实时状态、策略冲突或动作权限；多厂商中立性仍需第三方互操作和双向迁移证明。</a:t>
             </a:r>
           </a:p>
         </p:txBody>
@@ -12627,7 +12627,7 @@
                 <a:latin typeface="WenQuanYi Micro Hei"/>
                 <a:ea typeface="WenQuanYi Micro Hei"/>
               </a:rPr>
-              <a:t>数据与控制如何流动</a:t>
+              <a:t>数据供给与控制闭环分层</a:t>
             </a:r>
           </a:p>
         </p:txBody>
@@ -12668,7 +12668,7 @@
                 <a:latin typeface="WenQuanYi Micro Hei"/>
                 <a:ea typeface="WenQuanYi Micro Hei"/>
               </a:rPr>
-              <a:t>域湖仓完成本地加工，经公共层进入Data Suite，再进入Sense，建立观察与chain-of-custody。</a:t>
+              <a:t>域湖仓完成本地加工，经公共层和Data Suite形成可消费的数据契约，再进入Sense。</a:t>
             </a:r>
           </a:p>
           <a:p>
@@ -12688,7 +12688,7 @@
                 <a:latin typeface="WenQuanYi Micro Hei"/>
                 <a:ea typeface="WenQuanYi Micro Hei"/>
               </a:rPr>
-              <a:t>Think使用电信模型和Glass-Box推理；Act通过AN Apps调用既有OSS/RIC/SON，再向计量和Marketplace延伸。</a:t>
+              <a:t>Think使用电信模型；Act经AN Apps调用OSS/RIC/SON。结果、回滚和责任证据必须返回控制闭环，而不是停在数据产品层。</a:t>
             </a:r>
           </a:p>
         </p:txBody>
@@ -12817,7 +12817,7 @@
                 <a:latin typeface="WenQuanYi Micro Hei"/>
                 <a:ea typeface="WenQuanYi Micro Hei"/>
               </a:rPr>
-              <a:t>竞争含义</a:t>
+              <a:t>产品化差异，而非架构异质</a:t>
             </a:r>
           </a:p>
         </p:txBody>
@@ -12858,7 +12858,7 @@
                 <a:latin typeface="WenQuanYi Micro Hei"/>
                 <a:ea typeface="WenQuanYi Micro Hei"/>
               </a:rPr>
-              <a:t>优势是SKU可组合、进入现网快，不必等待6G新网元标准。</a:t>
+              <a:t>与Ericsson相近的联邦底座被组织成Data Suite、AN Fabric和AN Apps等分层SKU，进入现网更快。</a:t>
             </a:r>
           </a:p>
           <a:p>
@@ -12878,7 +12878,7 @@
                 <a:latin typeface="WenQuanYi Micro Hei"/>
                 <a:ea typeface="WenQuanYi Micro Hei"/>
               </a:rPr>
-              <a:t>代价是各层可能只在品牌层组合，并形成语义、应用与云后端的软锁定。客户若只买域App，分层复利就落空。</a:t>
+              <a:t>若契约不共享、控制证据不贯通，各层就只是品牌组合；Data Mesh最多优化Sense侧供给，不能成为自智内核。</a:t>
             </a:r>
           </a:p>
         </p:txBody>
@@ -13169,7 +13169,7 @@
                 <a:latin typeface="WenQuanYi Micro Hei"/>
                 <a:ea typeface="WenQuanYi Micro Hei"/>
               </a:rPr>
-              <a:t>Data Suite与AN Fabric是否共享同一契约，第三方后端/Agent能否双向替换，动作与回滚证据能否贯通域控制器。</a:t>
+              <a:t>同一数据产品契约能否跨Data Suite、AN Fabric和第三方Agent复用；后端能否双向替换；输入、动作、结果与回滚证据能否贯通域控制器。</a:t>
             </a:r>
           </a:p>
         </p:txBody>
@@ -13480,7 +13480,7 @@
                 <a:latin typeface="WenQuanYi Micro Hei"/>
                 <a:ea typeface="WenQuanYi Micro Hei"/>
               </a:rPr>
-              <a:t>三条路线不构成成熟度序列；最终胜负由四类接口控制权决定</a:t>
+              <a:t>两类技术架构、三种产品位置；最终胜负由四类接口控制权决定</a:t>
             </a:r>
           </a:p>
         </p:txBody>
@@ -13545,7 +13545,7 @@
                 <a:latin typeface="WenQuanYi Micro Hei"/>
                 <a:ea typeface="WenQuanYi Micro Hei"/>
               </a:rPr>
-              <a:t>Ericsson争联邦治理，Huawei争近源运行时，Nokia争语义产品与应用入口。谁能定义这些能力的外部接口，同时允许执行层和后端替换，谁才更接近长期平台位置；谁只提供封闭组件或单点应用，谁就仍停留在项目层。</a:t>
+              <a:t>Ericsson与Nokia在相近联邦分层底座内竞争不同入口：前者争治理，后者把数据契约连接到自智应用；Huawei争网络原生近源运行时。谁能定义外部接口，同时允许执行层和后端替换，谁才更接近长期平台位置。</a:t>
             </a:r>
           </a:p>
         </p:txBody>
@@ -13613,7 +13613,7 @@
                           <a:latin typeface="WenQuanYi Micro Hei"/>
                           <a:ea typeface="WenQuanYi Micro Hei"/>
                         </a:rPr>
-                        <a:t>Ericsson  ·  存量联邦</a:t>
+                        <a:t>Ericsson  ·  联邦治理入口</a:t>
                       </a:r>
                     </a:p>
                   </a:txBody>
@@ -13637,7 +13637,7 @@
                           <a:latin typeface="WenQuanYi Micro Hei"/>
                           <a:ea typeface="WenQuanYi Micro Hei"/>
                         </a:rPr>
-                        <a:t>Huawei  ·  网络原生拓扑</a:t>
+                        <a:t>Huawei  ·  网络原生执行</a:t>
                       </a:r>
                     </a:p>
                   </a:txBody>
@@ -13661,7 +13661,7 @@
                           <a:latin typeface="WenQuanYi Micro Hei"/>
                           <a:ea typeface="WenQuanYi Micro Hei"/>
                         </a:rPr>
-                        <a:t>Nokia  ·  分层商品化</a:t>
+                        <a:t>Nokia  ·  联邦应用入口</a:t>
                       </a:r>
                     </a:p>
                   </a:txBody>
@@ -13759,7 +13759,7 @@
                           <a:latin typeface="WenQuanYi Micro Hei"/>
                           <a:ea typeface="WenQuanYi Micro Hei"/>
                         </a:rPr>
-                        <a:t>数据管理、自治应用和商业外延如何形成可售组合</a:t>
+                        <a:t>在相近联邦底座上把数据契约、自智应用和商业外延形成可售组合</a:t>
                       </a:r>
                     </a:p>
                   </a:txBody>
@@ -15066,7 +15066,7 @@
                 <a:latin typeface="WenQuanYi Micro Hei"/>
                 <a:ea typeface="WenQuanYi Micro Hei"/>
               </a:rPr>
-              <a:t>Ericsson争夺联邦目录与渐进治理控制权。Huawei争夺数据拓扑与近源运行时控制权。Nokia争夺语义产品与自治应用入口控制权。三者可替代也可互补，但都不是一条通向统一Fabric的成熟度阶梯。</a:t>
+              <a:t>Ericsson与Nokia共享相近联邦分层骨架：前者争联邦目录与渐进治理，后者把数据契约产品化并连接自治应用；Huawei争数据拓扑与近源运行时。三者是两类技术架构和三种产品位置，不是成熟度阶梯。</a:t>
             </a:r>
           </a:p>
         </p:txBody>
@@ -15107,7 +15107,7 @@
                 <a:latin typeface="WenQuanYi Micro Hei"/>
                 <a:ea typeface="WenQuanYi Micro Hei"/>
               </a:rPr>
-              <a:t>真正的平台地位不是把所有数据收到一个平台，而是让跨域消费者遵循自己的语义、QoD和证据契约，同时证明运行时、后端和渠道仍可互操作、可替换。标准更可能冻结这些外部行为，而不是替市场选出唯一Data Fabric。</a:t>
+              <a:t>真正的平台地位不是把所有数据收到一个平台，也不是把Data Mesh写成自智内核，而是让消费者遵循稳定语义、QoD和证据契约，同时让状态—意图—策略—动作—结果—回滚闭环可验证，并证明运行时、后端和渠道仍可替换。</a:t>
             </a:r>
           </a:p>
         </p:txBody>

</xml_diff>

<commit_message>
Regenerate Nokia slide with corrected ANF boundary
Co-authored-by: newmanxiang <newmanxiang@users.noreply.github.com>
</commit_message>
<xml_diff>
--- a/reports/6g-data-fabric-section-23-deck.pptx
+++ b/reports/6g-data-fabric-section-23-deck.pptx
@@ -11128,7 +11128,7 @@
                 <a:latin typeface="WenQuanYi Micro Hei"/>
                 <a:ea typeface="WenQuanYi Micro Hei"/>
               </a:rPr>
-              <a:t>Nokia将联邦数据能力组织成自智软件链：优势在产品化入口，而非独立架构</a:t>
+              <a:t>Nokia以AN Fabric编织自智应用：共享数据与AI是内置能力，域控制器执行动作</a:t>
             </a:r>
           </a:p>
         </p:txBody>
@@ -11193,7 +11193,7 @@
                 <a:latin typeface="WenQuanYi Micro Hei"/>
                 <a:ea typeface="WenQuanYi Micro Hei"/>
               </a:rPr>
-              <a:t>Nokia与Ericsson共享“域内事实—联邦访问—治理语义—应用消费—域控制器动作”的相近骨架。Data Suite是数据供给与契约层，AN Fabric是智能消费层；Data Mesh主要支撑Sense，不是自智网络内核。真正的内核是状态—意图—策略—动作—结果—回滚闭环。</a:t>
+              <a:t>AN Fabric是自智网络的公共智能服务平台，内部包含共享数据管理、AIOps、安全与自治域服务；Data Suite和其他AN Apps通过API使用这些能力。ANF承载上层意图和应用编排，但具体实时资源动作仍由OSS、SMO、RIC、SON及域控制器执行。</a:t>
             </a:r>
           </a:p>
         </p:txBody>
@@ -11279,7 +11279,7 @@
                 <a:latin typeface="WenQuanYi Micro Hei"/>
                 <a:ea typeface="WenQuanYi Micro Hei"/>
               </a:rPr>
-              <a:t>主视觉  ·  自绘五段链</a:t>
+              <a:t>主视觉  ·  官方定位还原</a:t>
             </a:r>
           </a:p>
         </p:txBody>
@@ -11363,7 +11363,7 @@
                 <a:latin typeface="WenQuanYi Micro Hei"/>
                 <a:ea typeface="WenQuanYi Micro Hei"/>
               </a:rPr>
-              <a:t>1  域数据底座</a:t>
+              <a:t>1  网络与OSS数据</a:t>
             </a:r>
           </a:p>
         </p:txBody>
@@ -11404,7 +11404,7 @@
                 <a:latin typeface="WenQuanYi Micro Hei"/>
                 <a:ea typeface="WenQuanYi Micro Hei"/>
               </a:rPr>
-              <a:t>Domain lakehouse  ·  各域本地采集、加工与存储</a:t>
+              <a:t>RAN、Core、Transport、Fixed及OSS持续产生状态与事件</a:t>
             </a:r>
           </a:p>
         </p:txBody>
@@ -11531,7 +11531,7 @@
                 <a:latin typeface="WenQuanYi Micro Hei"/>
                 <a:ea typeface="WenQuanYi Micro Hei"/>
               </a:rPr>
-              <a:t>2  Common Fabric / Lakehouse</a:t>
+              <a:t>2  AN Fabric公共服务</a:t>
             </a:r>
           </a:p>
         </p:txBody>
@@ -11572,7 +11572,7 @@
                 <a:latin typeface="WenQuanYi Micro Hei"/>
                 <a:ea typeface="WenQuanYi Micro Hei"/>
               </a:rPr>
-              <a:t>适配、抽象和联邦访问，提供逻辑视图而非强制集中</a:t>
+              <a:t>Data Management、AIOps、Security与Autonomous Domain Services</a:t>
             </a:r>
           </a:p>
         </p:txBody>
@@ -11699,7 +11699,7 @@
                 <a:latin typeface="WenQuanYi Micro Hei"/>
                 <a:ea typeface="WenQuanYi Micro Hei"/>
               </a:rPr>
-              <a:t>3  数据契约层 / Data Suite</a:t>
+              <a:t>3  AN Apps / Data Suite</a:t>
             </a:r>
           </a:p>
         </p:txBody>
@@ -11740,7 +11740,7 @@
                 <a:latin typeface="WenQuanYi Micro Hei"/>
                 <a:ea typeface="WenQuanYi Micro Hei"/>
               </a:rPr>
-              <a:t>稳定ID、语义、QoD、Owner、版本和血缘，统一数据供给</a:t>
+              <a:t>数据产品、业务/运营意图、分析和自动化工作流</a:t>
             </a:r>
           </a:p>
         </p:txBody>
@@ -11867,7 +11867,7 @@
                 <a:latin typeface="WenQuanYi Micro Hei"/>
                 <a:ea typeface="WenQuanYi Micro Hei"/>
               </a:rPr>
-              <a:t>4  自智消费层 / AN Fabric</a:t>
+              <a:t>4  域控制与编排</a:t>
             </a:r>
           </a:p>
         </p:txBody>
@@ -11908,7 +11908,7 @@
                 <a:latin typeface="WenQuanYi Micro Hei"/>
                 <a:ea typeface="WenQuanYi Micro Hei"/>
               </a:rPr>
-              <a:t>Sense–Think及应用编排；不统一实时状态、策略冲突和动作权限</a:t>
+              <a:t>OSS、SMO、RIC、SON及域控制器保留状态与动作权限</a:t>
             </a:r>
           </a:p>
         </p:txBody>
@@ -12035,7 +12035,7 @@
                 <a:latin typeface="WenQuanYi Micro Hei"/>
                 <a:ea typeface="WenQuanYi Micro Hei"/>
               </a:rPr>
-              <a:t>5  动作闭环 + 商业外延</a:t>
+              <a:t>5  网元动作与回证</a:t>
             </a:r>
           </a:p>
         </p:txBody>
@@ -12076,7 +12076,7 @@
                 <a:latin typeface="WenQuanYi Micro Hei"/>
                 <a:ea typeface="WenQuanYi Micro Hei"/>
               </a:rPr>
-              <a:t>域控制器执行、结果验证和回滚，再连接API、计量与Marketplace</a:t>
+              <a:t>执行、自愈、结果、回滚；证据返回应用和公共服务</a:t>
             </a:r>
           </a:p>
         </p:txBody>
@@ -12227,7 +12227,7 @@
                 <a:latin typeface="WenQuanYi Micro Hei"/>
                 <a:ea typeface="WenQuanYi Micro Hei"/>
               </a:rPr>
-              <a:t>官方图  仅证智能消费层</a:t>
+              <a:t>官方图  ANF为应用公共底座</a:t>
             </a:r>
           </a:p>
         </p:txBody>
@@ -12268,7 +12268,7 @@
                 <a:latin typeface="WenQuanYi Micro Hei"/>
                 <a:ea typeface="WenQuanYi Micro Hei"/>
               </a:rPr>
-              <a:t>官方AN Fabric图只证明智能消费层和Marketplace外延，不能证明Data Mesh成为自智统一层。</a:t>
+              <a:t>官方白皮书：ANF包含Data Management、AIOps和Autonomous Domain Services，AN Apps经内部API使用这些服务。</a:t>
             </a:r>
           </a:p>
           <a:p>
@@ -12288,7 +12288,7 @@
                 <a:latin typeface="WenQuanYi Micro Hei"/>
                 <a:ea typeface="WenQuanYi Micro Hei"/>
               </a:rPr>
-              <a:t>Data Suite、域数据底座和公共湖仓不在图中；数据契约层与控制闭环必须分开读取。</a:t>
+              <a:t>Data Suite官网：属于AN应用栈并由AN Fabric驱动；因此不能画成ANF上游的独立数据平台。</a:t>
             </a:r>
           </a:p>
           <a:p>
@@ -12308,7 +12308,7 @@
                 <a:latin typeface="WenQuanYi Micro Hei"/>
                 <a:ea typeface="WenQuanYi Micro Hei"/>
               </a:rPr>
-              <a:t>高风险动作仍经AN Apps回到域控制器；公共层偏Non-RT，不能替代RAN快环、动作授权和回滚。</a:t>
+              <a:t>官方图未画OSS、SMO、RIC、SON或网元路径；不能据此断言ANF直接承担全部资源控制。</a:t>
             </a:r>
           </a:p>
         </p:txBody>
@@ -12437,7 +12437,7 @@
                 <a:latin typeface="WenQuanYi Micro Hei"/>
                 <a:ea typeface="WenQuanYi Micro Hei"/>
               </a:rPr>
-              <a:t>统一的是数据契约</a:t>
+              <a:t>ANF内含数据编织能力</a:t>
             </a:r>
           </a:p>
         </p:txBody>
@@ -12478,7 +12478,7 @@
                 <a:latin typeface="WenQuanYi Micro Hei"/>
                 <a:ea typeface="WenQuanYi Micro Hei"/>
               </a:rPr>
-              <a:t>Data Suite可统一稳定ID、Schema、QoD、Owner、版本和血缘，使域数据被自智应用重复消费。</a:t>
+              <a:t>统一数据管理不是ANF外部前置层，而是其公共服务之一：网络数据被采集、治理、关联并发布为可复用数据产品。</a:t>
             </a:r>
           </a:p>
           <a:p>
@@ -12498,7 +12498,7 @@
                 <a:latin typeface="WenQuanYi Micro Hei"/>
                 <a:ea typeface="WenQuanYi Micro Hei"/>
               </a:rPr>
-              <a:t>它不统一实时状态、策略冲突或动作权限；多厂商中立性仍需第三方互操作和双向迁移证明。</a:t>
+              <a:t>Data Suite将目录、血缘、质量、语义和产品能力形成用户入口，支撑AI和自动化应用。</a:t>
             </a:r>
           </a:p>
         </p:txBody>
@@ -12627,7 +12627,7 @@
                 <a:latin typeface="WenQuanYi Micro Hei"/>
                 <a:ea typeface="WenQuanYi Micro Hei"/>
               </a:rPr>
-              <a:t>数据供给与控制闭环分层</a:t>
+              <a:t>AN Apps承载意图与用例</a:t>
             </a:r>
           </a:p>
         </p:txBody>
@@ -12668,7 +12668,7 @@
                 <a:latin typeface="WenQuanYi Micro Hei"/>
                 <a:ea typeface="WenQuanYi Micro Hei"/>
               </a:rPr>
-              <a:t>域湖仓完成本地加工，经公共层和Data Suite形成可消费的数据契约，再进入Sense。</a:t>
+              <a:t>AN Apps面向运营、网络安全和用户体验，使用ANF的数据、模型、知识和自治域服务。</a:t>
             </a:r>
           </a:p>
           <a:p>
@@ -12688,7 +12688,7 @@
                 <a:latin typeface="WenQuanYi Micro Hei"/>
                 <a:ea typeface="WenQuanYi Micro Hei"/>
               </a:rPr>
-              <a:t>Think使用电信模型；Act经AN Apps调用OSS/RIC/SON。结果、回滚和责任证据必须返回控制闭环，而不是停在数据产品层。</a:t>
+              <a:t>它们解释业务/运营意图并编排分析与自动化工作流；Fabric Experience和Marketplace承接体验及商业入口。</a:t>
             </a:r>
           </a:p>
         </p:txBody>
@@ -12817,7 +12817,7 @@
                 <a:latin typeface="WenQuanYi Micro Hei"/>
                 <a:ea typeface="WenQuanYi Micro Hei"/>
               </a:rPr>
-              <a:t>产品化差异，而非架构异质</a:t>
+              <a:t>域控制器执行资源动作</a:t>
             </a:r>
           </a:p>
         </p:txBody>
@@ -12858,7 +12858,7 @@
                 <a:latin typeface="WenQuanYi Micro Hei"/>
                 <a:ea typeface="WenQuanYi Micro Hei"/>
               </a:rPr>
-              <a:t>与Ericsson相近的联邦底座被组织成Data Suite、AN Fabric和AN Apps等分层SKU，进入现网更快。</a:t>
+              <a:t>服务层给出目标、分析和动作请求，SMO、RIC、SON、OSS及域控制器完成具体控制并保留实时状态。</a:t>
             </a:r>
           </a:p>
           <a:p>
@@ -12878,7 +12878,7 @@
                 <a:latin typeface="WenQuanYi Micro Hei"/>
                 <a:ea typeface="WenQuanYi Micro Hei"/>
               </a:rPr>
-              <a:t>若契约不共享、控制证据不贯通，各层就只是品牌组合；Data Mesh最多优化Sense侧供给，不能成为自智内核。</a:t>
+              <a:t>KDDI与stc案例证明域级恢复和SON动作，不证明完整ANF已经成为跨域统一资源控制面。</a:t>
             </a:r>
           </a:p>
         </p:txBody>
@@ -12964,7 +12964,7 @@
                 <a:latin typeface="WenQuanYi Micro Hei"/>
                 <a:ea typeface="WenQuanYi Micro Hei"/>
               </a:rPr>
-              <a:t>域应用已证</a:t>
+              <a:t>官方架构已证</a:t>
             </a:r>
           </a:p>
         </p:txBody>
@@ -13005,7 +13005,7 @@
                 <a:latin typeface="WenQuanYi Micro Hei"/>
                 <a:ea typeface="WenQuanYi Micro Hei"/>
               </a:rPr>
-              <a:t>KDDI覆盖20万4G/5G RAN；stc披露超过1万次自动动作和性能改善；Indosat证明节能应用可扩展。它们证明域级闭环，不证明统一跨域Fabric。</a:t>
+              <a:t>ANF包含Data Management、AIOps与Autonomous Domain Services；AN Apps经API使用公共能力，Data Suite由ANF驱动。</a:t>
             </a:r>
           </a:p>
         </p:txBody>
@@ -13046,7 +13046,7 @@
                 <a:latin typeface="WenQuanYi Micro Hei"/>
                 <a:ea typeface="WenQuanYi Micro Hei"/>
               </a:rPr>
-              <a:t>规模信号</a:t>
+              <a:t>域执行已证</a:t>
             </a:r>
           </a:p>
         </p:txBody>
@@ -13087,7 +13087,7 @@
                 <a:latin typeface="WenQuanYi Micro Hei"/>
                 <a:ea typeface="WenQuanYi Micro Hei"/>
               </a:rPr>
-              <a:t>匿名Tier-1：25万小区、27万报告/秒，仅支持摄取与关联潜力。因客户未具名，不能外推广泛跨域商用。</a:t>
+              <a:t>KDDI 20万RAN由Recovery System恢复；stc MantaRay SON执行&gt;1万次动作。证明域控制，不证明完整ANF统一栈。</a:t>
             </a:r>
           </a:p>
         </p:txBody>
@@ -13169,7 +13169,7 @@
                 <a:latin typeface="WenQuanYi Micro Hei"/>
                 <a:ea typeface="WenQuanYi Micro Hei"/>
               </a:rPr>
-              <a:t>同一数据产品契约能否跨Data Suite、AN Fabric和第三方Agent复用；后端能否双向替换；输入、动作、结果与回滚证据能否贯通域控制器。</a:t>
+              <a:t>具名部署中，Data Suite能否被第三方AN Apps复用，ANF意图能否经开放接口进入多厂商域控制器，并返回动作、结果与回滚证据。</a:t>
             </a:r>
           </a:p>
         </p:txBody>

</xml_diff>

<commit_message>
Regenerate decks with unambiguous data-fitness terminology
Co-authored-by: newmanxiang <newmanxiang@users.noreply.github.com>
</commit_message>
<xml_diff>
--- a/reports/6g-data-fabric-section-23-deck.pptx
+++ b/reports/6g-data-fabric-section-23-deck.pptx
@@ -3825,7 +3825,7 @@
                 <a:latin typeface="WenQuanYi Micro Hei"/>
                 <a:ea typeface="WenQuanYi Micro Hei"/>
               </a:rPr>
-              <a:t>模型与产品要跨RAN、Core、OSS/BSS复用，必须有稳定对象、上下文、QoD和版本。名称相似不等于跨域语义已经对齐。</a:t>
+              <a:t>模型与产品要跨RAN、Core、OSS/BSS复用，必须有稳定对象、上下文、任务适用性和版本。名称相似不等于跨域语义已经对齐。</a:t>
             </a:r>
           </a:p>
         </p:txBody>
@@ -5510,7 +5510,7 @@
                 <a:latin typeface="WenQuanYi Micro Hei"/>
                 <a:ea typeface="WenQuanYi Micro Hei"/>
               </a:rPr>
-              <a:t>QoD / 产品契约</a:t>
+              <a:t>任务适用性/ 产品契约</a:t>
             </a:r>
           </a:p>
         </p:txBody>
@@ -6468,7 +6468,7 @@
                 <a:latin typeface="WenQuanYi Micro Hei"/>
                 <a:ea typeface="WenQuanYi Micro Hei"/>
               </a:rPr>
-              <a:t>稳定ID  ·  最小元数据  ·  QoD  ·  授权  ·  动作证据</a:t>
+              <a:t>稳定ID  ·  最小元数据  · 任务适用性 ·  授权  ·  动作证据</a:t>
             </a:r>
           </a:p>
         </p:txBody>
@@ -6931,7 +6931,7 @@
                 <a:latin typeface="WenQuanYi Micro Hei"/>
                 <a:ea typeface="WenQuanYi Micro Hei"/>
               </a:rPr>
-              <a:t>角色、稳定标识、最小元数据、交付控制、QoD/授权/证据挂钩点，以及一致性测试。</a:t>
+              <a:t>角色、稳定标识、最小元数据、交付控制、任务适用性/授权/证据挂钩点，以及一致性测试。</a:t>
             </a:r>
           </a:p>
           <a:p>
@@ -8847,7 +8847,7 @@
                 <a:latin typeface="WenQuanYi Micro Hei"/>
                 <a:ea typeface="WenQuanYi Micro Hei"/>
               </a:rPr>
-              <a:t>代价是跨产品Schema、QoD、策略和版本可能长期碎片化；协调成本若高于替换成本，联邦优势会下降。</a:t>
+              <a:t>代价是跨产品Schema、任务适用性、策略和版本可能长期碎片化；协调成本若高于替换成本，联邦优势会下降。</a:t>
             </a:r>
           </a:p>
         </p:txBody>
@@ -9514,7 +9514,7 @@
                 <a:latin typeface="WenQuanYi Micro Hei"/>
                 <a:ea typeface="WenQuanYi Micro Hei"/>
               </a:rPr>
-              <a:t>这是一条“先重构执行、再决定治理边界”的路线：DO编排拓扑，DA近源处理，DCP异步分发。它首先是6G数据面机制，能吸收部分发现、编排和交付能力，但不会自动解决跨域语义、QoD、血缘与产品责任。不能把“补成Fabric”当成唯一终点。</a:t>
+              <a:t>这是一条“先重构执行、再决定治理边界”的路线：DO编排拓扑，DA近源处理，DCP异步分发。它首先是6G数据面机制，能吸收部分发现、编排和交付能力，但不会自动解决跨域语义、任务适用性、血缘与产品责任。不能把“补成Fabric”当成唯一终点。</a:t>
             </a:r>
           </a:p>
         </p:txBody>
@@ -14103,7 +14103,7 @@
                           <a:latin typeface="WenQuanYi Micro Hei"/>
                           <a:ea typeface="WenQuanYi Micro Hei"/>
                         </a:rPr>
-                        <a:t>跨产品语义、QoD、策略和版本协调持续存在</a:t>
+                        <a:t>跨产品语义、任务适用性、策略和版本协调持续存在</a:t>
                       </a:r>
                     </a:p>
                   </a:txBody>
@@ -14558,7 +14558,7 @@
                 <a:latin typeface="WenQuanYi Micro Hei"/>
                 <a:ea typeface="WenQuanYi Micro Hei"/>
               </a:rPr>
-              <a:t>2  QoD与产品契约</a:t>
+              <a:t>2 任务适用性与产品契约</a:t>
             </a:r>
           </a:p>
         </p:txBody>
@@ -15107,7 +15107,7 @@
                 <a:latin typeface="WenQuanYi Micro Hei"/>
                 <a:ea typeface="WenQuanYi Micro Hei"/>
               </a:rPr>
-              <a:t>真正的平台地位不是把所有数据收到一个平台，也不是把Data Mesh写成自智内核，而是让消费者遵循稳定语义、QoD和证据契约，同时让状态—意图—策略—动作—结果—回滚闭环可验证，并证明运行时、后端和渠道仍可替换。</a:t>
+              <a:t>真正的平台地位不是把所有数据收到一个平台，也不是把Data Mesh写成自智内核，而是让消费者遵循稳定语义、任务适用性和证据契约，同时让状态—意图—策略—动作—结果—回滚闭环可验证，并证明运行时、后端和渠道仍可替换。</a:t>
             </a:r>
           </a:p>
         </p:txBody>

</xml_diff>